<commit_message>
Update presentation with September FSY magazine lesson details
Enrich the deck from the printed September 2026 FSY magazine: add an
'Inside a Fast Sunday Lesson' slide showing the magazine's four-step
study pattern (truth, scripture, story, testify, then choose an
invitation), and update the September preview slide with the actual
guide pages (46-49) and each week's scriptures (D&C 13; 107; 84;
27:12-13; 110:11-16; D&C 25 for YW; JS-History 1:66-73 for AP quorums).

Co-Authored-By: Claude Fable 5 <noreply@anthropic.com>
Claude-Session: https://claude.ai/code/session_01NQir395bsK1jUiLLBPYw8i
</commit_message>
<xml_diff>
--- a/new-sunday-youth-curriculum.pptx
+++ b/new-sunday-youth-curriculum.pptx
@@ -16,9 +16,10 @@
     <p:sldId id="264" r:id="rId10"/>
     <p:sldId id="265" r:id="rId11"/>
     <p:sldId id="266" r:id="rId12"/>
+    <p:sldId id="267" r:id="rId13"/>
   </p:sldIdLst>
   <p:notesMasterIdLst>
-    <p:notesMasterId r:id="rId13"/>
+    <p:notesMasterId r:id="rId14"/>
   </p:notesMasterIdLst>
   <p:sldSz cx="12192000" cy="6858000"/>
   <p:notesSz cx="6858000" cy="12192000"/>
@@ -600,7 +601,7 @@
           <a:p>
             <a:r>
               <a:rPr lang="en-US" dirty="0"/>
-              <a:t>These three questions come straight from the Church's official fifth-Sunday outline. Give youth and parents time to actually answer — this discussion is the point of the meeting. On question two, you might read Doctrine and Covenants 88:122 aloud together first.</a:t>
+              <a:t>Play the official instructional video here. It features Young Men General President Timothy L. Farnes and Young Women General President Emily Belle Freeman, and shows what the new weekly lessons look like in practice. Have it queued in Gospel Library before the meeting. Pause where the video invites discussion and use the questions on the next slide.</a:t>
             </a:r>
             <a:endParaRPr lang="en-US" dirty="0"/>
           </a:p>
@@ -688,7 +689,7 @@
           <a:p>
             <a:r>
               <a:rPr lang="en-US" dirty="0"/>
-              <a:t>Close with the invitations: youth, read the September chapter before next Sunday. Parents, get the magazine and keep the conversation going at home. Leaders, watch the videos and prepare. End with your testimony that this change is about growing closer to Jesus Christ — every single week.</a:t>
+              <a:t>These three questions come straight from the Church's official fifth-Sunday outline. Give youth and parents time to actually answer — this discussion is the point of the meeting. On question two, you might read Doctrine and Covenants 88:122 aloud together first.</a:t>
             </a:r>
             <a:endParaRPr lang="en-US" dirty="0"/>
           </a:p>
@@ -712,6 +713,94 @@
             <a:fld id="{F7021451-1387-4CA6-816F-3879F97B5CBC}" type="slidenum">
               <a:rPr lang="en-US"/>
               <a:t>11</a:t>
+            </a:fld>
+            <a:endParaRPr lang="en-US"/>
+          </a:p>
+        </p:txBody>
+      </p:sp>
+    </p:spTree>
+    <p:extLst>
+      <p:ext uri="{BB962C8B-B14F-4D97-AF65-F5344CB8AC3E}">
+        <p14:creationId xmlns:p14="http://schemas.microsoft.com/office/powerpoint/2010/main" val="1024086991"/>
+      </p:ext>
+    </p:extLst>
+  </p:cSld>
+  <p:clrMapOvr>
+    <a:masterClrMapping/>
+  </p:clrMapOvr>
+</p:notes>
+</file>
+
+<file path=ppt/notesSlides/notesSlide12.xml><?xml version="1.0" encoding="utf-8"?>
+<p:notes xmlns:a="http://schemas.openxmlformats.org/drawingml/2006/main" xmlns:r="http://schemas.openxmlformats.org/officeDocument/2006/relationships" xmlns:p="http://schemas.openxmlformats.org/presentationml/2006/main">
+  <p:cSld>
+    <p:spTree>
+      <p:nvGrpSpPr>
+        <p:cNvPr id="1" name=""/>
+        <p:cNvGrpSpPr/>
+        <p:nvPr/>
+      </p:nvGrpSpPr>
+      <p:grpSpPr>
+        <a:xfrm>
+          <a:off x="0" y="0"/>
+          <a:ext cx="0" cy="0"/>
+          <a:chOff x="0" y="0"/>
+          <a:chExt cx="0" cy="0"/>
+        </a:xfrm>
+      </p:grpSpPr>
+      <p:sp>
+        <p:nvSpPr>
+          <p:cNvPr id="2" name="Slide Image Placeholder 1"/>
+          <p:cNvSpPr>
+            <a:spLocks noGrp="1" noRot="1" noChangeAspect="1"/>
+          </p:cNvSpPr>
+          <p:nvPr>
+            <p:ph type="sldImg"/>
+          </p:nvPr>
+        </p:nvSpPr>
+        <p:spPr/>
+      </p:sp>
+      <p:sp>
+        <p:nvSpPr>
+          <p:cNvPr id="3" name="Notes Placeholder 2"/>
+          <p:cNvSpPr>
+            <a:spLocks noGrp="1"/>
+          </p:cNvSpPr>
+          <p:nvPr>
+            <p:ph type="body" idx="1"/>
+          </p:nvPr>
+        </p:nvSpPr>
+        <p:spPr/>
+        <p:txBody>
+          <a:bodyPr/>
+          <a:lstStyle/>
+          <a:p>
+            <a:r>
+              <a:rPr lang="en-US" dirty="0"/>
+              <a:t>Close with the invitations: youth, read the September chapter before next Sunday. Parents, get the magazine and keep the conversation going at home. Leaders, watch the videos and prepare. End with your testimony that this change is about growing closer to Jesus Christ — every single week.</a:t>
+            </a:r>
+            <a:endParaRPr lang="en-US" dirty="0"/>
+          </a:p>
+        </p:txBody>
+      </p:sp>
+      <p:sp>
+        <p:nvSpPr>
+          <p:cNvPr id="4" name="Slide Number Placeholder 3"/>
+          <p:cNvSpPr>
+            <a:spLocks noGrp="1"/>
+          </p:cNvSpPr>
+          <p:nvPr>
+            <p:ph type="sldNum" sz="quarter" idx="10"/>
+          </p:nvPr>
+        </p:nvSpPr>
+        <p:spPr/>
+        <p:txBody>
+          <a:bodyPr/>
+          <a:lstStyle/>
+          <a:p>
+            <a:fld id="{F7021451-1387-4CA6-816F-3879F97B5CBC}" type="slidenum">
+              <a:rPr lang="en-US"/>
+              <a:t>12</a:t>
             </a:fld>
             <a:endParaRPr lang="en-US"/>
           </a:p>
@@ -1216,7 +1305,7 @@
           <a:p>
             <a:r>
               <a:rPr lang="en-US" dirty="0"/>
-              <a:t>September's theme is 'You Are Blessed by Priesthood Keys and Authority,' anchored in Matthew 16. The intro lesson asks: have you ever thought about what your life would be like if God's priesthood authority had never been restored? Encourage the youth to read the chapter before September 6. Point out the two activity ideas — great for a midweek activity that ties into Sunday.</a:t>
+              <a:t>This pattern comes straight from the September FSY magazine's fast Sunday lesson. September's chapter is 'You Are Blessed by Priesthood Keys and Authority,' pages 46 through 49 of the guide. Notice how simple and repeatable it is: truth, scripture, story, testimony — then youth choose an invitation to actually live during the month. Youth themselves can lead any of these steps.</a:t>
             </a:r>
             <a:endParaRPr lang="en-US" dirty="0"/>
           </a:p>
@@ -1304,7 +1393,7 @@
           <a:p>
             <a:r>
               <a:rPr lang="en-US" dirty="0"/>
-              <a:t>Everything is free and already available. The guide and every Sunday lesson are in Gospel Library. Every household can get one free print subscription to the FSY magazine at magazines.ChurchofJesusChrist.org. And sunday.ChurchofJesusChrist.org has the instructional videos and implementation guide. Parents: having the same materials at home is the superpower here.</a:t>
+              <a:t>September's theme is 'You Are Blessed by Priesthood Keys and Authority' — pages 46 to 49 of the FSY guide, anchored in Matthew 16. The magazine's closing question for the month: how would your life be different if the priesthood hadn't been restored? On the third Sunday youth fill out a table mapping D&amp;C 13, 27, and 110 to the heavenly messengers and the keys they restored. On the last Sunday, Young Women study Emma Smith as an 'elect lady' in D&amp;C 25, and Aaronic Priesthood quorums study Joseph Smith's account of John the Baptist in Joseph Smith—History. Encourage youth to read the chapter before September 6, and point out the two activity ideas for midweek.</a:t>
             </a:r>
             <a:endParaRPr lang="en-US" dirty="0"/>
           </a:p>
@@ -1392,7 +1481,7 @@
           <a:p>
             <a:r>
               <a:rPr lang="en-US" dirty="0"/>
-              <a:t>Play the official instructional video here. It features Young Men General President Timothy L. Farnes and Young Women General President Emily Belle Freeman, and shows what the new weekly lessons look like in practice. Have it queued in Gospel Library before the meeting. Pause where the video invites discussion and use the questions on the next slide.</a:t>
+              <a:t>Everything is free and already available. The guide and every Sunday lesson are in Gospel Library. Every household can get one free print subscription to the FSY magazine at magazines.ChurchofJesusChrist.org. And sunday.ChurchofJesusChrist.org has the instructional videos and implementation guide. Parents: having the same materials at home is the superpower here.</a:t>
             </a:r>
             <a:endParaRPr lang="en-US" dirty="0"/>
           </a:p>
@@ -2154,6 +2243,349 @@
     <p:bg>
       <p:bgPr>
         <a:solidFill>
+          <a:srgbClr val="1B2A52"/>
+        </a:solidFill>
+      </p:bgPr>
+    </p:bg>
+    <p:spTree>
+      <p:nvGrpSpPr>
+        <p:cNvPr id="1" name=""/>
+        <p:cNvGrpSpPr/>
+        <p:nvPr/>
+      </p:nvGrpSpPr>
+      <p:grpSpPr>
+        <a:xfrm>
+          <a:off x="0" y="0"/>
+          <a:ext cx="0" cy="0"/>
+          <a:chOff x="0" y="0"/>
+          <a:chExt cx="0" cy="0"/>
+        </a:xfrm>
+      </p:grpSpPr>
+      <p:sp>
+        <p:nvSpPr>
+          <p:cNvPr id="2" name="Shape 0"/>
+          <p:cNvSpPr/>
+          <p:nvPr/>
+        </p:nvSpPr>
+        <p:spPr>
+          <a:xfrm>
+            <a:off x="9052560" y="-1920240"/>
+            <a:ext cx="4937760" cy="4937760"/>
+          </a:xfrm>
+          <a:prstGeom prst="ellipse">
+            <a:avLst/>
+          </a:prstGeom>
+          <a:ln w="19050">
+            <a:solidFill>
+              <a:srgbClr val="31437A"/>
+            </a:solidFill>
+            <a:prstDash val="solid"/>
+          </a:ln>
+        </p:spPr>
+      </p:sp>
+      <p:sp>
+        <p:nvSpPr>
+          <p:cNvPr id="3" name="Shape 1"/>
+          <p:cNvSpPr/>
+          <p:nvPr/>
+        </p:nvSpPr>
+        <p:spPr>
+          <a:xfrm>
+            <a:off x="-1463040" y="4572000"/>
+            <a:ext cx="4023360" cy="4023360"/>
+          </a:xfrm>
+          <a:prstGeom prst="ellipse">
+            <a:avLst/>
+          </a:prstGeom>
+          <a:ln w="19050">
+            <a:solidFill>
+              <a:srgbClr val="31437A"/>
+            </a:solidFill>
+            <a:prstDash val="solid"/>
+          </a:ln>
+        </p:spPr>
+      </p:sp>
+      <p:sp>
+        <p:nvSpPr>
+          <p:cNvPr id="4" name="Text 2"/>
+          <p:cNvSpPr txBox="1"/>
+          <p:nvPr/>
+        </p:nvSpPr>
+        <p:spPr>
+          <a:xfrm>
+            <a:off x="548640" y="438912"/>
+            <a:ext cx="11064240" cy="292608"/>
+          </a:xfrm>
+          <a:prstGeom prst="rect">
+            <a:avLst/>
+          </a:prstGeom>
+          <a:noFill/>
+          <a:ln/>
+        </p:spPr>
+        <p:txBody>
+          <a:bodyPr wrap="square" lIns="0" tIns="0" rIns="0" bIns="0" rtlCol="0" anchor="ctr"/>
+          <a:lstStyle/>
+          <a:p>
+            <a:pPr algn="l" indent="0" marL="0">
+              <a:buNone/>
+            </a:pPr>
+            <a:r>
+              <a:rPr lang="en-US" sz="1200" b="1" spc="300" kern="0" dirty="0">
+                <a:solidFill>
+                  <a:srgbClr val="C9A227"/>
+                </a:solidFill>
+                <a:latin typeface="Calibri" pitchFamily="34" charset="0"/>
+                <a:ea typeface="Calibri" pitchFamily="34" charset="-122"/>
+                <a:cs typeface="Calibri" pitchFamily="34" charset="-120"/>
+              </a:rPr>
+              <a:t>WATCH TOGETHER</a:t>
+            </a:r>
+            <a:endParaRPr lang="en-US" sz="1200" dirty="0"/>
+          </a:p>
+        </p:txBody>
+      </p:sp>
+      <p:sp>
+        <p:nvSpPr>
+          <p:cNvPr id="5" name="Text 3"/>
+          <p:cNvSpPr txBox="1"/>
+          <p:nvPr/>
+        </p:nvSpPr>
+        <p:spPr>
+          <a:xfrm>
+            <a:off x="548640" y="749808"/>
+            <a:ext cx="11064240" cy="731520"/>
+          </a:xfrm>
+          <a:prstGeom prst="rect">
+            <a:avLst/>
+          </a:prstGeom>
+          <a:noFill/>
+          <a:ln/>
+        </p:spPr>
+        <p:txBody>
+          <a:bodyPr wrap="square" lIns="0" tIns="0" rIns="0" bIns="0" rtlCol="0" anchor="ctr"/>
+          <a:lstStyle/>
+          <a:p>
+            <a:pPr algn="l" indent="0" marL="0">
+              <a:buNone/>
+            </a:pPr>
+            <a:r>
+              <a:rPr lang="en-US" sz="3400" b="1" dirty="0">
+                <a:solidFill>
+                  <a:srgbClr val="FFFFFF"/>
+                </a:solidFill>
+                <a:latin typeface="Cambria" pitchFamily="34" charset="0"/>
+                <a:ea typeface="Cambria" pitchFamily="34" charset="-122"/>
+                <a:cs typeface="Cambria" pitchFamily="34" charset="-120"/>
+              </a:rPr>
+              <a:t>The Instructional Video</a:t>
+            </a:r>
+            <a:endParaRPr lang="en-US" sz="3400" dirty="0"/>
+          </a:p>
+        </p:txBody>
+      </p:sp>
+      <p:sp>
+        <p:nvSpPr>
+          <p:cNvPr id="6" name="Shape 4"/>
+          <p:cNvSpPr/>
+          <p:nvPr/>
+        </p:nvSpPr>
+        <p:spPr>
+          <a:xfrm>
+            <a:off x="1325880" y="2651760"/>
+            <a:ext cx="1737360" cy="1737360"/>
+          </a:xfrm>
+          <a:prstGeom prst="ellipse">
+            <a:avLst/>
+          </a:prstGeom>
+          <a:solidFill>
+            <a:srgbClr val="C9A227"/>
+          </a:solidFill>
+          <a:ln/>
+        </p:spPr>
+      </p:sp>
+      <p:pic>
+        <p:nvPicPr>
+          <p:cNvPr id="7" name="Image 0" descr="preencoded.png">    </p:cNvPr>
+          <p:cNvPicPr>
+            <a:picLocks noChangeAspect="1"/>
+          </p:cNvPicPr>
+          <p:nvPr/>
+        </p:nvPicPr>
+        <p:blipFill>
+          <a:blip r:embed="rId1"/>
+          <a:stretch>
+            <a:fillRect/>
+          </a:stretch>
+        </p:blipFill>
+        <p:spPr>
+          <a:xfrm>
+            <a:off x="1938528" y="3200400"/>
+            <a:ext cx="621792" cy="621792"/>
+          </a:xfrm>
+          <a:prstGeom prst="rect">
+            <a:avLst/>
+          </a:prstGeom>
+        </p:spPr>
+      </p:pic>
+      <p:sp>
+        <p:nvSpPr>
+          <p:cNvPr id="8" name="Text 5"/>
+          <p:cNvSpPr txBox="1"/>
+          <p:nvPr/>
+        </p:nvSpPr>
+        <p:spPr>
+          <a:xfrm>
+            <a:off x="3657600" y="2514600"/>
+            <a:ext cx="7680960" cy="868680"/>
+          </a:xfrm>
+          <a:prstGeom prst="rect">
+            <a:avLst/>
+          </a:prstGeom>
+          <a:noFill/>
+          <a:ln/>
+        </p:spPr>
+        <p:txBody>
+          <a:bodyPr wrap="square" lIns="0" tIns="0" rIns="0" bIns="0" rtlCol="0" anchor="ctr"/>
+          <a:lstStyle/>
+          <a:p>
+            <a:pPr indent="0" marL="0">
+              <a:buNone/>
+            </a:pPr>
+            <a:r>
+              <a:rPr lang="en-US" sz="1650" dirty="0">
+                <a:solidFill>
+                  <a:srgbClr val="FFFFFF"/>
+                </a:solidFill>
+                <a:latin typeface="Calibri" pitchFamily="34" charset="0"/>
+                <a:ea typeface="Calibri" pitchFamily="34" charset="-122"/>
+                <a:cs typeface="Calibri" pitchFamily="34" charset="-120"/>
+              </a:rPr>
+              <a:t>A message from President Timothy L. Farnes and President Emily Belle Freeman introducing the new Sunday youth curriculum.</a:t>
+            </a:r>
+            <a:endParaRPr lang="en-US" sz="1650" dirty="0"/>
+          </a:p>
+        </p:txBody>
+      </p:sp>
+      <p:sp>
+        <p:nvSpPr>
+          <p:cNvPr id="9" name="Text 6"/>
+          <p:cNvSpPr txBox="1"/>
+          <p:nvPr/>
+        </p:nvSpPr>
+        <p:spPr>
+          <a:xfrm>
+            <a:off x="3657600" y="3474720"/>
+            <a:ext cx="7680960" cy="777240"/>
+          </a:xfrm>
+          <a:prstGeom prst="rect">
+            <a:avLst/>
+          </a:prstGeom>
+          <a:noFill/>
+          <a:ln/>
+        </p:spPr>
+        <p:txBody>
+          <a:bodyPr wrap="square" lIns="0" tIns="0" rIns="0" bIns="0" rtlCol="0" anchor="ctr"/>
+          <a:lstStyle/>
+          <a:p>
+            <a:pPr indent="0" marL="0">
+              <a:buNone/>
+            </a:pPr>
+            <a:r>
+              <a:rPr lang="en-US" sz="1350" b="1" dirty="0">
+                <a:solidFill>
+                  <a:srgbClr val="C9A227"/>
+                </a:solidFill>
+                <a:latin typeface="Calibri" pitchFamily="34" charset="0"/>
+                <a:ea typeface="Calibri" pitchFamily="34" charset="-122"/>
+                <a:cs typeface="Calibri" pitchFamily="34" charset="-120"/>
+              </a:rPr>
+              <a:t>Find it in: </a:t>
+            </a:r>
+            <a:pPr indent="0" marL="0">
+              <a:buNone/>
+            </a:pPr>
+            <a:r>
+              <a:rPr lang="en-US" sz="1350" dirty="0">
+                <a:solidFill>
+                  <a:srgbClr val="C9D6EF"/>
+                </a:solidFill>
+                <a:latin typeface="Calibri" pitchFamily="34" charset="0"/>
+                <a:ea typeface="Calibri" pitchFamily="34" charset="-122"/>
+                <a:cs typeface="Calibri" pitchFamily="34" charset="-120"/>
+              </a:rPr>
+              <a:t>Gospel Library → Changes to the Sunday Class Meeting Schedule → Youth Fifth-Sunday Instruction Materials, or at sunday.ChurchofJesusChrist.org.</a:t>
+            </a:r>
+            <a:endParaRPr lang="en-US" sz="1350" dirty="0"/>
+          </a:p>
+        </p:txBody>
+      </p:sp>
+      <p:sp>
+        <p:nvSpPr>
+          <p:cNvPr id="10" name="Text 7"/>
+          <p:cNvSpPr txBox="1"/>
+          <p:nvPr/>
+        </p:nvSpPr>
+        <p:spPr>
+          <a:xfrm>
+            <a:off x="3657600" y="4343400"/>
+            <a:ext cx="7680960" cy="548640"/>
+          </a:xfrm>
+          <a:prstGeom prst="rect">
+            <a:avLst/>
+          </a:prstGeom>
+          <a:noFill/>
+          <a:ln/>
+        </p:spPr>
+        <p:txBody>
+          <a:bodyPr wrap="square" lIns="0" tIns="0" rIns="0" bIns="0" rtlCol="0" anchor="ctr"/>
+          <a:lstStyle/>
+          <a:p>
+            <a:pPr indent="0" marL="0">
+              <a:buNone/>
+            </a:pPr>
+            <a:r>
+              <a:rPr lang="en-US" sz="1350" b="1" dirty="0">
+                <a:solidFill>
+                  <a:srgbClr val="C9A227"/>
+                </a:solidFill>
+                <a:latin typeface="Calibri" pitchFamily="34" charset="0"/>
+                <a:ea typeface="Calibri" pitchFamily="34" charset="-122"/>
+                <a:cs typeface="Calibri" pitchFamily="34" charset="-120"/>
+              </a:rPr>
+              <a:t>Tip: </a:t>
+            </a:r>
+            <a:pPr indent="0" marL="0">
+              <a:buNone/>
+            </a:pPr>
+            <a:r>
+              <a:rPr lang="en-US" sz="1350" dirty="0">
+                <a:solidFill>
+                  <a:srgbClr val="C9D6EF"/>
+                </a:solidFill>
+                <a:latin typeface="Calibri" pitchFamily="34" charset="0"/>
+                <a:ea typeface="Calibri" pitchFamily="34" charset="-122"/>
+                <a:cs typeface="Calibri" pitchFamily="34" charset="-120"/>
+              </a:rPr>
+              <a:t>pause the video where prompted and use the discussion questions on the next slide.</a:t>
+            </a:r>
+            <a:endParaRPr lang="en-US" sz="1350" dirty="0"/>
+          </a:p>
+        </p:txBody>
+      </p:sp>
+    </p:spTree>
+  </p:cSld>
+  <p:clrMapOvr>
+    <a:masterClrMapping/>
+  </p:clrMapOvr>
+</p:sld>
+</file>
+
+<file path=ppt/slides/slide11.xml><?xml version="1.0" encoding="utf-8"?>
+<p:sld xmlns:a="http://schemas.openxmlformats.org/drawingml/2006/main" xmlns:r="http://schemas.openxmlformats.org/officeDocument/2006/relationships" xmlns:p="http://schemas.openxmlformats.org/presentationml/2006/main">
+  <p:cSld name="Slide 11">
+    <p:bg>
+      <p:bgPr>
+        <a:solidFill>
           <a:srgbClr val="FFFFFF"/>
         </a:solidFill>
       </p:bgPr>
@@ -2657,9 +3089,9 @@
 </p:sld>
 </file>
 
-<file path=ppt/slides/slide11.xml><?xml version="1.0" encoding="utf-8"?>
+<file path=ppt/slides/slide12.xml><?xml version="1.0" encoding="utf-8"?>
 <p:sld xmlns:a="http://schemas.openxmlformats.org/drawingml/2006/main" xmlns:r="http://schemas.openxmlformats.org/officeDocument/2006/relationships" xmlns:p="http://schemas.openxmlformats.org/presentationml/2006/main">
-  <p:cSld name="Slide 11">
+  <p:cSld name="Slide 12">
     <p:bg>
       <p:bgPr>
         <a:solidFill>
@@ -7318,7 +7750,7 @@
                 <a:ea typeface="Calibri" pitchFamily="34" charset="-122"/>
                 <a:cs typeface="Calibri" pitchFamily="34" charset="-120"/>
               </a:rPr>
-              <a:t>SEPTEMBER 2026  ·  THE FIRST MONTH</a:t>
+              <a:t>WHAT A LESSON LOOKS LIKE  ·  FROM THE SEPTEMBER FSY MAGAZINE</a:t>
             </a:r>
             <a:endParaRPr lang="en-US" sz="1200" dirty="0"/>
           </a:p>
@@ -7349,7 +7781,7 @@
               <a:buNone/>
             </a:pPr>
             <a:r>
-              <a:rPr lang="en-US" sz="2700" b="1" dirty="0">
+              <a:rPr lang="en-US" sz="3400" b="1" dirty="0">
                 <a:solidFill>
                   <a:srgbClr val="1B2A52"/>
                 </a:solidFill>
@@ -7357,9 +7789,9 @@
                 <a:ea typeface="Cambria" pitchFamily="34" charset="-122"/>
                 <a:cs typeface="Cambria" pitchFamily="34" charset="-120"/>
               </a:rPr>
-              <a:t>“You Are Blessed by Priesthood Keys and Authority”</a:t>
-            </a:r>
-            <a:endParaRPr lang="en-US" sz="2700" dirty="0"/>
+              <a:t>Inside a Fast Sunday Lesson</a:t>
+            </a:r>
+            <a:endParaRPr lang="en-US" sz="3400" dirty="0"/>
           </a:p>
         </p:txBody>
       </p:sp>
@@ -7371,36 +7803,36 @@
         </p:nvSpPr>
         <p:spPr>
           <a:xfrm>
-            <a:off x="502920" y="1691640"/>
-            <a:ext cx="4160520" cy="2377440"/>
+            <a:off x="502920" y="1783080"/>
+            <a:ext cx="2724912" cy="3246120"/>
           </a:xfrm>
           <a:prstGeom prst="roundRect">
             <a:avLst>
-              <a:gd name="adj" fmla="val 4615"/>
+              <a:gd name="adj" fmla="val 4027"/>
             </a:avLst>
+          </a:prstGeom>
+          <a:solidFill>
+            <a:srgbClr val="EDF1F8"/>
+          </a:solidFill>
+          <a:ln/>
+        </p:spPr>
+      </p:sp>
+      <p:sp>
+        <p:nvSpPr>
+          <p:cNvPr id="5" name="Shape 3"/>
+          <p:cNvSpPr/>
+          <p:nvPr/>
+        </p:nvSpPr>
+        <p:spPr>
+          <a:xfrm>
+            <a:off x="777240" y="2057400"/>
+            <a:ext cx="566928" cy="566928"/>
+          </a:xfrm>
+          <a:prstGeom prst="ellipse">
+            <a:avLst/>
           </a:prstGeom>
           <a:solidFill>
             <a:srgbClr val="1B2A52"/>
-          </a:solidFill>
-          <a:ln/>
-        </p:spPr>
-      </p:sp>
-      <p:sp>
-        <p:nvSpPr>
-          <p:cNvPr id="5" name="Shape 3"/>
-          <p:cNvSpPr/>
-          <p:nvPr/>
-        </p:nvSpPr>
-        <p:spPr>
-          <a:xfrm>
-            <a:off x="822960" y="1965960"/>
-            <a:ext cx="566928" cy="566928"/>
-          </a:xfrm>
-          <a:prstGeom prst="ellipse">
-            <a:avLst/>
-          </a:prstGeom>
-          <a:solidFill>
-            <a:srgbClr val="C9A227"/>
           </a:solidFill>
           <a:ln/>
         </p:spPr>
@@ -7421,7 +7853,7 @@
         </p:blipFill>
         <p:spPr>
           <a:xfrm>
-            <a:off x="976031" y="2119031"/>
+            <a:off x="930311" y="2210471"/>
             <a:ext cx="260787" cy="260787"/>
           </a:xfrm>
           <a:prstGeom prst="rect">
@@ -7431,42 +7863,23 @@
       </p:pic>
       <p:sp>
         <p:nvSpPr>
-          <p:cNvPr id="7" name="Text 4"/>
-          <p:cNvSpPr txBox="1"/>
-          <p:nvPr/>
-        </p:nvSpPr>
-        <p:spPr>
-          <a:xfrm>
-            <a:off x="1572768" y="2103120"/>
-            <a:ext cx="2926080" cy="274320"/>
-          </a:xfrm>
-          <a:prstGeom prst="rect">
-            <a:avLst/>
-          </a:prstGeom>
-          <a:noFill/>
-          <a:ln/>
-        </p:spPr>
-        <p:txBody>
-          <a:bodyPr wrap="square" lIns="0" tIns="0" rIns="0" bIns="0" rtlCol="0" anchor="ctr"/>
-          <a:lstStyle/>
-          <a:p>
-            <a:pPr indent="0" marL="0">
-              <a:buNone/>
-            </a:pPr>
-            <a:r>
-              <a:rPr lang="en-US" sz="1100" b="1" spc="200" kern="0" dirty="0">
-                <a:solidFill>
-                  <a:srgbClr val="C9A227"/>
-                </a:solidFill>
-                <a:latin typeface="Calibri" pitchFamily="34" charset="0"/>
-                <a:ea typeface="Calibri" pitchFamily="34" charset="-122"/>
-                <a:cs typeface="Calibri" pitchFamily="34" charset="-120"/>
-              </a:rPr>
-              <a:t>MATTHEW 16:19</a:t>
-            </a:r>
-            <a:endParaRPr lang="en-US" sz="1100" dirty="0"/>
-          </a:p>
-        </p:txBody>
+          <p:cNvPr id="7" name="Shape 4"/>
+          <p:cNvSpPr/>
+          <p:nvPr/>
+        </p:nvSpPr>
+        <p:spPr>
+          <a:xfrm>
+            <a:off x="2587752" y="2121408"/>
+            <a:ext cx="438912" cy="438912"/>
+          </a:xfrm>
+          <a:prstGeom prst="ellipse">
+            <a:avLst/>
+          </a:prstGeom>
+          <a:solidFill>
+            <a:srgbClr val="C9A227"/>
+          </a:solidFill>
+          <a:ln/>
+        </p:spPr>
       </p:sp>
       <p:sp>
         <p:nvSpPr>
@@ -7476,34 +7889,34 @@
         </p:nvSpPr>
         <p:spPr>
           <a:xfrm>
-            <a:off x="822960" y="2697480"/>
-            <a:ext cx="3566160" cy="960120"/>
-          </a:xfrm>
-          <a:prstGeom prst="rect">
-            <a:avLst/>
-          </a:prstGeom>
-          <a:noFill/>
-          <a:ln/>
-        </p:spPr>
-        <p:txBody>
-          <a:bodyPr wrap="square" lIns="0" tIns="0" rIns="0" bIns="0" rtlCol="0" anchor="ctr"/>
-          <a:lstStyle/>
-          <a:p>
-            <a:pPr indent="0" marL="0">
-              <a:buNone/>
-            </a:pPr>
-            <a:r>
-              <a:rPr lang="en-US" sz="1550" i="1" dirty="0">
-                <a:solidFill>
-                  <a:srgbClr val="FFFFFF"/>
+            <a:off x="2587752" y="2121408"/>
+            <a:ext cx="438912" cy="438912"/>
+          </a:xfrm>
+          <a:prstGeom prst="rect">
+            <a:avLst/>
+          </a:prstGeom>
+          <a:noFill/>
+          <a:ln/>
+        </p:spPr>
+        <p:txBody>
+          <a:bodyPr wrap="square" lIns="0" tIns="0" rIns="0" bIns="0" rtlCol="0" anchor="ctr"/>
+          <a:lstStyle/>
+          <a:p>
+            <a:pPr algn="ctr" indent="0" marL="0">
+              <a:buNone/>
+            </a:pPr>
+            <a:r>
+              <a:rPr lang="en-US" sz="1700" b="1" dirty="0">
+                <a:solidFill>
+                  <a:srgbClr val="1B2A52"/>
                 </a:solidFill>
                 <a:latin typeface="Cambria" pitchFamily="34" charset="0"/>
                 <a:ea typeface="Cambria" pitchFamily="34" charset="-122"/>
                 <a:cs typeface="Cambria" pitchFamily="34" charset="-120"/>
               </a:rPr>
-              <a:t>“And I will give unto thee the keys of the kingdom of heaven …”</a:t>
-            </a:r>
-            <a:endParaRPr lang="en-US" sz="1550" dirty="0"/>
+              <a:t>1</a:t>
+            </a:r>
+            <a:endParaRPr lang="en-US" sz="1700" dirty="0"/>
           </a:p>
         </p:txBody>
       </p:sp>
@@ -7515,34 +7928,34 @@
         </p:nvSpPr>
         <p:spPr>
           <a:xfrm>
-            <a:off x="822960" y="3639312"/>
-            <a:ext cx="3566160" cy="274320"/>
-          </a:xfrm>
-          <a:prstGeom prst="rect">
-            <a:avLst/>
-          </a:prstGeom>
-          <a:noFill/>
-          <a:ln/>
-        </p:spPr>
-        <p:txBody>
-          <a:bodyPr wrap="square" lIns="0" tIns="0" rIns="0" bIns="0" rtlCol="0" anchor="ctr"/>
-          <a:lstStyle/>
-          <a:p>
-            <a:pPr indent="0" marL="0">
-              <a:buNone/>
-            </a:pPr>
-            <a:r>
-              <a:rPr lang="en-US" sz="1050" dirty="0">
-                <a:solidFill>
-                  <a:srgbClr val="C9D6EF"/>
-                </a:solidFill>
-                <a:latin typeface="Calibri" pitchFamily="34" charset="0"/>
-                <a:ea typeface="Calibri" pitchFamily="34" charset="-122"/>
-                <a:cs typeface="Calibri" pitchFamily="34" charset="-120"/>
-              </a:rPr>
-              <a:t>The month's anchor scripture</a:t>
-            </a:r>
-            <a:endParaRPr lang="en-US" sz="1050" dirty="0"/>
+            <a:off x="777240" y="2880360"/>
+            <a:ext cx="2212848" cy="658368"/>
+          </a:xfrm>
+          <a:prstGeom prst="rect">
+            <a:avLst/>
+          </a:prstGeom>
+          <a:noFill/>
+          <a:ln/>
+        </p:spPr>
+        <p:txBody>
+          <a:bodyPr wrap="square" lIns="0" tIns="0" rIns="0" bIns="0" rtlCol="0" anchor="ctr"/>
+          <a:lstStyle/>
+          <a:p>
+            <a:pPr indent="0" marL="0">
+              <a:buNone/>
+            </a:pPr>
+            <a:r>
+              <a:rPr lang="en-US" sz="1500" b="1" dirty="0">
+                <a:solidFill>
+                  <a:srgbClr val="1B2A52"/>
+                </a:solidFill>
+                <a:latin typeface="Calibri" pitchFamily="34" charset="0"/>
+                <a:ea typeface="Calibri" pitchFamily="34" charset="-122"/>
+                <a:cs typeface="Calibri" pitchFamily="34" charset="-120"/>
+              </a:rPr>
+              <a:t>Choose an eternal truth</a:t>
+            </a:r>
+            <a:endParaRPr lang="en-US" sz="1500" dirty="0"/>
           </a:p>
         </p:txBody>
       </p:sp>
@@ -7554,32 +7967,32 @@
         </p:nvSpPr>
         <p:spPr>
           <a:xfrm>
-            <a:off x="548640" y="4343400"/>
-            <a:ext cx="4114800" cy="274320"/>
-          </a:xfrm>
-          <a:prstGeom prst="rect">
-            <a:avLst/>
-          </a:prstGeom>
-          <a:noFill/>
-          <a:ln/>
-        </p:spPr>
-        <p:txBody>
-          <a:bodyPr wrap="square" lIns="0" tIns="0" rIns="0" bIns="0" rtlCol="0" anchor="ctr"/>
-          <a:lstStyle/>
-          <a:p>
-            <a:pPr indent="0" marL="0">
-              <a:buNone/>
-            </a:pPr>
-            <a:r>
-              <a:rPr lang="en-US" sz="1100" b="1" spc="200" kern="0" dirty="0">
-                <a:solidFill>
-                  <a:srgbClr val="8F7115"/>
-                </a:solidFill>
-                <a:latin typeface="Calibri" pitchFamily="34" charset="0"/>
-                <a:ea typeface="Calibri" pitchFamily="34" charset="-122"/>
-                <a:cs typeface="Calibri" pitchFamily="34" charset="-120"/>
-              </a:rPr>
-              <a:t>ACTIVITY IDEAS FOR THE MONTH</a:t>
+            <a:off x="777240" y="3566160"/>
+            <a:ext cx="2212848" cy="1325880"/>
+          </a:xfrm>
+          <a:prstGeom prst="rect">
+            <a:avLst/>
+          </a:prstGeom>
+          <a:noFill/>
+          <a:ln/>
+        </p:spPr>
+        <p:txBody>
+          <a:bodyPr wrap="square" lIns="0" tIns="0" rIns="0" bIns="0" rtlCol="0" anchor="t"/>
+          <a:lstStyle/>
+          <a:p>
+            <a:pPr indent="0" marL="0">
+              <a:buNone/>
+            </a:pPr>
+            <a:r>
+              <a:rPr lang="en-US" sz="1100" dirty="0">
+                <a:solidFill>
+                  <a:srgbClr val="5C6575"/>
+                </a:solidFill>
+                <a:latin typeface="Calibri" pitchFamily="34" charset="0"/>
+                <a:ea typeface="Calibri" pitchFamily="34" charset="-122"/>
+                <a:cs typeface="Calibri" pitchFamily="34" charset="-120"/>
+              </a:rPr>
+              <a:t>Pick a truth from the chapter and share thoughts and questions about it.</a:t>
             </a:r>
             <a:endParaRPr lang="en-US" sz="1100" dirty="0"/>
           </a:p>
@@ -7593,12 +8006,12 @@
         </p:nvSpPr>
         <p:spPr>
           <a:xfrm>
-            <a:off x="548640" y="4709160"/>
-            <a:ext cx="4114800" cy="658368"/>
+            <a:off x="3328416" y="1783080"/>
+            <a:ext cx="2724912" cy="3246120"/>
           </a:xfrm>
           <a:prstGeom prst="roundRect">
             <a:avLst>
-              <a:gd name="adj" fmla="val 50000"/>
+              <a:gd name="adj" fmla="val 4027"/>
             </a:avLst>
           </a:prstGeom>
           <a:solidFill>
@@ -7615,8 +8028,8 @@
         </p:nvSpPr>
         <p:spPr>
           <a:xfrm>
-            <a:off x="685800" y="4828032"/>
-            <a:ext cx="420624" cy="420624"/>
+            <a:off x="3602736" y="2057400"/>
+            <a:ext cx="566928" cy="566928"/>
           </a:xfrm>
           <a:prstGeom prst="ellipse">
             <a:avLst/>
@@ -7643,8 +8056,8 @@
         </p:blipFill>
         <p:spPr>
           <a:xfrm>
-            <a:off x="799368" y="4941600"/>
-            <a:ext cx="193487" cy="193487"/>
+            <a:off x="3755807" y="2210471"/>
+            <a:ext cx="260787" cy="260787"/>
           </a:xfrm>
           <a:prstGeom prst="rect">
             <a:avLst/>
@@ -7653,57 +8066,155 @@
       </p:pic>
       <p:sp>
         <p:nvSpPr>
-          <p:cNvPr id="14" name="Text 10"/>
-          <p:cNvSpPr txBox="1"/>
-          <p:nvPr/>
-        </p:nvSpPr>
-        <p:spPr>
-          <a:xfrm>
-            <a:off x="1261872" y="4791456"/>
-            <a:ext cx="3291840" cy="502920"/>
-          </a:xfrm>
-          <a:prstGeom prst="rect">
-            <a:avLst/>
-          </a:prstGeom>
-          <a:noFill/>
-          <a:ln/>
-        </p:spPr>
-        <p:txBody>
-          <a:bodyPr wrap="square" lIns="0" tIns="0" rIns="0" bIns="0" rtlCol="0" anchor="ctr"/>
-          <a:lstStyle/>
-          <a:p>
-            <a:pPr indent="0" marL="0">
-              <a:buNone/>
-            </a:pPr>
-            <a:r>
-              <a:rPr lang="en-US" sz="1250" b="1" dirty="0">
+          <p:cNvPr id="14" name="Shape 10"/>
+          <p:cNvSpPr/>
+          <p:nvPr/>
+        </p:nvSpPr>
+        <p:spPr>
+          <a:xfrm>
+            <a:off x="5413248" y="2121408"/>
+            <a:ext cx="438912" cy="438912"/>
+          </a:xfrm>
+          <a:prstGeom prst="ellipse">
+            <a:avLst/>
+          </a:prstGeom>
+          <a:solidFill>
+            <a:srgbClr val="C9A227"/>
+          </a:solidFill>
+          <a:ln/>
+        </p:spPr>
+      </p:sp>
+      <p:sp>
+        <p:nvSpPr>
+          <p:cNvPr id="15" name="Text 11"/>
+          <p:cNvSpPr txBox="1"/>
+          <p:nvPr/>
+        </p:nvSpPr>
+        <p:spPr>
+          <a:xfrm>
+            <a:off x="5413248" y="2121408"/>
+            <a:ext cx="438912" cy="438912"/>
+          </a:xfrm>
+          <a:prstGeom prst="rect">
+            <a:avLst/>
+          </a:prstGeom>
+          <a:noFill/>
+          <a:ln/>
+        </p:spPr>
+        <p:txBody>
+          <a:bodyPr wrap="square" lIns="0" tIns="0" rIns="0" bIns="0" rtlCol="0" anchor="ctr"/>
+          <a:lstStyle/>
+          <a:p>
+            <a:pPr algn="ctr" indent="0" marL="0">
+              <a:buNone/>
+            </a:pPr>
+            <a:r>
+              <a:rPr lang="en-US" sz="1700" b="1" dirty="0">
                 <a:solidFill>
                   <a:srgbClr val="1B2A52"/>
                 </a:solidFill>
-                <a:latin typeface="Calibri" pitchFamily="34" charset="0"/>
-                <a:ea typeface="Calibri" pitchFamily="34" charset="-122"/>
-                <a:cs typeface="Calibri" pitchFamily="34" charset="-120"/>
-              </a:rPr>
-              <a:t>The One-Match Fire Challenge</a:t>
-            </a:r>
-            <a:endParaRPr lang="en-US" sz="1250" dirty="0"/>
-          </a:p>
-        </p:txBody>
-      </p:sp>
-      <p:sp>
-        <p:nvSpPr>
-          <p:cNvPr id="15" name="Shape 11"/>
+                <a:latin typeface="Cambria" pitchFamily="34" charset="0"/>
+                <a:ea typeface="Cambria" pitchFamily="34" charset="-122"/>
+                <a:cs typeface="Cambria" pitchFamily="34" charset="-120"/>
+              </a:rPr>
+              <a:t>2</a:t>
+            </a:r>
+            <a:endParaRPr lang="en-US" sz="1700" dirty="0"/>
+          </a:p>
+        </p:txBody>
+      </p:sp>
+      <p:sp>
+        <p:nvSpPr>
+          <p:cNvPr id="16" name="Text 12"/>
+          <p:cNvSpPr txBox="1"/>
+          <p:nvPr/>
+        </p:nvSpPr>
+        <p:spPr>
+          <a:xfrm>
+            <a:off x="3602736" y="2880360"/>
+            <a:ext cx="2212848" cy="658368"/>
+          </a:xfrm>
+          <a:prstGeom prst="rect">
+            <a:avLst/>
+          </a:prstGeom>
+          <a:noFill/>
+          <a:ln/>
+        </p:spPr>
+        <p:txBody>
+          <a:bodyPr wrap="square" lIns="0" tIns="0" rIns="0" bIns="0" rtlCol="0" anchor="ctr"/>
+          <a:lstStyle/>
+          <a:p>
+            <a:pPr indent="0" marL="0">
+              <a:buNone/>
+            </a:pPr>
+            <a:r>
+              <a:rPr lang="en-US" sz="1500" b="1" dirty="0">
+                <a:solidFill>
+                  <a:srgbClr val="1B2A52"/>
+                </a:solidFill>
+                <a:latin typeface="Calibri" pitchFamily="34" charset="0"/>
+                <a:ea typeface="Calibri" pitchFamily="34" charset="-122"/>
+                <a:cs typeface="Calibri" pitchFamily="34" charset="-120"/>
+              </a:rPr>
+              <a:t>Read a scripture together</a:t>
+            </a:r>
+            <a:endParaRPr lang="en-US" sz="1500" dirty="0"/>
+          </a:p>
+        </p:txBody>
+      </p:sp>
+      <p:sp>
+        <p:nvSpPr>
+          <p:cNvPr id="17" name="Text 13"/>
+          <p:cNvSpPr txBox="1"/>
+          <p:nvPr/>
+        </p:nvSpPr>
+        <p:spPr>
+          <a:xfrm>
+            <a:off x="3602736" y="3566160"/>
+            <a:ext cx="2212848" cy="1325880"/>
+          </a:xfrm>
+          <a:prstGeom prst="rect">
+            <a:avLst/>
+          </a:prstGeom>
+          <a:noFill/>
+          <a:ln/>
+        </p:spPr>
+        <p:txBody>
+          <a:bodyPr wrap="square" lIns="0" tIns="0" rIns="0" bIns="0" rtlCol="0" anchor="t"/>
+          <a:lstStyle/>
+          <a:p>
+            <a:pPr indent="0" marL="0">
+              <a:buNone/>
+            </a:pPr>
+            <a:r>
+              <a:rPr lang="en-US" sz="1100" dirty="0">
+                <a:solidFill>
+                  <a:srgbClr val="5C6575"/>
+                </a:solidFill>
+                <a:latin typeface="Calibri" pitchFamily="34" charset="0"/>
+                <a:ea typeface="Calibri" pitchFamily="34" charset="-122"/>
+                <a:cs typeface="Calibri" pitchFamily="34" charset="-120"/>
+              </a:rPr>
+              <a:t>Find verses that support it — what message does God have for you in it?</a:t>
+            </a:r>
+            <a:endParaRPr lang="en-US" sz="1100" dirty="0"/>
+          </a:p>
+        </p:txBody>
+      </p:sp>
+      <p:sp>
+        <p:nvSpPr>
+          <p:cNvPr id="18" name="Shape 14"/>
           <p:cNvSpPr/>
           <p:nvPr/>
         </p:nvSpPr>
         <p:spPr>
           <a:xfrm>
-            <a:off x="548640" y="5532120"/>
-            <a:ext cx="4114800" cy="658368"/>
+            <a:off x="6153912" y="1783080"/>
+            <a:ext cx="2724912" cy="3246120"/>
           </a:xfrm>
           <a:prstGeom prst="roundRect">
             <a:avLst>
-              <a:gd name="adj" fmla="val 50000"/>
+              <a:gd name="adj" fmla="val 4027"/>
             </a:avLst>
           </a:prstGeom>
           <a:solidFill>
@@ -7714,14 +8225,14 @@
       </p:sp>
       <p:sp>
         <p:nvSpPr>
-          <p:cNvPr id="16" name="Shape 12"/>
+          <p:cNvPr id="19" name="Shape 15"/>
           <p:cNvSpPr/>
           <p:nvPr/>
         </p:nvSpPr>
         <p:spPr>
           <a:xfrm>
-            <a:off x="685800" y="5650992"/>
-            <a:ext cx="420624" cy="420624"/>
+            <a:off x="6428232" y="2057400"/>
+            <a:ext cx="566928" cy="566928"/>
           </a:xfrm>
           <a:prstGeom prst="ellipse">
             <a:avLst/>
@@ -7734,7 +8245,7 @@
       </p:sp>
       <p:pic>
         <p:nvPicPr>
-          <p:cNvPr id="17" name="Image 2" descr="preencoded.png">    </p:cNvPr>
+          <p:cNvPr id="20" name="Image 2" descr="preencoded.png">    </p:cNvPr>
           <p:cNvPicPr>
             <a:picLocks noChangeAspect="1"/>
           </p:cNvPicPr>
@@ -7748,8 +8259,8 @@
         </p:blipFill>
         <p:spPr>
           <a:xfrm>
-            <a:off x="799368" y="5764560"/>
-            <a:ext cx="193487" cy="193487"/>
+            <a:off x="6581303" y="2210471"/>
+            <a:ext cx="260787" cy="260787"/>
           </a:xfrm>
           <a:prstGeom prst="rect">
             <a:avLst/>
@@ -7758,57 +8269,155 @@
       </p:pic>
       <p:sp>
         <p:nvSpPr>
-          <p:cNvPr id="18" name="Text 13"/>
-          <p:cNvSpPr txBox="1"/>
-          <p:nvPr/>
-        </p:nvSpPr>
-        <p:spPr>
-          <a:xfrm>
-            <a:off x="1261872" y="5614416"/>
-            <a:ext cx="3291840" cy="502920"/>
-          </a:xfrm>
-          <a:prstGeom prst="rect">
-            <a:avLst/>
-          </a:prstGeom>
-          <a:noFill/>
-          <a:ln/>
-        </p:spPr>
-        <p:txBody>
-          <a:bodyPr wrap="square" lIns="0" tIns="0" rIns="0" bIns="0" rtlCol="0" anchor="ctr"/>
-          <a:lstStyle/>
-          <a:p>
-            <a:pPr indent="0" marL="0">
-              <a:buNone/>
-            </a:pPr>
-            <a:r>
-              <a:rPr lang="en-US" sz="1250" b="1" dirty="0">
+          <p:cNvPr id="21" name="Shape 16"/>
+          <p:cNvSpPr/>
+          <p:nvPr/>
+        </p:nvSpPr>
+        <p:spPr>
+          <a:xfrm>
+            <a:off x="8238744" y="2121408"/>
+            <a:ext cx="438912" cy="438912"/>
+          </a:xfrm>
+          <a:prstGeom prst="ellipse">
+            <a:avLst/>
+          </a:prstGeom>
+          <a:solidFill>
+            <a:srgbClr val="C9A227"/>
+          </a:solidFill>
+          <a:ln/>
+        </p:spPr>
+      </p:sp>
+      <p:sp>
+        <p:nvSpPr>
+          <p:cNvPr id="22" name="Text 17"/>
+          <p:cNvSpPr txBox="1"/>
+          <p:nvPr/>
+        </p:nvSpPr>
+        <p:spPr>
+          <a:xfrm>
+            <a:off x="8238744" y="2121408"/>
+            <a:ext cx="438912" cy="438912"/>
+          </a:xfrm>
+          <a:prstGeom prst="rect">
+            <a:avLst/>
+          </a:prstGeom>
+          <a:noFill/>
+          <a:ln/>
+        </p:spPr>
+        <p:txBody>
+          <a:bodyPr wrap="square" lIns="0" tIns="0" rIns="0" bIns="0" rtlCol="0" anchor="ctr"/>
+          <a:lstStyle/>
+          <a:p>
+            <a:pPr algn="ctr" indent="0" marL="0">
+              <a:buNone/>
+            </a:pPr>
+            <a:r>
+              <a:rPr lang="en-US" sz="1700" b="1" dirty="0">
                 <a:solidFill>
                   <a:srgbClr val="1B2A52"/>
                 </a:solidFill>
-                <a:latin typeface="Calibri" pitchFamily="34" charset="0"/>
-                <a:ea typeface="Calibri" pitchFamily="34" charset="-122"/>
-                <a:cs typeface="Calibri" pitchFamily="34" charset="-120"/>
-              </a:rPr>
-              <a:t>A Flashlight and God's Priesthood Power</a:t>
-            </a:r>
-            <a:endParaRPr lang="en-US" sz="1250" dirty="0"/>
-          </a:p>
-        </p:txBody>
-      </p:sp>
-      <p:sp>
-        <p:nvSpPr>
-          <p:cNvPr id="19" name="Shape 14"/>
+                <a:latin typeface="Cambria" pitchFamily="34" charset="0"/>
+                <a:ea typeface="Cambria" pitchFamily="34" charset="-122"/>
+                <a:cs typeface="Cambria" pitchFamily="34" charset="-120"/>
+              </a:rPr>
+              <a:t>3</a:t>
+            </a:r>
+            <a:endParaRPr lang="en-US" sz="1700" dirty="0"/>
+          </a:p>
+        </p:txBody>
+      </p:sp>
+      <p:sp>
+        <p:nvSpPr>
+          <p:cNvPr id="23" name="Text 18"/>
+          <p:cNvSpPr txBox="1"/>
+          <p:nvPr/>
+        </p:nvSpPr>
+        <p:spPr>
+          <a:xfrm>
+            <a:off x="6428232" y="2880360"/>
+            <a:ext cx="2212848" cy="658368"/>
+          </a:xfrm>
+          <a:prstGeom prst="rect">
+            <a:avLst/>
+          </a:prstGeom>
+          <a:noFill/>
+          <a:ln/>
+        </p:spPr>
+        <p:txBody>
+          <a:bodyPr wrap="square" lIns="0" tIns="0" rIns="0" bIns="0" rtlCol="0" anchor="ctr"/>
+          <a:lstStyle/>
+          <a:p>
+            <a:pPr indent="0" marL="0">
+              <a:buNone/>
+            </a:pPr>
+            <a:r>
+              <a:rPr lang="en-US" sz="1500" b="1" dirty="0">
+                <a:solidFill>
+                  <a:srgbClr val="1B2A52"/>
+                </a:solidFill>
+                <a:latin typeface="Calibri" pitchFamily="34" charset="0"/>
+                <a:ea typeface="Calibri" pitchFamily="34" charset="-122"/>
+                <a:cs typeface="Calibri" pitchFamily="34" charset="-120"/>
+              </a:rPr>
+              <a:t>Share a personal story</a:t>
+            </a:r>
+            <a:endParaRPr lang="en-US" sz="1500" dirty="0"/>
+          </a:p>
+        </p:txBody>
+      </p:sp>
+      <p:sp>
+        <p:nvSpPr>
+          <p:cNvPr id="24" name="Text 19"/>
+          <p:cNvSpPr txBox="1"/>
+          <p:nvPr/>
+        </p:nvSpPr>
+        <p:spPr>
+          <a:xfrm>
+            <a:off x="6428232" y="3566160"/>
+            <a:ext cx="2212848" cy="1325880"/>
+          </a:xfrm>
+          <a:prstGeom prst="rect">
+            <a:avLst/>
+          </a:prstGeom>
+          <a:noFill/>
+          <a:ln/>
+        </p:spPr>
+        <p:txBody>
+          <a:bodyPr wrap="square" lIns="0" tIns="0" rIns="0" bIns="0" rtlCol="0" anchor="t"/>
+          <a:lstStyle/>
+          <a:p>
+            <a:pPr indent="0" marL="0">
+              <a:buNone/>
+            </a:pPr>
+            <a:r>
+              <a:rPr lang="en-US" sz="1100" dirty="0">
+                <a:solidFill>
+                  <a:srgbClr val="5C6575"/>
+                </a:solidFill>
+                <a:latin typeface="Calibri" pitchFamily="34" charset="0"/>
+                <a:ea typeface="Calibri" pitchFamily="34" charset="-122"/>
+                <a:cs typeface="Calibri" pitchFamily="34" charset="-120"/>
+              </a:rPr>
+              <a:t>An experience living this truth, or a promised blessing the Lord has kept.</a:t>
+            </a:r>
+            <a:endParaRPr lang="en-US" sz="1100" dirty="0"/>
+          </a:p>
+        </p:txBody>
+      </p:sp>
+      <p:sp>
+        <p:nvSpPr>
+          <p:cNvPr id="25" name="Shape 20"/>
           <p:cNvSpPr/>
           <p:nvPr/>
         </p:nvSpPr>
         <p:spPr>
           <a:xfrm>
-            <a:off x="4937760" y="1691640"/>
-            <a:ext cx="6720840" cy="1033272"/>
+            <a:off x="8979408" y="1783080"/>
+            <a:ext cx="2724912" cy="3246120"/>
           </a:xfrm>
           <a:prstGeom prst="roundRect">
             <a:avLst>
-              <a:gd name="adj" fmla="val 8850"/>
+              <a:gd name="adj" fmla="val 4027"/>
             </a:avLst>
           </a:prstGeom>
           <a:solidFill>
@@ -7819,19 +8428,17 @@
       </p:sp>
       <p:sp>
         <p:nvSpPr>
-          <p:cNvPr id="20" name="Shape 15"/>
+          <p:cNvPr id="26" name="Shape 21"/>
           <p:cNvSpPr/>
           <p:nvPr/>
         </p:nvSpPr>
         <p:spPr>
           <a:xfrm>
-            <a:off x="5138928" y="1938528"/>
-            <a:ext cx="960120" cy="530352"/>
-          </a:xfrm>
-          <a:prstGeom prst="roundRect">
-            <a:avLst>
-              <a:gd name="adj" fmla="val 13793"/>
-            </a:avLst>
+            <a:off x="9253728" y="2057400"/>
+            <a:ext cx="566928" cy="566928"/>
+          </a:xfrm>
+          <a:prstGeom prst="ellipse">
+            <a:avLst/>
           </a:prstGeom>
           <a:solidFill>
             <a:srgbClr val="1B2A52"/>
@@ -7839,16 +8446,60 @@
           <a:ln/>
         </p:spPr>
       </p:sp>
-      <p:sp>
-        <p:nvSpPr>
-          <p:cNvPr id="21" name="Text 16"/>
-          <p:cNvSpPr txBox="1"/>
-          <p:nvPr/>
-        </p:nvSpPr>
-        <p:spPr>
-          <a:xfrm>
-            <a:off x="5138928" y="1938528"/>
-            <a:ext cx="960120" cy="530352"/>
+      <p:pic>
+        <p:nvPicPr>
+          <p:cNvPr id="27" name="Image 3" descr="preencoded.png">    </p:cNvPr>
+          <p:cNvPicPr>
+            <a:picLocks noChangeAspect="1"/>
+          </p:cNvPicPr>
+          <p:nvPr/>
+        </p:nvPicPr>
+        <p:blipFill>
+          <a:blip r:embed="rId4"/>
+          <a:stretch>
+            <a:fillRect/>
+          </a:stretch>
+        </p:blipFill>
+        <p:spPr>
+          <a:xfrm>
+            <a:off x="9406799" y="2210471"/>
+            <a:ext cx="260787" cy="260787"/>
+          </a:xfrm>
+          <a:prstGeom prst="rect">
+            <a:avLst/>
+          </a:prstGeom>
+        </p:spPr>
+      </p:pic>
+      <p:sp>
+        <p:nvSpPr>
+          <p:cNvPr id="28" name="Shape 22"/>
+          <p:cNvSpPr/>
+          <p:nvPr/>
+        </p:nvSpPr>
+        <p:spPr>
+          <a:xfrm>
+            <a:off x="11064240" y="2121408"/>
+            <a:ext cx="438912" cy="438912"/>
+          </a:xfrm>
+          <a:prstGeom prst="ellipse">
+            <a:avLst/>
+          </a:prstGeom>
+          <a:solidFill>
+            <a:srgbClr val="C9A227"/>
+          </a:solidFill>
+          <a:ln/>
+        </p:spPr>
+      </p:sp>
+      <p:sp>
+        <p:nvSpPr>
+          <p:cNvPr id="29" name="Text 23"/>
+          <p:cNvSpPr txBox="1"/>
+          <p:nvPr/>
+        </p:nvSpPr>
+        <p:spPr>
+          <a:xfrm>
+            <a:off x="11064240" y="2121408"/>
+            <a:ext cx="438912" cy="438912"/>
           </a:xfrm>
           <a:prstGeom prst="rect">
             <a:avLst/>
@@ -7864,85 +8515,85 @@
               <a:buNone/>
             </a:pPr>
             <a:r>
-              <a:rPr lang="en-US" sz="1150" b="1" dirty="0">
-                <a:solidFill>
-                  <a:srgbClr val="C9A227"/>
-                </a:solidFill>
-                <a:latin typeface="Calibri" pitchFamily="34" charset="0"/>
-                <a:ea typeface="Calibri" pitchFamily="34" charset="-122"/>
-                <a:cs typeface="Calibri" pitchFamily="34" charset="-120"/>
-              </a:rPr>
-              <a:t>SEP 6</a:t>
-            </a:r>
-            <a:endParaRPr lang="en-US" sz="1150" dirty="0"/>
-          </a:p>
-        </p:txBody>
-      </p:sp>
-      <p:sp>
-        <p:nvSpPr>
-          <p:cNvPr id="22" name="Text 17"/>
-          <p:cNvSpPr txBox="1"/>
-          <p:nvPr/>
-        </p:nvSpPr>
-        <p:spPr>
-          <a:xfrm>
-            <a:off x="6309360" y="1828800"/>
-            <a:ext cx="5212080" cy="329184"/>
-          </a:xfrm>
-          <a:prstGeom prst="rect">
-            <a:avLst/>
-          </a:prstGeom>
-          <a:noFill/>
-          <a:ln/>
-        </p:spPr>
-        <p:txBody>
-          <a:bodyPr wrap="square" lIns="0" tIns="0" rIns="0" bIns="0" rtlCol="0" anchor="ctr"/>
-          <a:lstStyle/>
-          <a:p>
-            <a:pPr indent="0" marL="0">
-              <a:buNone/>
-            </a:pPr>
-            <a:r>
-              <a:rPr lang="en-US" sz="1450" b="1" dirty="0">
+              <a:rPr lang="en-US" sz="1700" b="1" dirty="0">
                 <a:solidFill>
                   <a:srgbClr val="1B2A52"/>
                 </a:solidFill>
-                <a:latin typeface="Calibri" pitchFamily="34" charset="0"/>
-                <a:ea typeface="Calibri" pitchFamily="34" charset="-122"/>
-                <a:cs typeface="Calibri" pitchFamily="34" charset="-120"/>
-              </a:rPr>
-              <a:t>Fast Sunday — study the chapter</a:t>
-            </a:r>
-            <a:endParaRPr lang="en-US" sz="1450" dirty="0"/>
-          </a:p>
-        </p:txBody>
-      </p:sp>
-      <p:sp>
-        <p:nvSpPr>
-          <p:cNvPr id="23" name="Text 18"/>
-          <p:cNvSpPr txBox="1"/>
-          <p:nvPr/>
-        </p:nvSpPr>
-        <p:spPr>
-          <a:xfrm>
-            <a:off x="6309360" y="2176272"/>
-            <a:ext cx="5212080" cy="457200"/>
-          </a:xfrm>
-          <a:prstGeom prst="rect">
-            <a:avLst/>
-          </a:prstGeom>
-          <a:noFill/>
-          <a:ln/>
-        </p:spPr>
-        <p:txBody>
-          <a:bodyPr wrap="square" lIns="0" tIns="0" rIns="0" bIns="0" rtlCol="0" anchor="ctr"/>
-          <a:lstStyle/>
-          <a:p>
-            <a:pPr indent="0" marL="0">
-              <a:buNone/>
-            </a:pPr>
-            <a:r>
-              <a:rPr lang="en-US" sz="1150" dirty="0">
+                <a:latin typeface="Cambria" pitchFamily="34" charset="0"/>
+                <a:ea typeface="Cambria" pitchFamily="34" charset="-122"/>
+                <a:cs typeface="Cambria" pitchFamily="34" charset="-120"/>
+              </a:rPr>
+              <a:t>4</a:t>
+            </a:r>
+            <a:endParaRPr lang="en-US" sz="1700" dirty="0"/>
+          </a:p>
+        </p:txBody>
+      </p:sp>
+      <p:sp>
+        <p:nvSpPr>
+          <p:cNvPr id="30" name="Text 24"/>
+          <p:cNvSpPr txBox="1"/>
+          <p:nvPr/>
+        </p:nvSpPr>
+        <p:spPr>
+          <a:xfrm>
+            <a:off x="9253728" y="2880360"/>
+            <a:ext cx="2212848" cy="658368"/>
+          </a:xfrm>
+          <a:prstGeom prst="rect">
+            <a:avLst/>
+          </a:prstGeom>
+          <a:noFill/>
+          <a:ln/>
+        </p:spPr>
+        <p:txBody>
+          <a:bodyPr wrap="square" lIns="0" tIns="0" rIns="0" bIns="0" rtlCol="0" anchor="ctr"/>
+          <a:lstStyle/>
+          <a:p>
+            <a:pPr indent="0" marL="0">
+              <a:buNone/>
+            </a:pPr>
+            <a:r>
+              <a:rPr lang="en-US" sz="1500" b="1" dirty="0">
+                <a:solidFill>
+                  <a:srgbClr val="1B2A52"/>
+                </a:solidFill>
+                <a:latin typeface="Calibri" pitchFamily="34" charset="0"/>
+                <a:ea typeface="Calibri" pitchFamily="34" charset="-122"/>
+                <a:cs typeface="Calibri" pitchFamily="34" charset="-120"/>
+              </a:rPr>
+              <a:t>Testify</a:t>
+            </a:r>
+            <a:endParaRPr lang="en-US" sz="1500" dirty="0"/>
+          </a:p>
+        </p:txBody>
+      </p:sp>
+      <p:sp>
+        <p:nvSpPr>
+          <p:cNvPr id="31" name="Text 25"/>
+          <p:cNvSpPr txBox="1"/>
+          <p:nvPr/>
+        </p:nvSpPr>
+        <p:spPr>
+          <a:xfrm>
+            <a:off x="9253728" y="3566160"/>
+            <a:ext cx="2212848" cy="1325880"/>
+          </a:xfrm>
+          <a:prstGeom prst="rect">
+            <a:avLst/>
+          </a:prstGeom>
+          <a:noFill/>
+          <a:ln/>
+        </p:spPr>
+        <p:txBody>
+          <a:bodyPr wrap="square" lIns="0" tIns="0" rIns="0" bIns="0" rtlCol="0" anchor="t"/>
+          <a:lstStyle/>
+          <a:p>
+            <a:pPr indent="0" marL="0">
+              <a:buNone/>
+            </a:pPr>
+            <a:r>
+              <a:rPr lang="en-US" sz="1100" dirty="0">
                 <a:solidFill>
                   <a:srgbClr val="5C6575"/>
                 </a:solidFill>
@@ -7950,121 +8601,84 @@
                 <a:ea typeface="Calibri" pitchFamily="34" charset="-122"/>
                 <a:cs typeface="Calibri" pitchFamily="34" charset="-120"/>
               </a:rPr>
-              <a:t>Read and discuss September's FSY guide chapter together.</a:t>
-            </a:r>
-            <a:endParaRPr lang="en-US" sz="1150" dirty="0"/>
-          </a:p>
-        </p:txBody>
-      </p:sp>
-      <p:sp>
-        <p:nvSpPr>
-          <p:cNvPr id="24" name="Shape 19"/>
+              <a:t>Share what you know from your own experience and what the Spirit has taught you.</a:t>
+            </a:r>
+            <a:endParaRPr lang="en-US" sz="1100" dirty="0"/>
+          </a:p>
+        </p:txBody>
+      </p:sp>
+      <p:sp>
+        <p:nvSpPr>
+          <p:cNvPr id="32" name="Shape 26"/>
           <p:cNvSpPr/>
           <p:nvPr/>
         </p:nvSpPr>
         <p:spPr>
           <a:xfrm>
-            <a:off x="4937760" y="2862072"/>
-            <a:ext cx="6720840" cy="1033272"/>
+            <a:off x="502920" y="5349240"/>
+            <a:ext cx="11201400" cy="960120"/>
           </a:xfrm>
           <a:prstGeom prst="roundRect">
             <a:avLst>
-              <a:gd name="adj" fmla="val 8850"/>
+              <a:gd name="adj" fmla="val 9524"/>
             </a:avLst>
           </a:prstGeom>
           <a:solidFill>
-            <a:srgbClr val="EDF1F8"/>
+            <a:srgbClr val="F6EFDB"/>
           </a:solidFill>
           <a:ln/>
         </p:spPr>
       </p:sp>
-      <p:sp>
-        <p:nvSpPr>
-          <p:cNvPr id="25" name="Shape 20"/>
-          <p:cNvSpPr/>
-          <p:nvPr/>
-        </p:nvSpPr>
-        <p:spPr>
-          <a:xfrm>
-            <a:off x="5138928" y="3108960"/>
-            <a:ext cx="960120" cy="530352"/>
-          </a:xfrm>
-          <a:prstGeom prst="roundRect">
-            <a:avLst>
-              <a:gd name="adj" fmla="val 13793"/>
-            </a:avLst>
-          </a:prstGeom>
-          <a:solidFill>
-            <a:srgbClr val="1B2A52"/>
-          </a:solidFill>
-          <a:ln/>
-        </p:spPr>
-      </p:sp>
-      <p:sp>
-        <p:nvSpPr>
-          <p:cNvPr id="26" name="Text 21"/>
-          <p:cNvSpPr txBox="1"/>
-          <p:nvPr/>
-        </p:nvSpPr>
-        <p:spPr>
-          <a:xfrm>
-            <a:off x="5138928" y="3108960"/>
-            <a:ext cx="960120" cy="530352"/>
-          </a:xfrm>
-          <a:prstGeom prst="rect">
-            <a:avLst/>
-          </a:prstGeom>
-          <a:noFill/>
-          <a:ln/>
-        </p:spPr>
-        <p:txBody>
-          <a:bodyPr wrap="square" lIns="0" tIns="0" rIns="0" bIns="0" rtlCol="0" anchor="ctr"/>
-          <a:lstStyle/>
-          <a:p>
-            <a:pPr algn="ctr" indent="0" marL="0">
-              <a:buNone/>
-            </a:pPr>
-            <a:r>
-              <a:rPr lang="en-US" sz="1150" b="1" dirty="0">
-                <a:solidFill>
-                  <a:srgbClr val="C9A227"/>
-                </a:solidFill>
-                <a:latin typeface="Calibri" pitchFamily="34" charset="0"/>
-                <a:ea typeface="Calibri" pitchFamily="34" charset="-122"/>
-                <a:cs typeface="Calibri" pitchFamily="34" charset="-120"/>
-              </a:rPr>
-              <a:t>SEP 13</a:t>
-            </a:r>
-            <a:endParaRPr lang="en-US" sz="1150" dirty="0"/>
-          </a:p>
-        </p:txBody>
-      </p:sp>
-      <p:sp>
-        <p:nvSpPr>
-          <p:cNvPr id="27" name="Text 22"/>
-          <p:cNvSpPr txBox="1"/>
-          <p:nvPr/>
-        </p:nvSpPr>
-        <p:spPr>
-          <a:xfrm>
-            <a:off x="6309360" y="2999232"/>
-            <a:ext cx="5212080" cy="329184"/>
-          </a:xfrm>
-          <a:prstGeom prst="rect">
-            <a:avLst/>
-          </a:prstGeom>
-          <a:noFill/>
-          <a:ln/>
-        </p:spPr>
-        <p:txBody>
-          <a:bodyPr wrap="square" lIns="0" tIns="0" rIns="0" bIns="0" rtlCol="0" anchor="ctr"/>
-          <a:lstStyle/>
-          <a:p>
-            <a:pPr indent="0" marL="0">
-              <a:buNone/>
-            </a:pPr>
-            <a:r>
-              <a:rPr lang="en-US" sz="1450" b="1" dirty="0">
+      <p:pic>
+        <p:nvPicPr>
+          <p:cNvPr id="33" name="Image 4" descr="preencoded.png">    </p:cNvPr>
+          <p:cNvPicPr>
+            <a:picLocks noChangeAspect="1"/>
+          </p:cNvPicPr>
+          <p:nvPr/>
+        </p:nvPicPr>
+        <p:blipFill>
+          <a:blip r:embed="rId5"/>
+          <a:stretch>
+            <a:fillRect/>
+          </a:stretch>
+        </p:blipFill>
+        <p:spPr>
+          <a:xfrm>
+            <a:off x="841248" y="5605272"/>
+            <a:ext cx="384048" cy="384048"/>
+          </a:xfrm>
+          <a:prstGeom prst="rect">
+            <a:avLst/>
+          </a:prstGeom>
+        </p:spPr>
+      </p:pic>
+      <p:sp>
+        <p:nvSpPr>
+          <p:cNvPr id="34" name="Text 27"/>
+          <p:cNvSpPr txBox="1"/>
+          <p:nvPr/>
+        </p:nvSpPr>
+        <p:spPr>
+          <a:xfrm>
+            <a:off x="1371600" y="5504688"/>
+            <a:ext cx="10149840" cy="685800"/>
+          </a:xfrm>
+          <a:prstGeom prst="rect">
+            <a:avLst/>
+          </a:prstGeom>
+          <a:noFill/>
+          <a:ln/>
+        </p:spPr>
+        <p:txBody>
+          <a:bodyPr wrap="square" lIns="0" tIns="0" rIns="0" bIns="0" rtlCol="0" anchor="ctr"/>
+          <a:lstStyle/>
+          <a:p>
+            <a:pPr indent="0" marL="0">
+              <a:buNone/>
+            </a:pPr>
+            <a:r>
+              <a:rPr lang="en-US" sz="1300" b="1" dirty="0">
                 <a:solidFill>
                   <a:srgbClr val="1B2A52"/>
                 </a:solidFill>
@@ -8072,370 +8686,23 @@
                 <a:ea typeface="Calibri" pitchFamily="34" charset="-122"/>
                 <a:cs typeface="Calibri" pitchFamily="34" charset="-120"/>
               </a:rPr>
-              <a:t>The restoration of the priesthood</a:t>
-            </a:r>
-            <a:endParaRPr lang="en-US" sz="1450" dirty="0"/>
-          </a:p>
-        </p:txBody>
-      </p:sp>
-      <p:sp>
-        <p:nvSpPr>
-          <p:cNvPr id="28" name="Text 23"/>
-          <p:cNvSpPr txBox="1"/>
-          <p:nvPr/>
-        </p:nvSpPr>
-        <p:spPr>
-          <a:xfrm>
-            <a:off x="6309360" y="3346704"/>
-            <a:ext cx="5212080" cy="457200"/>
-          </a:xfrm>
-          <a:prstGeom prst="rect">
-            <a:avLst/>
-          </a:prstGeom>
-          <a:noFill/>
-          <a:ln/>
-        </p:spPr>
-        <p:txBody>
-          <a:bodyPr wrap="square" lIns="0" tIns="0" rIns="0" bIns="0" rtlCol="0" anchor="ctr"/>
-          <a:lstStyle/>
-          <a:p>
-            <a:pPr indent="0" marL="0">
-              <a:buNone/>
-            </a:pPr>
-            <a:r>
-              <a:rPr lang="en-US" sz="1150" dirty="0">
-                <a:solidFill>
-                  <a:srgbClr val="5C6575"/>
-                </a:solidFill>
-                <a:latin typeface="Calibri" pitchFamily="34" charset="0"/>
-                <a:ea typeface="Calibri" pitchFamily="34" charset="-122"/>
-                <a:cs typeface="Calibri" pitchFamily="34" charset="-120"/>
-              </a:rPr>
-              <a:t>Learn how God's priesthood authority was restored in our day.</a:t>
-            </a:r>
-            <a:endParaRPr lang="en-US" sz="1150" dirty="0"/>
-          </a:p>
-        </p:txBody>
-      </p:sp>
-      <p:sp>
-        <p:nvSpPr>
-          <p:cNvPr id="29" name="Shape 24"/>
-          <p:cNvSpPr/>
-          <p:nvPr/>
-        </p:nvSpPr>
-        <p:spPr>
-          <a:xfrm>
-            <a:off x="4937760" y="4032504"/>
-            <a:ext cx="6720840" cy="1033272"/>
-          </a:xfrm>
-          <a:prstGeom prst="roundRect">
-            <a:avLst>
-              <a:gd name="adj" fmla="val 8850"/>
-            </a:avLst>
-          </a:prstGeom>
-          <a:solidFill>
-            <a:srgbClr val="EDF1F8"/>
-          </a:solidFill>
-          <a:ln/>
-        </p:spPr>
-      </p:sp>
-      <p:sp>
-        <p:nvSpPr>
-          <p:cNvPr id="30" name="Shape 25"/>
-          <p:cNvSpPr/>
-          <p:nvPr/>
-        </p:nvSpPr>
-        <p:spPr>
-          <a:xfrm>
-            <a:off x="5138928" y="4279392"/>
-            <a:ext cx="960120" cy="530352"/>
-          </a:xfrm>
-          <a:prstGeom prst="roundRect">
-            <a:avLst>
-              <a:gd name="adj" fmla="val 13793"/>
-            </a:avLst>
-          </a:prstGeom>
-          <a:solidFill>
-            <a:srgbClr val="1B2A52"/>
-          </a:solidFill>
-          <a:ln/>
-        </p:spPr>
-      </p:sp>
-      <p:sp>
-        <p:nvSpPr>
-          <p:cNvPr id="31" name="Text 26"/>
-          <p:cNvSpPr txBox="1"/>
-          <p:nvPr/>
-        </p:nvSpPr>
-        <p:spPr>
-          <a:xfrm>
-            <a:off x="5138928" y="4279392"/>
-            <a:ext cx="960120" cy="530352"/>
-          </a:xfrm>
-          <a:prstGeom prst="rect">
-            <a:avLst/>
-          </a:prstGeom>
-          <a:noFill/>
-          <a:ln/>
-        </p:spPr>
-        <p:txBody>
-          <a:bodyPr wrap="square" lIns="0" tIns="0" rIns="0" bIns="0" rtlCol="0" anchor="ctr"/>
-          <a:lstStyle/>
-          <a:p>
-            <a:pPr algn="ctr" indent="0" marL="0">
-              <a:buNone/>
-            </a:pPr>
-            <a:r>
-              <a:rPr lang="en-US" sz="1150" b="1" dirty="0">
-                <a:solidFill>
-                  <a:srgbClr val="C9A227"/>
-                </a:solidFill>
-                <a:latin typeface="Calibri" pitchFamily="34" charset="0"/>
-                <a:ea typeface="Calibri" pitchFamily="34" charset="-122"/>
-                <a:cs typeface="Calibri" pitchFamily="34" charset="-120"/>
-              </a:rPr>
-              <a:t>SEP 20</a:t>
-            </a:r>
-            <a:endParaRPr lang="en-US" sz="1150" dirty="0"/>
-          </a:p>
-        </p:txBody>
-      </p:sp>
-      <p:sp>
-        <p:nvSpPr>
-          <p:cNvPr id="32" name="Text 27"/>
-          <p:cNvSpPr txBox="1"/>
-          <p:nvPr/>
-        </p:nvSpPr>
-        <p:spPr>
-          <a:xfrm>
-            <a:off x="6309360" y="4169664"/>
-            <a:ext cx="5212080" cy="329184"/>
-          </a:xfrm>
-          <a:prstGeom prst="rect">
-            <a:avLst/>
-          </a:prstGeom>
-          <a:noFill/>
-          <a:ln/>
-        </p:spPr>
-        <p:txBody>
-          <a:bodyPr wrap="square" lIns="0" tIns="0" rIns="0" bIns="0" rtlCol="0" anchor="ctr"/>
-          <a:lstStyle/>
-          <a:p>
-            <a:pPr indent="0" marL="0">
-              <a:buNone/>
-            </a:pPr>
-            <a:r>
-              <a:rPr lang="en-US" sz="1450" b="1" dirty="0">
-                <a:solidFill>
-                  <a:srgbClr val="1B2A52"/>
-                </a:solidFill>
-                <a:latin typeface="Calibri" pitchFamily="34" charset="0"/>
-                <a:ea typeface="Calibri" pitchFamily="34" charset="-122"/>
-                <a:cs typeface="Calibri" pitchFamily="34" charset="-120"/>
-              </a:rPr>
-              <a:t>Priesthood keys</a:t>
-            </a:r>
-            <a:endParaRPr lang="en-US" sz="1450" dirty="0"/>
-          </a:p>
-        </p:txBody>
-      </p:sp>
-      <p:sp>
-        <p:nvSpPr>
-          <p:cNvPr id="33" name="Text 28"/>
-          <p:cNvSpPr txBox="1"/>
-          <p:nvPr/>
-        </p:nvSpPr>
-        <p:spPr>
-          <a:xfrm>
-            <a:off x="6309360" y="4517136"/>
-            <a:ext cx="5212080" cy="457200"/>
-          </a:xfrm>
-          <a:prstGeom prst="rect">
-            <a:avLst/>
-          </a:prstGeom>
-          <a:noFill/>
-          <a:ln/>
-        </p:spPr>
-        <p:txBody>
-          <a:bodyPr wrap="square" lIns="0" tIns="0" rIns="0" bIns="0" rtlCol="0" anchor="ctr"/>
-          <a:lstStyle/>
-          <a:p>
-            <a:pPr indent="0" marL="0">
-              <a:buNone/>
-            </a:pPr>
-            <a:r>
-              <a:rPr lang="en-US" sz="1150" dirty="0">
-                <a:solidFill>
-                  <a:srgbClr val="5C6575"/>
-                </a:solidFill>
-                <a:latin typeface="Calibri" pitchFamily="34" charset="0"/>
-                <a:ea typeface="Calibri" pitchFamily="34" charset="-122"/>
-                <a:cs typeface="Calibri" pitchFamily="34" charset="-120"/>
-              </a:rPr>
-              <a:t>What priesthood keys are — and how they bless your life.</a:t>
-            </a:r>
-            <a:endParaRPr lang="en-US" sz="1150" dirty="0"/>
-          </a:p>
-        </p:txBody>
-      </p:sp>
-      <p:sp>
-        <p:nvSpPr>
-          <p:cNvPr id="34" name="Shape 29"/>
-          <p:cNvSpPr/>
-          <p:nvPr/>
-        </p:nvSpPr>
-        <p:spPr>
-          <a:xfrm>
-            <a:off x="4937760" y="5202936"/>
-            <a:ext cx="6720840" cy="1033272"/>
-          </a:xfrm>
-          <a:prstGeom prst="roundRect">
-            <a:avLst>
-              <a:gd name="adj" fmla="val 8850"/>
-            </a:avLst>
-          </a:prstGeom>
-          <a:solidFill>
-            <a:srgbClr val="EDF1F8"/>
-          </a:solidFill>
-          <a:ln/>
-        </p:spPr>
-      </p:sp>
-      <p:sp>
-        <p:nvSpPr>
-          <p:cNvPr id="35" name="Shape 30"/>
-          <p:cNvSpPr/>
-          <p:nvPr/>
-        </p:nvSpPr>
-        <p:spPr>
-          <a:xfrm>
-            <a:off x="5138928" y="5449824"/>
-            <a:ext cx="960120" cy="530352"/>
-          </a:xfrm>
-          <a:prstGeom prst="roundRect">
-            <a:avLst>
-              <a:gd name="adj" fmla="val 13793"/>
-            </a:avLst>
-          </a:prstGeom>
-          <a:solidFill>
-            <a:srgbClr val="1B2A52"/>
-          </a:solidFill>
-          <a:ln/>
-        </p:spPr>
-      </p:sp>
-      <p:sp>
-        <p:nvSpPr>
-          <p:cNvPr id="36" name="Text 31"/>
-          <p:cNvSpPr txBox="1"/>
-          <p:nvPr/>
-        </p:nvSpPr>
-        <p:spPr>
-          <a:xfrm>
-            <a:off x="5138928" y="5449824"/>
-            <a:ext cx="960120" cy="530352"/>
-          </a:xfrm>
-          <a:prstGeom prst="rect">
-            <a:avLst/>
-          </a:prstGeom>
-          <a:noFill/>
-          <a:ln/>
-        </p:spPr>
-        <p:txBody>
-          <a:bodyPr wrap="square" lIns="0" tIns="0" rIns="0" bIns="0" rtlCol="0" anchor="ctr"/>
-          <a:lstStyle/>
-          <a:p>
-            <a:pPr algn="ctr" indent="0" marL="0">
-              <a:buNone/>
-            </a:pPr>
-            <a:r>
-              <a:rPr lang="en-US" sz="1150" b="1" dirty="0">
-                <a:solidFill>
-                  <a:srgbClr val="C9A227"/>
-                </a:solidFill>
-                <a:latin typeface="Calibri" pitchFamily="34" charset="0"/>
-                <a:ea typeface="Calibri" pitchFamily="34" charset="-122"/>
-                <a:cs typeface="Calibri" pitchFamily="34" charset="-120"/>
-              </a:rPr>
-              <a:t>SEP 27</a:t>
-            </a:r>
-            <a:endParaRPr lang="en-US" sz="1150" dirty="0"/>
-          </a:p>
-        </p:txBody>
-      </p:sp>
-      <p:sp>
-        <p:nvSpPr>
-          <p:cNvPr id="37" name="Text 32"/>
-          <p:cNvSpPr txBox="1"/>
-          <p:nvPr/>
-        </p:nvSpPr>
-        <p:spPr>
-          <a:xfrm>
-            <a:off x="6309360" y="5340096"/>
-            <a:ext cx="5212080" cy="329184"/>
-          </a:xfrm>
-          <a:prstGeom prst="rect">
-            <a:avLst/>
-          </a:prstGeom>
-          <a:noFill/>
-          <a:ln/>
-        </p:spPr>
-        <p:txBody>
-          <a:bodyPr wrap="square" lIns="0" tIns="0" rIns="0" bIns="0" rtlCol="0" anchor="ctr"/>
-          <a:lstStyle/>
-          <a:p>
-            <a:pPr indent="0" marL="0">
-              <a:buNone/>
-            </a:pPr>
-            <a:r>
-              <a:rPr lang="en-US" sz="1450" b="1" dirty="0">
-                <a:solidFill>
-                  <a:srgbClr val="1B2A52"/>
-                </a:solidFill>
-                <a:latin typeface="Calibri" pitchFamily="34" charset="0"/>
-                <a:ea typeface="Calibri" pitchFamily="34" charset="-122"/>
-                <a:cs typeface="Calibri" pitchFamily="34" charset="-120"/>
-              </a:rPr>
-              <a:t>Covenant daughters and sons of God</a:t>
-            </a:r>
-            <a:endParaRPr lang="en-US" sz="1450" dirty="0"/>
-          </a:p>
-        </p:txBody>
-      </p:sp>
-      <p:sp>
-        <p:nvSpPr>
-          <p:cNvPr id="38" name="Text 33"/>
-          <p:cNvSpPr txBox="1"/>
-          <p:nvPr/>
-        </p:nvSpPr>
-        <p:spPr>
-          <a:xfrm>
-            <a:off x="6309360" y="5687568"/>
-            <a:ext cx="5212080" cy="457200"/>
-          </a:xfrm>
-          <a:prstGeom prst="rect">
-            <a:avLst/>
-          </a:prstGeom>
-          <a:noFill/>
-          <a:ln/>
-        </p:spPr>
-        <p:txBody>
-          <a:bodyPr wrap="square" lIns="0" tIns="0" rIns="0" bIns="0" rtlCol="0" anchor="ctr"/>
-          <a:lstStyle/>
-          <a:p>
-            <a:pPr indent="0" marL="0">
-              <a:buNone/>
-            </a:pPr>
-            <a:r>
-              <a:rPr lang="en-US" sz="1150" dirty="0">
-                <a:solidFill>
-                  <a:srgbClr val="5C6575"/>
-                </a:solidFill>
-                <a:latin typeface="Calibri" pitchFamily="34" charset="0"/>
-                <a:ea typeface="Calibri" pitchFamily="34" charset="-122"/>
-                <a:cs typeface="Calibri" pitchFamily="34" charset="-120"/>
-              </a:rPr>
-              <a:t>Young Women and Aaronic Priesthood quorums each hold their own lesson.</a:t>
-            </a:r>
-            <a:endParaRPr lang="en-US" sz="1150" dirty="0"/>
+              <a:t>Then: </a:t>
+            </a:r>
+            <a:pPr indent="0" marL="0">
+              <a:buNone/>
+            </a:pPr>
+            <a:r>
+              <a:rPr lang="en-US" sz="1300" dirty="0">
+                <a:solidFill>
+                  <a:srgbClr val="232A35"/>
+                </a:solidFill>
+                <a:latin typeface="Calibri" pitchFamily="34" charset="0"/>
+                <a:ea typeface="Calibri" pitchFamily="34" charset="-122"/>
+                <a:cs typeface="Calibri" pitchFamily="34" charset="-120"/>
+              </a:rPr>
+              <a:t>repeat with another truth as time allows — and each fast Sunday, choose an invitation from the guide (or one of your own) to live that month.</a:t>
+            </a:r>
+            <a:endParaRPr lang="en-US" sz="1300" dirty="0"/>
           </a:p>
         </p:txBody>
       </p:sp>
@@ -8504,7 +8771,7 @@
                 <a:ea typeface="Calibri" pitchFamily="34" charset="-122"/>
                 <a:cs typeface="Calibri" pitchFamily="34" charset="-120"/>
               </a:rPr>
-              <a:t>RESOURCES</a:t>
+              <a:t>SEPTEMBER 2026  ·  THE FIRST MONTH</a:t>
             </a:r>
             <a:endParaRPr lang="en-US" sz="1200" dirty="0"/>
           </a:p>
@@ -8535,7 +8802,7 @@
               <a:buNone/>
             </a:pPr>
             <a:r>
-              <a:rPr lang="en-US" sz="3400" b="1" dirty="0">
+              <a:rPr lang="en-US" sz="2700" b="1" dirty="0">
                 <a:solidFill>
                   <a:srgbClr val="1B2A52"/>
                 </a:solidFill>
@@ -8543,9 +8810,9 @@
                 <a:ea typeface="Cambria" pitchFamily="34" charset="-122"/>
                 <a:cs typeface="Cambria" pitchFamily="34" charset="-120"/>
               </a:rPr>
-              <a:t>Where to Find Everything</a:t>
-            </a:r>
-            <a:endParaRPr lang="en-US" sz="3400" dirty="0"/>
+              <a:t>“You Are Blessed by Priesthood Keys and Authority”</a:t>
+            </a:r>
+            <a:endParaRPr lang="en-US" sz="2700" dirty="0"/>
           </a:p>
         </p:txBody>
       </p:sp>
@@ -8557,16 +8824,16 @@
         </p:nvSpPr>
         <p:spPr>
           <a:xfrm>
-            <a:off x="502920" y="1783080"/>
-            <a:ext cx="2724912" cy="3017520"/>
+            <a:off x="502920" y="1691640"/>
+            <a:ext cx="4160520" cy="2377440"/>
           </a:xfrm>
           <a:prstGeom prst="roundRect">
             <a:avLst>
-              <a:gd name="adj" fmla="val 4027"/>
+              <a:gd name="adj" fmla="val 4615"/>
             </a:avLst>
           </a:prstGeom>
           <a:solidFill>
-            <a:srgbClr val="EDF1F8"/>
+            <a:srgbClr val="1B2A52"/>
           </a:solidFill>
           <a:ln/>
         </p:spPr>
@@ -8579,14 +8846,14 @@
         </p:nvSpPr>
         <p:spPr>
           <a:xfrm>
-            <a:off x="777240" y="2057400"/>
+            <a:off x="822960" y="1965960"/>
             <a:ext cx="566928" cy="566928"/>
           </a:xfrm>
           <a:prstGeom prst="ellipse">
             <a:avLst/>
           </a:prstGeom>
           <a:solidFill>
-            <a:srgbClr val="1B2A52"/>
+            <a:srgbClr val="C9A227"/>
           </a:solidFill>
           <a:ln/>
         </p:spPr>
@@ -8607,7 +8874,7 @@
         </p:blipFill>
         <p:spPr>
           <a:xfrm>
-            <a:off x="930311" y="2210471"/>
+            <a:off x="976031" y="2119031"/>
             <a:ext cx="260787" cy="260787"/>
           </a:xfrm>
           <a:prstGeom prst="rect">
@@ -8623,34 +8890,34 @@
         </p:nvSpPr>
         <p:spPr>
           <a:xfrm>
-            <a:off x="777240" y="2834640"/>
-            <a:ext cx="2212848" cy="640080"/>
-          </a:xfrm>
-          <a:prstGeom prst="rect">
-            <a:avLst/>
-          </a:prstGeom>
-          <a:noFill/>
-          <a:ln/>
-        </p:spPr>
-        <p:txBody>
-          <a:bodyPr wrap="square" lIns="0" tIns="0" rIns="0" bIns="0" rtlCol="0" anchor="ctr"/>
-          <a:lstStyle/>
-          <a:p>
-            <a:pPr indent="0" marL="0">
-              <a:buNone/>
-            </a:pPr>
-            <a:r>
-              <a:rPr lang="en-US" sz="1500" b="1" dirty="0">
-                <a:solidFill>
-                  <a:srgbClr val="1B2A52"/>
-                </a:solidFill>
-                <a:latin typeface="Calibri" pitchFamily="34" charset="0"/>
-                <a:ea typeface="Calibri" pitchFamily="34" charset="-122"/>
-                <a:cs typeface="Calibri" pitchFamily="34" charset="-120"/>
-              </a:rPr>
-              <a:t>FSY Guide</a:t>
-            </a:r>
-            <a:endParaRPr lang="en-US" sz="1500" dirty="0"/>
+            <a:off x="1572768" y="2103120"/>
+            <a:ext cx="2926080" cy="274320"/>
+          </a:xfrm>
+          <a:prstGeom prst="rect">
+            <a:avLst/>
+          </a:prstGeom>
+          <a:noFill/>
+          <a:ln/>
+        </p:spPr>
+        <p:txBody>
+          <a:bodyPr wrap="square" lIns="0" tIns="0" rIns="0" bIns="0" rtlCol="0" anchor="ctr"/>
+          <a:lstStyle/>
+          <a:p>
+            <a:pPr indent="0" marL="0">
+              <a:buNone/>
+            </a:pPr>
+            <a:r>
+              <a:rPr lang="en-US" sz="1100" b="1" spc="200" kern="0" dirty="0">
+                <a:solidFill>
+                  <a:srgbClr val="C9A227"/>
+                </a:solidFill>
+                <a:latin typeface="Calibri" pitchFamily="34" charset="0"/>
+                <a:ea typeface="Calibri" pitchFamily="34" charset="-122"/>
+                <a:cs typeface="Calibri" pitchFamily="34" charset="-120"/>
+              </a:rPr>
+              <a:t>MATTHEW 16:19</a:t>
+            </a:r>
+            <a:endParaRPr lang="en-US" sz="1100" dirty="0"/>
           </a:p>
         </p:txBody>
       </p:sp>
@@ -8662,32 +8929,110 @@
         </p:nvSpPr>
         <p:spPr>
           <a:xfrm>
-            <a:off x="777240" y="3383280"/>
-            <a:ext cx="2212848" cy="1051560"/>
-          </a:xfrm>
-          <a:prstGeom prst="rect">
-            <a:avLst/>
-          </a:prstGeom>
-          <a:noFill/>
-          <a:ln/>
-        </p:spPr>
-        <p:txBody>
-          <a:bodyPr wrap="square" lIns="0" tIns="0" rIns="0" bIns="0" rtlCol="0" anchor="t"/>
-          <a:lstStyle/>
-          <a:p>
-            <a:pPr indent="0" marL="0">
-              <a:buNone/>
-            </a:pPr>
-            <a:r>
-              <a:rPr lang="en-US" sz="1100" dirty="0">
-                <a:solidFill>
-                  <a:srgbClr val="5C6575"/>
-                </a:solidFill>
-                <a:latin typeface="Calibri" pitchFamily="34" charset="0"/>
-                <a:ea typeface="Calibri" pitchFamily="34" charset="-122"/>
-                <a:cs typeface="Calibri" pitchFamily="34" charset="-120"/>
-              </a:rPr>
-              <a:t>For the Strength of Youth: A Guide for Making Choices — in the Gospel Library app and in print.</a:t>
+            <a:off x="822960" y="2697480"/>
+            <a:ext cx="3566160" cy="960120"/>
+          </a:xfrm>
+          <a:prstGeom prst="rect">
+            <a:avLst/>
+          </a:prstGeom>
+          <a:noFill/>
+          <a:ln/>
+        </p:spPr>
+        <p:txBody>
+          <a:bodyPr wrap="square" lIns="0" tIns="0" rIns="0" bIns="0" rtlCol="0" anchor="ctr"/>
+          <a:lstStyle/>
+          <a:p>
+            <a:pPr indent="0" marL="0">
+              <a:buNone/>
+            </a:pPr>
+            <a:r>
+              <a:rPr lang="en-US" sz="1550" i="1" dirty="0">
+                <a:solidFill>
+                  <a:srgbClr val="FFFFFF"/>
+                </a:solidFill>
+                <a:latin typeface="Cambria" pitchFamily="34" charset="0"/>
+                <a:ea typeface="Cambria" pitchFamily="34" charset="-122"/>
+                <a:cs typeface="Cambria" pitchFamily="34" charset="-120"/>
+              </a:rPr>
+              <a:t>“And I will give unto thee the keys of the kingdom of heaven …”</a:t>
+            </a:r>
+            <a:endParaRPr lang="en-US" sz="1550" dirty="0"/>
+          </a:p>
+        </p:txBody>
+      </p:sp>
+      <p:sp>
+        <p:nvSpPr>
+          <p:cNvPr id="9" name="Text 6"/>
+          <p:cNvSpPr txBox="1"/>
+          <p:nvPr/>
+        </p:nvSpPr>
+        <p:spPr>
+          <a:xfrm>
+            <a:off x="822960" y="3639312"/>
+            <a:ext cx="3566160" cy="274320"/>
+          </a:xfrm>
+          <a:prstGeom prst="rect">
+            <a:avLst/>
+          </a:prstGeom>
+          <a:noFill/>
+          <a:ln/>
+        </p:spPr>
+        <p:txBody>
+          <a:bodyPr wrap="square" lIns="0" tIns="0" rIns="0" bIns="0" rtlCol="0" anchor="ctr"/>
+          <a:lstStyle/>
+          <a:p>
+            <a:pPr indent="0" marL="0">
+              <a:buNone/>
+            </a:pPr>
+            <a:r>
+              <a:rPr lang="en-US" sz="1050" dirty="0">
+                <a:solidFill>
+                  <a:srgbClr val="C9D6EF"/>
+                </a:solidFill>
+                <a:latin typeface="Calibri" pitchFamily="34" charset="0"/>
+                <a:ea typeface="Calibri" pitchFamily="34" charset="-122"/>
+                <a:cs typeface="Calibri" pitchFamily="34" charset="-120"/>
+              </a:rPr>
+              <a:t>The month's anchor scripture</a:t>
+            </a:r>
+            <a:endParaRPr lang="en-US" sz="1050" dirty="0"/>
+          </a:p>
+        </p:txBody>
+      </p:sp>
+      <p:sp>
+        <p:nvSpPr>
+          <p:cNvPr id="10" name="Text 7"/>
+          <p:cNvSpPr txBox="1"/>
+          <p:nvPr/>
+        </p:nvSpPr>
+        <p:spPr>
+          <a:xfrm>
+            <a:off x="548640" y="4343400"/>
+            <a:ext cx="4114800" cy="274320"/>
+          </a:xfrm>
+          <a:prstGeom prst="rect">
+            <a:avLst/>
+          </a:prstGeom>
+          <a:noFill/>
+          <a:ln/>
+        </p:spPr>
+        <p:txBody>
+          <a:bodyPr wrap="square" lIns="0" tIns="0" rIns="0" bIns="0" rtlCol="0" anchor="ctr"/>
+          <a:lstStyle/>
+          <a:p>
+            <a:pPr indent="0" marL="0">
+              <a:buNone/>
+            </a:pPr>
+            <a:r>
+              <a:rPr lang="en-US" sz="1100" b="1" spc="200" kern="0" dirty="0">
+                <a:solidFill>
+                  <a:srgbClr val="8F7115"/>
+                </a:solidFill>
+                <a:latin typeface="Calibri" pitchFamily="34" charset="0"/>
+                <a:ea typeface="Calibri" pitchFamily="34" charset="-122"/>
+                <a:cs typeface="Calibri" pitchFamily="34" charset="-120"/>
+              </a:rPr>
+              <a:t>ACTIVITY IDEAS FOR THE MONTH</a:t>
             </a:r>
             <a:endParaRPr lang="en-US" sz="1100" dirty="0"/>
           </a:p>
@@ -8695,18 +9040,18 @@
       </p:sp>
       <p:sp>
         <p:nvSpPr>
-          <p:cNvPr id="9" name="Shape 6"/>
+          <p:cNvPr id="11" name="Shape 8"/>
           <p:cNvSpPr/>
           <p:nvPr/>
         </p:nvSpPr>
         <p:spPr>
           <a:xfrm>
-            <a:off x="3328416" y="1783080"/>
-            <a:ext cx="2724912" cy="3017520"/>
+            <a:off x="548640" y="4709160"/>
+            <a:ext cx="4114800" cy="658368"/>
           </a:xfrm>
           <a:prstGeom prst="roundRect">
             <a:avLst>
-              <a:gd name="adj" fmla="val 4027"/>
+              <a:gd name="adj" fmla="val 50000"/>
             </a:avLst>
           </a:prstGeom>
           <a:solidFill>
@@ -8717,14 +9062,14 @@
       </p:sp>
       <p:sp>
         <p:nvSpPr>
-          <p:cNvPr id="10" name="Shape 7"/>
+          <p:cNvPr id="12" name="Shape 9"/>
           <p:cNvSpPr/>
           <p:nvPr/>
         </p:nvSpPr>
         <p:spPr>
           <a:xfrm>
-            <a:off x="3602736" y="2057400"/>
-            <a:ext cx="566928" cy="566928"/>
+            <a:off x="685800" y="4828032"/>
+            <a:ext cx="420624" cy="420624"/>
           </a:xfrm>
           <a:prstGeom prst="ellipse">
             <a:avLst/>
@@ -8737,7 +9082,7 @@
       </p:sp>
       <p:pic>
         <p:nvPicPr>
-          <p:cNvPr id="11" name="Image 1" descr="preencoded.png">    </p:cNvPr>
+          <p:cNvPr id="13" name="Image 1" descr="preencoded.png">    </p:cNvPr>
           <p:cNvPicPr>
             <a:picLocks noChangeAspect="1"/>
           </p:cNvPicPr>
@@ -8751,8 +9096,8 @@
         </p:blipFill>
         <p:spPr>
           <a:xfrm>
-            <a:off x="3755807" y="2210471"/>
-            <a:ext cx="260787" cy="260787"/>
+            <a:off x="799368" y="4941600"/>
+            <a:ext cx="193487" cy="193487"/>
           </a:xfrm>
           <a:prstGeom prst="rect">
             <a:avLst/>
@@ -8761,30 +9106,30 @@
       </p:pic>
       <p:sp>
         <p:nvSpPr>
-          <p:cNvPr id="12" name="Text 8"/>
-          <p:cNvSpPr txBox="1"/>
-          <p:nvPr/>
-        </p:nvSpPr>
-        <p:spPr>
-          <a:xfrm>
-            <a:off x="3602736" y="2834640"/>
-            <a:ext cx="2212848" cy="640080"/>
-          </a:xfrm>
-          <a:prstGeom prst="rect">
-            <a:avLst/>
-          </a:prstGeom>
-          <a:noFill/>
-          <a:ln/>
-        </p:spPr>
-        <p:txBody>
-          <a:bodyPr wrap="square" lIns="0" tIns="0" rIns="0" bIns="0" rtlCol="0" anchor="ctr"/>
-          <a:lstStyle/>
-          <a:p>
-            <a:pPr indent="0" marL="0">
-              <a:buNone/>
-            </a:pPr>
-            <a:r>
-              <a:rPr lang="en-US" sz="1500" b="1" dirty="0">
+          <p:cNvPr id="14" name="Text 10"/>
+          <p:cNvSpPr txBox="1"/>
+          <p:nvPr/>
+        </p:nvSpPr>
+        <p:spPr>
+          <a:xfrm>
+            <a:off x="1261872" y="4791456"/>
+            <a:ext cx="3291840" cy="502920"/>
+          </a:xfrm>
+          <a:prstGeom prst="rect">
+            <a:avLst/>
+          </a:prstGeom>
+          <a:noFill/>
+          <a:ln/>
+        </p:spPr>
+        <p:txBody>
+          <a:bodyPr wrap="square" lIns="0" tIns="0" rIns="0" bIns="0" rtlCol="0" anchor="ctr"/>
+          <a:lstStyle/>
+          <a:p>
+            <a:pPr indent="0" marL="0">
+              <a:buNone/>
+            </a:pPr>
+            <a:r>
+              <a:rPr lang="en-US" sz="1250" b="1" dirty="0">
                 <a:solidFill>
                   <a:srgbClr val="1B2A52"/>
                 </a:solidFill>
@@ -8792,87 +9137,9 @@
                 <a:ea typeface="Calibri" pitchFamily="34" charset="-122"/>
                 <a:cs typeface="Calibri" pitchFamily="34" charset="-120"/>
               </a:rPr>
-              <a:t>FSY Magazine</a:t>
-            </a:r>
-            <a:endParaRPr lang="en-US" sz="1500" dirty="0"/>
-          </a:p>
-        </p:txBody>
-      </p:sp>
-      <p:sp>
-        <p:nvSpPr>
-          <p:cNvPr id="13" name="Text 9"/>
-          <p:cNvSpPr txBox="1"/>
-          <p:nvPr/>
-        </p:nvSpPr>
-        <p:spPr>
-          <a:xfrm>
-            <a:off x="3602736" y="3383280"/>
-            <a:ext cx="2212848" cy="1051560"/>
-          </a:xfrm>
-          <a:prstGeom prst="rect">
-            <a:avLst/>
-          </a:prstGeom>
-          <a:noFill/>
-          <a:ln/>
-        </p:spPr>
-        <p:txBody>
-          <a:bodyPr wrap="square" lIns="0" tIns="0" rIns="0" bIns="0" rtlCol="0" anchor="t"/>
-          <a:lstStyle/>
-          <a:p>
-            <a:pPr indent="0" marL="0">
-              <a:buNone/>
-            </a:pPr>
-            <a:r>
-              <a:rPr lang="en-US" sz="1100" dirty="0">
-                <a:solidFill>
-                  <a:srgbClr val="5C6575"/>
-                </a:solidFill>
-                <a:latin typeface="Calibri" pitchFamily="34" charset="0"/>
-                <a:ea typeface="Calibri" pitchFamily="34" charset="-122"/>
-                <a:cs typeface="Calibri" pitchFamily="34" charset="-120"/>
-              </a:rPr>
-              <a:t>Monthly stories and articles on each theme. One free print subscription per household.</a:t>
-            </a:r>
-            <a:endParaRPr lang="en-US" sz="1100" dirty="0"/>
-          </a:p>
-        </p:txBody>
-      </p:sp>
-      <p:sp>
-        <p:nvSpPr>
-          <p:cNvPr id="14" name="Text 10"/>
-          <p:cNvSpPr txBox="1"/>
-          <p:nvPr/>
-        </p:nvSpPr>
-        <p:spPr>
-          <a:xfrm>
-            <a:off x="3529584" y="4425696"/>
-            <a:ext cx="2432304" cy="274320"/>
-          </a:xfrm>
-          <a:prstGeom prst="rect">
-            <a:avLst/>
-          </a:prstGeom>
-          <a:noFill/>
-          <a:ln/>
-        </p:spPr>
-        <p:txBody>
-          <a:bodyPr wrap="square" lIns="0" tIns="0" rIns="0" bIns="0" rtlCol="0" anchor="ctr"/>
-          <a:lstStyle/>
-          <a:p>
-            <a:pPr indent="0" marL="0">
-              <a:buNone/>
-            </a:pPr>
-            <a:r>
-              <a:rPr lang="en-US" sz="870" b="1" dirty="0">
-                <a:solidFill>
-                  <a:srgbClr val="1B2A52"/>
-                </a:solidFill>
-                <a:latin typeface="Calibri" pitchFamily="34" charset="0"/>
-                <a:ea typeface="Calibri" pitchFamily="34" charset="-122"/>
-                <a:cs typeface="Calibri" pitchFamily="34" charset="-120"/>
-              </a:rPr>
-              <a:t>magazines.ChurchofJesusChrist.org</a:t>
-            </a:r>
-            <a:endParaRPr lang="en-US" sz="870" dirty="0"/>
+              <a:t>The One-Match Fire Challenge</a:t>
+            </a:r>
+            <a:endParaRPr lang="en-US" sz="1250" dirty="0"/>
           </a:p>
         </p:txBody>
       </p:sp>
@@ -8884,12 +9151,12 @@
         </p:nvSpPr>
         <p:spPr>
           <a:xfrm>
-            <a:off x="6153912" y="1783080"/>
-            <a:ext cx="2724912" cy="3017520"/>
+            <a:off x="548640" y="5532120"/>
+            <a:ext cx="4114800" cy="658368"/>
           </a:xfrm>
           <a:prstGeom prst="roundRect">
             <a:avLst>
-              <a:gd name="adj" fmla="val 4027"/>
+              <a:gd name="adj" fmla="val 50000"/>
             </a:avLst>
           </a:prstGeom>
           <a:solidFill>
@@ -8906,8 +9173,8 @@
         </p:nvSpPr>
         <p:spPr>
           <a:xfrm>
-            <a:off x="6428232" y="2057400"/>
-            <a:ext cx="566928" cy="566928"/>
+            <a:off x="685800" y="5650992"/>
+            <a:ext cx="420624" cy="420624"/>
           </a:xfrm>
           <a:prstGeom prst="ellipse">
             <a:avLst/>
@@ -8934,8 +9201,8 @@
         </p:blipFill>
         <p:spPr>
           <a:xfrm>
-            <a:off x="6581303" y="2210471"/>
-            <a:ext cx="260787" cy="260787"/>
+            <a:off x="799368" y="5764560"/>
+            <a:ext cx="193487" cy="193487"/>
           </a:xfrm>
           <a:prstGeom prst="rect">
             <a:avLst/>
@@ -8950,24 +9217,24 @@
         </p:nvSpPr>
         <p:spPr>
           <a:xfrm>
-            <a:off x="6428232" y="2834640"/>
-            <a:ext cx="2212848" cy="640080"/>
-          </a:xfrm>
-          <a:prstGeom prst="rect">
-            <a:avLst/>
-          </a:prstGeom>
-          <a:noFill/>
-          <a:ln/>
-        </p:spPr>
-        <p:txBody>
-          <a:bodyPr wrap="square" lIns="0" tIns="0" rIns="0" bIns="0" rtlCol="0" anchor="ctr"/>
-          <a:lstStyle/>
-          <a:p>
-            <a:pPr indent="0" marL="0">
-              <a:buNone/>
-            </a:pPr>
-            <a:r>
-              <a:rPr lang="en-US" sz="1500" b="1" dirty="0">
+            <a:off x="1261872" y="5614416"/>
+            <a:ext cx="3291840" cy="502920"/>
+          </a:xfrm>
+          <a:prstGeom prst="rect">
+            <a:avLst/>
+          </a:prstGeom>
+          <a:noFill/>
+          <a:ln/>
+        </p:spPr>
+        <p:txBody>
+          <a:bodyPr wrap="square" lIns="0" tIns="0" rIns="0" bIns="0" rtlCol="0" anchor="ctr"/>
+          <a:lstStyle/>
+          <a:p>
+            <a:pPr indent="0" marL="0">
+              <a:buNone/>
+            </a:pPr>
+            <a:r>
+              <a:rPr lang="en-US" sz="1250" b="1" dirty="0">
                 <a:solidFill>
                   <a:srgbClr val="1B2A52"/>
                 </a:solidFill>
@@ -8975,65 +9242,26 @@
                 <a:ea typeface="Calibri" pitchFamily="34" charset="-122"/>
                 <a:cs typeface="Calibri" pitchFamily="34" charset="-120"/>
               </a:rPr>
-              <a:t>Gospel Library</a:t>
-            </a:r>
-            <a:endParaRPr lang="en-US" sz="1500" dirty="0"/>
-          </a:p>
-        </p:txBody>
-      </p:sp>
-      <p:sp>
-        <p:nvSpPr>
-          <p:cNvPr id="19" name="Text 14"/>
-          <p:cNvSpPr txBox="1"/>
-          <p:nvPr/>
-        </p:nvSpPr>
-        <p:spPr>
-          <a:xfrm>
-            <a:off x="6428232" y="3383280"/>
-            <a:ext cx="2212848" cy="1051560"/>
-          </a:xfrm>
-          <a:prstGeom prst="rect">
-            <a:avLst/>
-          </a:prstGeom>
-          <a:noFill/>
-          <a:ln/>
-        </p:spPr>
-        <p:txBody>
-          <a:bodyPr wrap="square" lIns="0" tIns="0" rIns="0" bIns="0" rtlCol="0" anchor="t"/>
-          <a:lstStyle/>
-          <a:p>
-            <a:pPr indent="0" marL="0">
-              <a:buNone/>
-            </a:pPr>
-            <a:r>
-              <a:rPr lang="en-US" sz="1100" dirty="0">
-                <a:solidFill>
-                  <a:srgbClr val="5C6575"/>
-                </a:solidFill>
-                <a:latin typeface="Calibri" pitchFamily="34" charset="0"/>
-                <a:ea typeface="Calibri" pitchFamily="34" charset="-122"/>
-                <a:cs typeface="Calibri" pitchFamily="34" charset="-120"/>
-              </a:rPr>
-              <a:t>The FSY lessons for every Sunday, plus Come, Follow Me — all in the Gospel Library app.</a:t>
-            </a:r>
-            <a:endParaRPr lang="en-US" sz="1100" dirty="0"/>
-          </a:p>
-        </p:txBody>
-      </p:sp>
-      <p:sp>
-        <p:nvSpPr>
-          <p:cNvPr id="20" name="Shape 15"/>
+              <a:t>A Flashlight and God's Priesthood Power</a:t>
+            </a:r>
+            <a:endParaRPr lang="en-US" sz="1250" dirty="0"/>
+          </a:p>
+        </p:txBody>
+      </p:sp>
+      <p:sp>
+        <p:nvSpPr>
+          <p:cNvPr id="19" name="Shape 14"/>
           <p:cNvSpPr/>
           <p:nvPr/>
         </p:nvSpPr>
         <p:spPr>
           <a:xfrm>
-            <a:off x="8979408" y="1783080"/>
-            <a:ext cx="2724912" cy="3017520"/>
+            <a:off x="4937760" y="1691640"/>
+            <a:ext cx="6720840" cy="1033272"/>
           </a:xfrm>
           <a:prstGeom prst="roundRect">
             <a:avLst>
-              <a:gd name="adj" fmla="val 4027"/>
+              <a:gd name="adj" fmla="val 8850"/>
             </a:avLst>
           </a:prstGeom>
           <a:solidFill>
@@ -9044,17 +9272,19 @@
       </p:sp>
       <p:sp>
         <p:nvSpPr>
-          <p:cNvPr id="21" name="Shape 16"/>
+          <p:cNvPr id="20" name="Shape 15"/>
           <p:cNvSpPr/>
           <p:nvPr/>
         </p:nvSpPr>
         <p:spPr>
           <a:xfrm>
-            <a:off x="9253728" y="2057400"/>
-            <a:ext cx="566928" cy="566928"/>
-          </a:xfrm>
-          <a:prstGeom prst="ellipse">
-            <a:avLst/>
+            <a:off x="5138928" y="1938528"/>
+            <a:ext cx="960120" cy="530352"/>
+          </a:xfrm>
+          <a:prstGeom prst="roundRect">
+            <a:avLst>
+              <a:gd name="adj" fmla="val 13793"/>
+            </a:avLst>
           </a:prstGeom>
           <a:solidFill>
             <a:srgbClr val="1B2A52"/>
@@ -9062,56 +9292,71 @@
           <a:ln/>
         </p:spPr>
       </p:sp>
-      <p:pic>
-        <p:nvPicPr>
-          <p:cNvPr id="22" name="Image 3" descr="preencoded.png">    </p:cNvPr>
-          <p:cNvPicPr>
-            <a:picLocks noChangeAspect="1"/>
-          </p:cNvPicPr>
-          <p:nvPr/>
-        </p:nvPicPr>
-        <p:blipFill>
-          <a:blip r:embed="rId4"/>
-          <a:stretch>
-            <a:fillRect/>
-          </a:stretch>
-        </p:blipFill>
-        <p:spPr>
-          <a:xfrm>
-            <a:off x="9406799" y="2210471"/>
-            <a:ext cx="260787" cy="260787"/>
-          </a:xfrm>
-          <a:prstGeom prst="rect">
-            <a:avLst/>
-          </a:prstGeom>
-        </p:spPr>
-      </p:pic>
-      <p:sp>
-        <p:nvSpPr>
-          <p:cNvPr id="23" name="Text 17"/>
-          <p:cNvSpPr txBox="1"/>
-          <p:nvPr/>
-        </p:nvSpPr>
-        <p:spPr>
-          <a:xfrm>
-            <a:off x="9253728" y="2834640"/>
-            <a:ext cx="2212848" cy="640080"/>
-          </a:xfrm>
-          <a:prstGeom prst="rect">
-            <a:avLst/>
-          </a:prstGeom>
-          <a:noFill/>
-          <a:ln/>
-        </p:spPr>
-        <p:txBody>
-          <a:bodyPr wrap="square" lIns="0" tIns="0" rIns="0" bIns="0" rtlCol="0" anchor="ctr"/>
-          <a:lstStyle/>
-          <a:p>
-            <a:pPr indent="0" marL="0">
-              <a:buNone/>
-            </a:pPr>
-            <a:r>
-              <a:rPr lang="en-US" sz="1500" b="1" dirty="0">
+      <p:sp>
+        <p:nvSpPr>
+          <p:cNvPr id="21" name="Text 16"/>
+          <p:cNvSpPr txBox="1"/>
+          <p:nvPr/>
+        </p:nvSpPr>
+        <p:spPr>
+          <a:xfrm>
+            <a:off x="5138928" y="1938528"/>
+            <a:ext cx="960120" cy="530352"/>
+          </a:xfrm>
+          <a:prstGeom prst="rect">
+            <a:avLst/>
+          </a:prstGeom>
+          <a:noFill/>
+          <a:ln/>
+        </p:spPr>
+        <p:txBody>
+          <a:bodyPr wrap="square" lIns="0" tIns="0" rIns="0" bIns="0" rtlCol="0" anchor="ctr"/>
+          <a:lstStyle/>
+          <a:p>
+            <a:pPr algn="ctr" indent="0" marL="0">
+              <a:buNone/>
+            </a:pPr>
+            <a:r>
+              <a:rPr lang="en-US" sz="1150" b="1" dirty="0">
+                <a:solidFill>
+                  <a:srgbClr val="C9A227"/>
+                </a:solidFill>
+                <a:latin typeface="Calibri" pitchFamily="34" charset="0"/>
+                <a:ea typeface="Calibri" pitchFamily="34" charset="-122"/>
+                <a:cs typeface="Calibri" pitchFamily="34" charset="-120"/>
+              </a:rPr>
+              <a:t>SEP 6</a:t>
+            </a:r>
+            <a:endParaRPr lang="en-US" sz="1150" dirty="0"/>
+          </a:p>
+        </p:txBody>
+      </p:sp>
+      <p:sp>
+        <p:nvSpPr>
+          <p:cNvPr id="22" name="Text 17"/>
+          <p:cNvSpPr txBox="1"/>
+          <p:nvPr/>
+        </p:nvSpPr>
+        <p:spPr>
+          <a:xfrm>
+            <a:off x="6309360" y="1819656"/>
+            <a:ext cx="5212080" cy="329184"/>
+          </a:xfrm>
+          <a:prstGeom prst="rect">
+            <a:avLst/>
+          </a:prstGeom>
+          <a:noFill/>
+          <a:ln/>
+        </p:spPr>
+        <p:txBody>
+          <a:bodyPr wrap="square" lIns="0" tIns="0" rIns="0" bIns="0" rtlCol="0" anchor="ctr"/>
+          <a:lstStyle/>
+          <a:p>
+            <a:pPr indent="0" marL="0">
+              <a:buNone/>
+            </a:pPr>
+            <a:r>
+              <a:rPr lang="en-US" sz="1450" b="1" dirty="0">
                 <a:solidFill>
                   <a:srgbClr val="1B2A52"/>
                 </a:solidFill>
@@ -9119,22 +9364,22 @@
                 <a:ea typeface="Calibri" pitchFamily="34" charset="-122"/>
                 <a:cs typeface="Calibri" pitchFamily="34" charset="-120"/>
               </a:rPr>
-              <a:t>Sunday Website</a:t>
-            </a:r>
-            <a:endParaRPr lang="en-US" sz="1500" dirty="0"/>
-          </a:p>
-        </p:txBody>
-      </p:sp>
-      <p:sp>
-        <p:nvSpPr>
-          <p:cNvPr id="24" name="Text 18"/>
-          <p:cNvSpPr txBox="1"/>
-          <p:nvPr/>
-        </p:nvSpPr>
-        <p:spPr>
-          <a:xfrm>
-            <a:off x="9253728" y="3383280"/>
-            <a:ext cx="2212848" cy="1051560"/>
+              <a:t>Fast Sunday — study the chapter</a:t>
+            </a:r>
+            <a:endParaRPr lang="en-US" sz="1450" dirty="0"/>
+          </a:p>
+        </p:txBody>
+      </p:sp>
+      <p:sp>
+        <p:nvSpPr>
+          <p:cNvPr id="23" name="Text 18"/>
+          <p:cNvSpPr txBox="1"/>
+          <p:nvPr/>
+        </p:nvSpPr>
+        <p:spPr>
+          <a:xfrm>
+            <a:off x="6309360" y="2148840"/>
+            <a:ext cx="5257800" cy="512064"/>
           </a:xfrm>
           <a:prstGeom prst="rect">
             <a:avLst/>
@@ -9150,7 +9395,7 @@
               <a:buNone/>
             </a:pPr>
             <a:r>
-              <a:rPr lang="en-US" sz="1100" dirty="0">
+              <a:rPr lang="en-US" sz="1050" dirty="0">
                 <a:solidFill>
                   <a:srgbClr val="5C6575"/>
                 </a:solidFill>
@@ -9158,65 +9403,48 @@
                 <a:ea typeface="Calibri" pitchFamily="34" charset="-122"/>
                 <a:cs typeface="Calibri" pitchFamily="34" charset="-120"/>
               </a:rPr>
-              <a:t>Instructional videos, the implementation guide, and answers to common questions.</a:t>
-            </a:r>
-            <a:endParaRPr lang="en-US" sz="1100" dirty="0"/>
-          </a:p>
-        </p:txBody>
-      </p:sp>
-      <p:sp>
-        <p:nvSpPr>
-          <p:cNvPr id="25" name="Text 19"/>
-          <p:cNvSpPr txBox="1"/>
-          <p:nvPr/>
-        </p:nvSpPr>
-        <p:spPr>
-          <a:xfrm>
-            <a:off x="9180576" y="4425696"/>
-            <a:ext cx="2432304" cy="274320"/>
-          </a:xfrm>
-          <a:prstGeom prst="rect">
-            <a:avLst/>
-          </a:prstGeom>
-          <a:noFill/>
-          <a:ln/>
-        </p:spPr>
-        <p:txBody>
-          <a:bodyPr wrap="square" lIns="0" tIns="0" rIns="0" bIns="0" rtlCol="0" anchor="ctr"/>
-          <a:lstStyle/>
-          <a:p>
-            <a:pPr indent="0" marL="0">
-              <a:buNone/>
-            </a:pPr>
-            <a:r>
-              <a:rPr lang="en-US" sz="870" b="1" dirty="0">
-                <a:solidFill>
-                  <a:srgbClr val="1B2A52"/>
-                </a:solidFill>
-                <a:latin typeface="Calibri" pitchFamily="34" charset="0"/>
-                <a:ea typeface="Calibri" pitchFamily="34" charset="-122"/>
-                <a:cs typeface="Calibri" pitchFamily="34" charset="-120"/>
-              </a:rPr>
-              <a:t>sunday.ChurchofJesusChrist.org</a:t>
-            </a:r>
-            <a:endParaRPr lang="en-US" sz="870" dirty="0"/>
-          </a:p>
-        </p:txBody>
-      </p:sp>
-      <p:sp>
-        <p:nvSpPr>
-          <p:cNvPr id="26" name="Shape 20"/>
+              <a:t>FSY guide pages 46–49: discuss its truths and choose an invitation to live.</a:t>
+            </a:r>
+            <a:endParaRPr lang="en-US" sz="1050" dirty="0"/>
+          </a:p>
+        </p:txBody>
+      </p:sp>
+      <p:sp>
+        <p:nvSpPr>
+          <p:cNvPr id="24" name="Shape 19"/>
           <p:cNvSpPr/>
           <p:nvPr/>
         </p:nvSpPr>
         <p:spPr>
           <a:xfrm>
-            <a:off x="502920" y="5120640"/>
-            <a:ext cx="11201400" cy="1051560"/>
+            <a:off x="4937760" y="2862072"/>
+            <a:ext cx="6720840" cy="1033272"/>
           </a:xfrm>
           <a:prstGeom prst="roundRect">
             <a:avLst>
-              <a:gd name="adj" fmla="val 8696"/>
+              <a:gd name="adj" fmla="val 8850"/>
+            </a:avLst>
+          </a:prstGeom>
+          <a:solidFill>
+            <a:srgbClr val="EDF1F8"/>
+          </a:solidFill>
+          <a:ln/>
+        </p:spPr>
+      </p:sp>
+      <p:sp>
+        <p:nvSpPr>
+          <p:cNvPr id="25" name="Shape 20"/>
+          <p:cNvSpPr/>
+          <p:nvPr/>
+        </p:nvSpPr>
+        <p:spPr>
+          <a:xfrm>
+            <a:off x="5138928" y="3108960"/>
+            <a:ext cx="960120" cy="530352"/>
+          </a:xfrm>
+          <a:prstGeom prst="roundRect">
+            <a:avLst>
+              <a:gd name="adj" fmla="val 13793"/>
             </a:avLst>
           </a:prstGeom>
           <a:solidFill>
@@ -9227,74 +9455,191 @@
       </p:sp>
       <p:sp>
         <p:nvSpPr>
-          <p:cNvPr id="27" name="Shape 21"/>
+          <p:cNvPr id="26" name="Text 21"/>
+          <p:cNvSpPr txBox="1"/>
+          <p:nvPr/>
+        </p:nvSpPr>
+        <p:spPr>
+          <a:xfrm>
+            <a:off x="5138928" y="3108960"/>
+            <a:ext cx="960120" cy="530352"/>
+          </a:xfrm>
+          <a:prstGeom prst="rect">
+            <a:avLst/>
+          </a:prstGeom>
+          <a:noFill/>
+          <a:ln/>
+        </p:spPr>
+        <p:txBody>
+          <a:bodyPr wrap="square" lIns="0" tIns="0" rIns="0" bIns="0" rtlCol="0" anchor="ctr"/>
+          <a:lstStyle/>
+          <a:p>
+            <a:pPr algn="ctr" indent="0" marL="0">
+              <a:buNone/>
+            </a:pPr>
+            <a:r>
+              <a:rPr lang="en-US" sz="1150" b="1" dirty="0">
+                <a:solidFill>
+                  <a:srgbClr val="C9A227"/>
+                </a:solidFill>
+                <a:latin typeface="Calibri" pitchFamily="34" charset="0"/>
+                <a:ea typeface="Calibri" pitchFamily="34" charset="-122"/>
+                <a:cs typeface="Calibri" pitchFamily="34" charset="-120"/>
+              </a:rPr>
+              <a:t>SEP 13</a:t>
+            </a:r>
+            <a:endParaRPr lang="en-US" sz="1150" dirty="0"/>
+          </a:p>
+        </p:txBody>
+      </p:sp>
+      <p:sp>
+        <p:nvSpPr>
+          <p:cNvPr id="27" name="Text 22"/>
+          <p:cNvSpPr txBox="1"/>
+          <p:nvPr/>
+        </p:nvSpPr>
+        <p:spPr>
+          <a:xfrm>
+            <a:off x="6309360" y="2990088"/>
+            <a:ext cx="5212080" cy="329184"/>
+          </a:xfrm>
+          <a:prstGeom prst="rect">
+            <a:avLst/>
+          </a:prstGeom>
+          <a:noFill/>
+          <a:ln/>
+        </p:spPr>
+        <p:txBody>
+          <a:bodyPr wrap="square" lIns="0" tIns="0" rIns="0" bIns="0" rtlCol="0" anchor="ctr"/>
+          <a:lstStyle/>
+          <a:p>
+            <a:pPr indent="0" marL="0">
+              <a:buNone/>
+            </a:pPr>
+            <a:r>
+              <a:rPr lang="en-US" sz="1450" b="1" dirty="0">
+                <a:solidFill>
+                  <a:srgbClr val="1B2A52"/>
+                </a:solidFill>
+                <a:latin typeface="Calibri" pitchFamily="34" charset="0"/>
+                <a:ea typeface="Calibri" pitchFamily="34" charset="-122"/>
+                <a:cs typeface="Calibri" pitchFamily="34" charset="-120"/>
+              </a:rPr>
+              <a:t>The restoration of the priesthood</a:t>
+            </a:r>
+            <a:endParaRPr lang="en-US" sz="1450" dirty="0"/>
+          </a:p>
+        </p:txBody>
+      </p:sp>
+      <p:sp>
+        <p:nvSpPr>
+          <p:cNvPr id="28" name="Text 23"/>
+          <p:cNvSpPr txBox="1"/>
+          <p:nvPr/>
+        </p:nvSpPr>
+        <p:spPr>
+          <a:xfrm>
+            <a:off x="6309360" y="3319272"/>
+            <a:ext cx="5257800" cy="512064"/>
+          </a:xfrm>
+          <a:prstGeom prst="rect">
+            <a:avLst/>
+          </a:prstGeom>
+          <a:noFill/>
+          <a:ln/>
+        </p:spPr>
+        <p:txBody>
+          <a:bodyPr wrap="square" lIns="0" tIns="0" rIns="0" bIns="0" rtlCol="0" anchor="t"/>
+          <a:lstStyle/>
+          <a:p>
+            <a:pPr indent="0" marL="0">
+              <a:buNone/>
+            </a:pPr>
+            <a:r>
+              <a:rPr lang="en-US" sz="1050" dirty="0">
+                <a:solidFill>
+                  <a:srgbClr val="5C6575"/>
+                </a:solidFill>
+                <a:latin typeface="Calibri" pitchFamily="34" charset="0"/>
+                <a:ea typeface="Calibri" pitchFamily="34" charset="-122"/>
+                <a:cs typeface="Calibri" pitchFamily="34" charset="-120"/>
+              </a:rPr>
+              <a:t>How the Savior blesses us through both priesthoods — D&amp;C 13; 107:18–20; 84:20–21.</a:t>
+            </a:r>
+            <a:endParaRPr lang="en-US" sz="1050" dirty="0"/>
+          </a:p>
+        </p:txBody>
+      </p:sp>
+      <p:sp>
+        <p:nvSpPr>
+          <p:cNvPr id="29" name="Shape 24"/>
           <p:cNvSpPr/>
           <p:nvPr/>
         </p:nvSpPr>
         <p:spPr>
           <a:xfrm>
-            <a:off x="777240" y="5349240"/>
-            <a:ext cx="566928" cy="566928"/>
-          </a:xfrm>
-          <a:prstGeom prst="ellipse">
-            <a:avLst/>
+            <a:off x="4937760" y="4032504"/>
+            <a:ext cx="6720840" cy="1033272"/>
+          </a:xfrm>
+          <a:prstGeom prst="roundRect">
+            <a:avLst>
+              <a:gd name="adj" fmla="val 8850"/>
+            </a:avLst>
           </a:prstGeom>
           <a:solidFill>
-            <a:srgbClr val="C9A227"/>
+            <a:srgbClr val="EDF1F8"/>
           </a:solidFill>
           <a:ln/>
         </p:spPr>
       </p:sp>
-      <p:pic>
-        <p:nvPicPr>
-          <p:cNvPr id="28" name="Image 4" descr="preencoded.png">    </p:cNvPr>
-          <p:cNvPicPr>
-            <a:picLocks noChangeAspect="1"/>
-          </p:cNvPicPr>
-          <p:nvPr/>
-        </p:nvPicPr>
-        <p:blipFill>
-          <a:blip r:embed="rId5"/>
-          <a:stretch>
-            <a:fillRect/>
-          </a:stretch>
-        </p:blipFill>
-        <p:spPr>
-          <a:xfrm>
-            <a:off x="930311" y="5502311"/>
-            <a:ext cx="260787" cy="260787"/>
-          </a:xfrm>
-          <a:prstGeom prst="rect">
-            <a:avLst/>
-          </a:prstGeom>
-        </p:spPr>
-      </p:pic>
-      <p:sp>
-        <p:nvSpPr>
-          <p:cNvPr id="29" name="Text 22"/>
-          <p:cNvSpPr txBox="1"/>
-          <p:nvPr/>
-        </p:nvSpPr>
-        <p:spPr>
-          <a:xfrm>
-            <a:off x="1554480" y="5321808"/>
-            <a:ext cx="9966960" cy="685800"/>
-          </a:xfrm>
-          <a:prstGeom prst="rect">
-            <a:avLst/>
-          </a:prstGeom>
-          <a:noFill/>
-          <a:ln/>
-        </p:spPr>
-        <p:txBody>
-          <a:bodyPr wrap="square" lIns="0" tIns="0" rIns="0" bIns="0" rtlCol="0" anchor="ctr"/>
-          <a:lstStyle/>
-          <a:p>
-            <a:pPr indent="0" marL="0">
-              <a:buNone/>
-            </a:pPr>
-            <a:r>
-              <a:rPr lang="en-US" sz="1350" b="1" dirty="0">
+      <p:sp>
+        <p:nvSpPr>
+          <p:cNvPr id="30" name="Shape 25"/>
+          <p:cNvSpPr/>
+          <p:nvPr/>
+        </p:nvSpPr>
+        <p:spPr>
+          <a:xfrm>
+            <a:off x="5138928" y="4279392"/>
+            <a:ext cx="960120" cy="530352"/>
+          </a:xfrm>
+          <a:prstGeom prst="roundRect">
+            <a:avLst>
+              <a:gd name="adj" fmla="val 13793"/>
+            </a:avLst>
+          </a:prstGeom>
+          <a:solidFill>
+            <a:srgbClr val="1B2A52"/>
+          </a:solidFill>
+          <a:ln/>
+        </p:spPr>
+      </p:sp>
+      <p:sp>
+        <p:nvSpPr>
+          <p:cNvPr id="31" name="Text 26"/>
+          <p:cNvSpPr txBox="1"/>
+          <p:nvPr/>
+        </p:nvSpPr>
+        <p:spPr>
+          <a:xfrm>
+            <a:off x="5138928" y="4279392"/>
+            <a:ext cx="960120" cy="530352"/>
+          </a:xfrm>
+          <a:prstGeom prst="rect">
+            <a:avLst/>
+          </a:prstGeom>
+          <a:noFill/>
+          <a:ln/>
+        </p:spPr>
+        <p:txBody>
+          <a:bodyPr wrap="square" lIns="0" tIns="0" rIns="0" bIns="0" rtlCol="0" anchor="ctr"/>
+          <a:lstStyle/>
+          <a:p>
+            <a:pPr algn="ctr" indent="0" marL="0">
+              <a:buNone/>
+            </a:pPr>
+            <a:r>
+              <a:rPr lang="en-US" sz="1150" b="1" dirty="0">
                 <a:solidFill>
                   <a:srgbClr val="C9A227"/>
                 </a:solidFill>
@@ -9302,23 +9647,248 @@
                 <a:ea typeface="Calibri" pitchFamily="34" charset="-122"/>
                 <a:cs typeface="Calibri" pitchFamily="34" charset="-120"/>
               </a:rPr>
-              <a:t>For parents: </a:t>
-            </a:r>
-            <a:pPr indent="0" marL="0">
-              <a:buNone/>
-            </a:pPr>
-            <a:r>
-              <a:rPr lang="en-US" sz="1350" dirty="0">
-                <a:solidFill>
-                  <a:srgbClr val="FFFFFF"/>
-                </a:solidFill>
-                <a:latin typeface="Calibri" pitchFamily="34" charset="0"/>
-                <a:ea typeface="Calibri" pitchFamily="34" charset="-122"/>
-                <a:cs typeface="Calibri" pitchFamily="34" charset="-120"/>
-              </a:rPr>
-              <a:t>the same guide, magazine, and lessons at home make Sunday classes an easy, natural topic for family conversation all month long.</a:t>
-            </a:r>
-            <a:endParaRPr lang="en-US" sz="1350" dirty="0"/>
+              <a:t>SEP 20</a:t>
+            </a:r>
+            <a:endParaRPr lang="en-US" sz="1150" dirty="0"/>
+          </a:p>
+        </p:txBody>
+      </p:sp>
+      <p:sp>
+        <p:nvSpPr>
+          <p:cNvPr id="32" name="Text 27"/>
+          <p:cNvSpPr txBox="1"/>
+          <p:nvPr/>
+        </p:nvSpPr>
+        <p:spPr>
+          <a:xfrm>
+            <a:off x="6309360" y="4160520"/>
+            <a:ext cx="5212080" cy="329184"/>
+          </a:xfrm>
+          <a:prstGeom prst="rect">
+            <a:avLst/>
+          </a:prstGeom>
+          <a:noFill/>
+          <a:ln/>
+        </p:spPr>
+        <p:txBody>
+          <a:bodyPr wrap="square" lIns="0" tIns="0" rIns="0" bIns="0" rtlCol="0" anchor="ctr"/>
+          <a:lstStyle/>
+          <a:p>
+            <a:pPr indent="0" marL="0">
+              <a:buNone/>
+            </a:pPr>
+            <a:r>
+              <a:rPr lang="en-US" sz="1450" b="1" dirty="0">
+                <a:solidFill>
+                  <a:srgbClr val="1B2A52"/>
+                </a:solidFill>
+                <a:latin typeface="Calibri" pitchFamily="34" charset="0"/>
+                <a:ea typeface="Calibri" pitchFamily="34" charset="-122"/>
+                <a:cs typeface="Calibri" pitchFamily="34" charset="-120"/>
+              </a:rPr>
+              <a:t>Priesthood keys</a:t>
+            </a:r>
+            <a:endParaRPr lang="en-US" sz="1450" dirty="0"/>
+          </a:p>
+        </p:txBody>
+      </p:sp>
+      <p:sp>
+        <p:nvSpPr>
+          <p:cNvPr id="33" name="Text 28"/>
+          <p:cNvSpPr txBox="1"/>
+          <p:nvPr/>
+        </p:nvSpPr>
+        <p:spPr>
+          <a:xfrm>
+            <a:off x="6309360" y="4489704"/>
+            <a:ext cx="5257800" cy="512064"/>
+          </a:xfrm>
+          <a:prstGeom prst="rect">
+            <a:avLst/>
+          </a:prstGeom>
+          <a:noFill/>
+          <a:ln/>
+        </p:spPr>
+        <p:txBody>
+          <a:bodyPr wrap="square" lIns="0" tIns="0" rIns="0" bIns="0" rtlCol="0" anchor="t"/>
+          <a:lstStyle/>
+          <a:p>
+            <a:pPr indent="0" marL="0">
+              <a:buNone/>
+            </a:pPr>
+            <a:r>
+              <a:rPr lang="en-US" sz="1050" dirty="0">
+                <a:solidFill>
+                  <a:srgbClr val="5C6575"/>
+                </a:solidFill>
+                <a:latin typeface="Calibri" pitchFamily="34" charset="0"/>
+                <a:ea typeface="Calibri" pitchFamily="34" charset="-122"/>
+                <a:cs typeface="Calibri" pitchFamily="34" charset="-120"/>
+              </a:rPr>
+              <a:t>What keys are and what they unlock — D&amp;C 13; 27:12–13; 110:11–16.</a:t>
+            </a:r>
+            <a:endParaRPr lang="en-US" sz="1050" dirty="0"/>
+          </a:p>
+        </p:txBody>
+      </p:sp>
+      <p:sp>
+        <p:nvSpPr>
+          <p:cNvPr id="34" name="Shape 29"/>
+          <p:cNvSpPr/>
+          <p:nvPr/>
+        </p:nvSpPr>
+        <p:spPr>
+          <a:xfrm>
+            <a:off x="4937760" y="5202936"/>
+            <a:ext cx="6720840" cy="1033272"/>
+          </a:xfrm>
+          <a:prstGeom prst="roundRect">
+            <a:avLst>
+              <a:gd name="adj" fmla="val 8850"/>
+            </a:avLst>
+          </a:prstGeom>
+          <a:solidFill>
+            <a:srgbClr val="EDF1F8"/>
+          </a:solidFill>
+          <a:ln/>
+        </p:spPr>
+      </p:sp>
+      <p:sp>
+        <p:nvSpPr>
+          <p:cNvPr id="35" name="Shape 30"/>
+          <p:cNvSpPr/>
+          <p:nvPr/>
+        </p:nvSpPr>
+        <p:spPr>
+          <a:xfrm>
+            <a:off x="5138928" y="5449824"/>
+            <a:ext cx="960120" cy="530352"/>
+          </a:xfrm>
+          <a:prstGeom prst="roundRect">
+            <a:avLst>
+              <a:gd name="adj" fmla="val 13793"/>
+            </a:avLst>
+          </a:prstGeom>
+          <a:solidFill>
+            <a:srgbClr val="1B2A52"/>
+          </a:solidFill>
+          <a:ln/>
+        </p:spPr>
+      </p:sp>
+      <p:sp>
+        <p:nvSpPr>
+          <p:cNvPr id="36" name="Text 31"/>
+          <p:cNvSpPr txBox="1"/>
+          <p:nvPr/>
+        </p:nvSpPr>
+        <p:spPr>
+          <a:xfrm>
+            <a:off x="5138928" y="5449824"/>
+            <a:ext cx="960120" cy="530352"/>
+          </a:xfrm>
+          <a:prstGeom prst="rect">
+            <a:avLst/>
+          </a:prstGeom>
+          <a:noFill/>
+          <a:ln/>
+        </p:spPr>
+        <p:txBody>
+          <a:bodyPr wrap="square" lIns="0" tIns="0" rIns="0" bIns="0" rtlCol="0" anchor="ctr"/>
+          <a:lstStyle/>
+          <a:p>
+            <a:pPr algn="ctr" indent="0" marL="0">
+              <a:buNone/>
+            </a:pPr>
+            <a:r>
+              <a:rPr lang="en-US" sz="1150" b="1" dirty="0">
+                <a:solidFill>
+                  <a:srgbClr val="C9A227"/>
+                </a:solidFill>
+                <a:latin typeface="Calibri" pitchFamily="34" charset="0"/>
+                <a:ea typeface="Calibri" pitchFamily="34" charset="-122"/>
+                <a:cs typeface="Calibri" pitchFamily="34" charset="-120"/>
+              </a:rPr>
+              <a:t>SEP 27</a:t>
+            </a:r>
+            <a:endParaRPr lang="en-US" sz="1150" dirty="0"/>
+          </a:p>
+        </p:txBody>
+      </p:sp>
+      <p:sp>
+        <p:nvSpPr>
+          <p:cNvPr id="37" name="Text 32"/>
+          <p:cNvSpPr txBox="1"/>
+          <p:nvPr/>
+        </p:nvSpPr>
+        <p:spPr>
+          <a:xfrm>
+            <a:off x="6309360" y="5330952"/>
+            <a:ext cx="5212080" cy="329184"/>
+          </a:xfrm>
+          <a:prstGeom prst="rect">
+            <a:avLst/>
+          </a:prstGeom>
+          <a:noFill/>
+          <a:ln/>
+        </p:spPr>
+        <p:txBody>
+          <a:bodyPr wrap="square" lIns="0" tIns="0" rIns="0" bIns="0" rtlCol="0" anchor="ctr"/>
+          <a:lstStyle/>
+          <a:p>
+            <a:pPr indent="0" marL="0">
+              <a:buNone/>
+            </a:pPr>
+            <a:r>
+              <a:rPr lang="en-US" sz="1450" b="1" dirty="0">
+                <a:solidFill>
+                  <a:srgbClr val="1B2A52"/>
+                </a:solidFill>
+                <a:latin typeface="Calibri" pitchFamily="34" charset="0"/>
+                <a:ea typeface="Calibri" pitchFamily="34" charset="-122"/>
+                <a:cs typeface="Calibri" pitchFamily="34" charset="-120"/>
+              </a:rPr>
+              <a:t>Covenant daughters and sons of God</a:t>
+            </a:r>
+            <a:endParaRPr lang="en-US" sz="1450" dirty="0"/>
+          </a:p>
+        </p:txBody>
+      </p:sp>
+      <p:sp>
+        <p:nvSpPr>
+          <p:cNvPr id="38" name="Text 33"/>
+          <p:cNvSpPr txBox="1"/>
+          <p:nvPr/>
+        </p:nvSpPr>
+        <p:spPr>
+          <a:xfrm>
+            <a:off x="6309360" y="5660136"/>
+            <a:ext cx="5257800" cy="512064"/>
+          </a:xfrm>
+          <a:prstGeom prst="rect">
+            <a:avLst/>
+          </a:prstGeom>
+          <a:noFill/>
+          <a:ln/>
+        </p:spPr>
+        <p:txBody>
+          <a:bodyPr wrap="square" lIns="0" tIns="0" rIns="0" bIns="0" rtlCol="0" anchor="t"/>
+          <a:lstStyle/>
+          <a:p>
+            <a:pPr indent="0" marL="0">
+              <a:buNone/>
+            </a:pPr>
+            <a:r>
+              <a:rPr lang="en-US" sz="1050" dirty="0">
+                <a:solidFill>
+                  <a:srgbClr val="5C6575"/>
+                </a:solidFill>
+                <a:latin typeface="Calibri" pitchFamily="34" charset="0"/>
+                <a:ea typeface="Calibri" pitchFamily="34" charset="-122"/>
+                <a:cs typeface="Calibri" pitchFamily="34" charset="-120"/>
+              </a:rPr>
+              <a:t>YW learn from Emma Smith (D&amp;C 25); quorums from Joseph Smith (JS—History 1:66–73).</a:t>
+            </a:r>
+            <a:endParaRPr lang="en-US" sz="1050" dirty="0"/>
           </a:p>
         </p:txBody>
       </p:sp>
@@ -9336,7 +9906,7 @@
     <p:bg>
       <p:bgPr>
         <a:solidFill>
-          <a:srgbClr val="1B2A52"/>
+          <a:srgbClr val="FFFFFF"/>
         </a:solidFill>
       </p:bgPr>
     </p:bg>
@@ -9356,51 +9926,7 @@
       </p:grpSpPr>
       <p:sp>
         <p:nvSpPr>
-          <p:cNvPr id="2" name="Shape 0"/>
-          <p:cNvSpPr/>
-          <p:nvPr/>
-        </p:nvSpPr>
-        <p:spPr>
-          <a:xfrm>
-            <a:off x="9052560" y="-1920240"/>
-            <a:ext cx="4937760" cy="4937760"/>
-          </a:xfrm>
-          <a:prstGeom prst="ellipse">
-            <a:avLst/>
-          </a:prstGeom>
-          <a:ln w="19050">
-            <a:solidFill>
-              <a:srgbClr val="31437A"/>
-            </a:solidFill>
-            <a:prstDash val="solid"/>
-          </a:ln>
-        </p:spPr>
-      </p:sp>
-      <p:sp>
-        <p:nvSpPr>
-          <p:cNvPr id="3" name="Shape 1"/>
-          <p:cNvSpPr/>
-          <p:nvPr/>
-        </p:nvSpPr>
-        <p:spPr>
-          <a:xfrm>
-            <a:off x="-1463040" y="4572000"/>
-            <a:ext cx="4023360" cy="4023360"/>
-          </a:xfrm>
-          <a:prstGeom prst="ellipse">
-            <a:avLst/>
-          </a:prstGeom>
-          <a:ln w="19050">
-            <a:solidFill>
-              <a:srgbClr val="31437A"/>
-            </a:solidFill>
-            <a:prstDash val="solid"/>
-          </a:ln>
-        </p:spPr>
-      </p:sp>
-      <p:sp>
-        <p:nvSpPr>
-          <p:cNvPr id="4" name="Text 2"/>
+          <p:cNvPr id="2" name="Text 0"/>
           <p:cNvSpPr txBox="1"/>
           <p:nvPr/>
         </p:nvSpPr>
@@ -9425,13 +9951,13 @@
             <a:r>
               <a:rPr lang="en-US" sz="1200" b="1" spc="300" kern="0" dirty="0">
                 <a:solidFill>
-                  <a:srgbClr val="C9A227"/>
-                </a:solidFill>
-                <a:latin typeface="Calibri" pitchFamily="34" charset="0"/>
-                <a:ea typeface="Calibri" pitchFamily="34" charset="-122"/>
-                <a:cs typeface="Calibri" pitchFamily="34" charset="-120"/>
-              </a:rPr>
-              <a:t>WATCH TOGETHER</a:t>
+                  <a:srgbClr val="8F7115"/>
+                </a:solidFill>
+                <a:latin typeface="Calibri" pitchFamily="34" charset="0"/>
+                <a:ea typeface="Calibri" pitchFamily="34" charset="-122"/>
+                <a:cs typeface="Calibri" pitchFamily="34" charset="-120"/>
+              </a:rPr>
+              <a:t>RESOURCES</a:t>
             </a:r>
             <a:endParaRPr lang="en-US" sz="1200" dirty="0"/>
           </a:p>
@@ -9439,7 +9965,7 @@
       </p:sp>
       <p:sp>
         <p:nvSpPr>
-          <p:cNvPr id="5" name="Text 3"/>
+          <p:cNvPr id="3" name="Text 1"/>
           <p:cNvSpPr txBox="1"/>
           <p:nvPr/>
         </p:nvSpPr>
@@ -9464,13 +9990,13 @@
             <a:r>
               <a:rPr lang="en-US" sz="3400" b="1" dirty="0">
                 <a:solidFill>
-                  <a:srgbClr val="FFFFFF"/>
+                  <a:srgbClr val="1B2A52"/>
                 </a:solidFill>
                 <a:latin typeface="Cambria" pitchFamily="34" charset="0"/>
                 <a:ea typeface="Cambria" pitchFamily="34" charset="-122"/>
                 <a:cs typeface="Cambria" pitchFamily="34" charset="-120"/>
               </a:rPr>
-              <a:t>The Instructional Video</a:t>
+              <a:t>Where to Find Everything</a:t>
             </a:r>
             <a:endParaRPr lang="en-US" sz="3400" dirty="0"/>
           </a:p>
@@ -9478,27 +10004,49 @@
       </p:sp>
       <p:sp>
         <p:nvSpPr>
-          <p:cNvPr id="6" name="Shape 4"/>
+          <p:cNvPr id="4" name="Shape 2"/>
           <p:cNvSpPr/>
           <p:nvPr/>
         </p:nvSpPr>
         <p:spPr>
           <a:xfrm>
-            <a:off x="1325880" y="2651760"/>
-            <a:ext cx="1737360" cy="1737360"/>
+            <a:off x="502920" y="1783080"/>
+            <a:ext cx="2724912" cy="3017520"/>
+          </a:xfrm>
+          <a:prstGeom prst="roundRect">
+            <a:avLst>
+              <a:gd name="adj" fmla="val 4027"/>
+            </a:avLst>
+          </a:prstGeom>
+          <a:solidFill>
+            <a:srgbClr val="EDF1F8"/>
+          </a:solidFill>
+          <a:ln/>
+        </p:spPr>
+      </p:sp>
+      <p:sp>
+        <p:nvSpPr>
+          <p:cNvPr id="5" name="Shape 3"/>
+          <p:cNvSpPr/>
+          <p:nvPr/>
+        </p:nvSpPr>
+        <p:spPr>
+          <a:xfrm>
+            <a:off x="777240" y="2057400"/>
+            <a:ext cx="566928" cy="566928"/>
           </a:xfrm>
           <a:prstGeom prst="ellipse">
             <a:avLst/>
           </a:prstGeom>
           <a:solidFill>
-            <a:srgbClr val="C9A227"/>
+            <a:srgbClr val="1B2A52"/>
           </a:solidFill>
           <a:ln/>
         </p:spPr>
       </p:sp>
       <p:pic>
         <p:nvPicPr>
-          <p:cNvPr id="7" name="Image 0" descr="preencoded.png">    </p:cNvPr>
+          <p:cNvPr id="6" name="Image 0" descr="preencoded.png">    </p:cNvPr>
           <p:cNvPicPr>
             <a:picLocks noChangeAspect="1"/>
           </p:cNvPicPr>
@@ -9512,8 +10060,8 @@
         </p:blipFill>
         <p:spPr>
           <a:xfrm>
-            <a:off x="1938528" y="3200400"/>
-            <a:ext cx="621792" cy="621792"/>
+            <a:off x="930311" y="2210471"/>
+            <a:ext cx="260787" cy="260787"/>
           </a:xfrm>
           <a:prstGeom prst="rect">
             <a:avLst/>
@@ -9522,30 +10070,698 @@
       </p:pic>
       <p:sp>
         <p:nvSpPr>
+          <p:cNvPr id="7" name="Text 4"/>
+          <p:cNvSpPr txBox="1"/>
+          <p:nvPr/>
+        </p:nvSpPr>
+        <p:spPr>
+          <a:xfrm>
+            <a:off x="777240" y="2834640"/>
+            <a:ext cx="2212848" cy="640080"/>
+          </a:xfrm>
+          <a:prstGeom prst="rect">
+            <a:avLst/>
+          </a:prstGeom>
+          <a:noFill/>
+          <a:ln/>
+        </p:spPr>
+        <p:txBody>
+          <a:bodyPr wrap="square" lIns="0" tIns="0" rIns="0" bIns="0" rtlCol="0" anchor="ctr"/>
+          <a:lstStyle/>
+          <a:p>
+            <a:pPr indent="0" marL="0">
+              <a:buNone/>
+            </a:pPr>
+            <a:r>
+              <a:rPr lang="en-US" sz="1500" b="1" dirty="0">
+                <a:solidFill>
+                  <a:srgbClr val="1B2A52"/>
+                </a:solidFill>
+                <a:latin typeface="Calibri" pitchFamily="34" charset="0"/>
+                <a:ea typeface="Calibri" pitchFamily="34" charset="-122"/>
+                <a:cs typeface="Calibri" pitchFamily="34" charset="-120"/>
+              </a:rPr>
+              <a:t>FSY Guide</a:t>
+            </a:r>
+            <a:endParaRPr lang="en-US" sz="1500" dirty="0"/>
+          </a:p>
+        </p:txBody>
+      </p:sp>
+      <p:sp>
+        <p:nvSpPr>
           <p:cNvPr id="8" name="Text 5"/>
           <p:cNvSpPr txBox="1"/>
           <p:nvPr/>
         </p:nvSpPr>
         <p:spPr>
           <a:xfrm>
-            <a:off x="3657600" y="2514600"/>
-            <a:ext cx="7680960" cy="868680"/>
-          </a:xfrm>
-          <a:prstGeom prst="rect">
-            <a:avLst/>
-          </a:prstGeom>
-          <a:noFill/>
-          <a:ln/>
-        </p:spPr>
-        <p:txBody>
-          <a:bodyPr wrap="square" lIns="0" tIns="0" rIns="0" bIns="0" rtlCol="0" anchor="ctr"/>
-          <a:lstStyle/>
-          <a:p>
-            <a:pPr indent="0" marL="0">
-              <a:buNone/>
-            </a:pPr>
-            <a:r>
-              <a:rPr lang="en-US" sz="1650" dirty="0">
+            <a:off x="777240" y="3383280"/>
+            <a:ext cx="2212848" cy="1051560"/>
+          </a:xfrm>
+          <a:prstGeom prst="rect">
+            <a:avLst/>
+          </a:prstGeom>
+          <a:noFill/>
+          <a:ln/>
+        </p:spPr>
+        <p:txBody>
+          <a:bodyPr wrap="square" lIns="0" tIns="0" rIns="0" bIns="0" rtlCol="0" anchor="t"/>
+          <a:lstStyle/>
+          <a:p>
+            <a:pPr indent="0" marL="0">
+              <a:buNone/>
+            </a:pPr>
+            <a:r>
+              <a:rPr lang="en-US" sz="1100" dirty="0">
+                <a:solidFill>
+                  <a:srgbClr val="5C6575"/>
+                </a:solidFill>
+                <a:latin typeface="Calibri" pitchFamily="34" charset="0"/>
+                <a:ea typeface="Calibri" pitchFamily="34" charset="-122"/>
+                <a:cs typeface="Calibri" pitchFamily="34" charset="-120"/>
+              </a:rPr>
+              <a:t>For the Strength of Youth: A Guide for Making Choices — in the Gospel Library app and in print.</a:t>
+            </a:r>
+            <a:endParaRPr lang="en-US" sz="1100" dirty="0"/>
+          </a:p>
+        </p:txBody>
+      </p:sp>
+      <p:sp>
+        <p:nvSpPr>
+          <p:cNvPr id="9" name="Shape 6"/>
+          <p:cNvSpPr/>
+          <p:nvPr/>
+        </p:nvSpPr>
+        <p:spPr>
+          <a:xfrm>
+            <a:off x="3328416" y="1783080"/>
+            <a:ext cx="2724912" cy="3017520"/>
+          </a:xfrm>
+          <a:prstGeom prst="roundRect">
+            <a:avLst>
+              <a:gd name="adj" fmla="val 4027"/>
+            </a:avLst>
+          </a:prstGeom>
+          <a:solidFill>
+            <a:srgbClr val="EDF1F8"/>
+          </a:solidFill>
+          <a:ln/>
+        </p:spPr>
+      </p:sp>
+      <p:sp>
+        <p:nvSpPr>
+          <p:cNvPr id="10" name="Shape 7"/>
+          <p:cNvSpPr/>
+          <p:nvPr/>
+        </p:nvSpPr>
+        <p:spPr>
+          <a:xfrm>
+            <a:off x="3602736" y="2057400"/>
+            <a:ext cx="566928" cy="566928"/>
+          </a:xfrm>
+          <a:prstGeom prst="ellipse">
+            <a:avLst/>
+          </a:prstGeom>
+          <a:solidFill>
+            <a:srgbClr val="1B2A52"/>
+          </a:solidFill>
+          <a:ln/>
+        </p:spPr>
+      </p:sp>
+      <p:pic>
+        <p:nvPicPr>
+          <p:cNvPr id="11" name="Image 1" descr="preencoded.png">    </p:cNvPr>
+          <p:cNvPicPr>
+            <a:picLocks noChangeAspect="1"/>
+          </p:cNvPicPr>
+          <p:nvPr/>
+        </p:nvPicPr>
+        <p:blipFill>
+          <a:blip r:embed="rId2"/>
+          <a:stretch>
+            <a:fillRect/>
+          </a:stretch>
+        </p:blipFill>
+        <p:spPr>
+          <a:xfrm>
+            <a:off x="3755807" y="2210471"/>
+            <a:ext cx="260787" cy="260787"/>
+          </a:xfrm>
+          <a:prstGeom prst="rect">
+            <a:avLst/>
+          </a:prstGeom>
+        </p:spPr>
+      </p:pic>
+      <p:sp>
+        <p:nvSpPr>
+          <p:cNvPr id="12" name="Text 8"/>
+          <p:cNvSpPr txBox="1"/>
+          <p:nvPr/>
+        </p:nvSpPr>
+        <p:spPr>
+          <a:xfrm>
+            <a:off x="3602736" y="2834640"/>
+            <a:ext cx="2212848" cy="640080"/>
+          </a:xfrm>
+          <a:prstGeom prst="rect">
+            <a:avLst/>
+          </a:prstGeom>
+          <a:noFill/>
+          <a:ln/>
+        </p:spPr>
+        <p:txBody>
+          <a:bodyPr wrap="square" lIns="0" tIns="0" rIns="0" bIns="0" rtlCol="0" anchor="ctr"/>
+          <a:lstStyle/>
+          <a:p>
+            <a:pPr indent="0" marL="0">
+              <a:buNone/>
+            </a:pPr>
+            <a:r>
+              <a:rPr lang="en-US" sz="1500" b="1" dirty="0">
+                <a:solidFill>
+                  <a:srgbClr val="1B2A52"/>
+                </a:solidFill>
+                <a:latin typeface="Calibri" pitchFamily="34" charset="0"/>
+                <a:ea typeface="Calibri" pitchFamily="34" charset="-122"/>
+                <a:cs typeface="Calibri" pitchFamily="34" charset="-120"/>
+              </a:rPr>
+              <a:t>FSY Magazine</a:t>
+            </a:r>
+            <a:endParaRPr lang="en-US" sz="1500" dirty="0"/>
+          </a:p>
+        </p:txBody>
+      </p:sp>
+      <p:sp>
+        <p:nvSpPr>
+          <p:cNvPr id="13" name="Text 9"/>
+          <p:cNvSpPr txBox="1"/>
+          <p:nvPr/>
+        </p:nvSpPr>
+        <p:spPr>
+          <a:xfrm>
+            <a:off x="3602736" y="3383280"/>
+            <a:ext cx="2212848" cy="1051560"/>
+          </a:xfrm>
+          <a:prstGeom prst="rect">
+            <a:avLst/>
+          </a:prstGeom>
+          <a:noFill/>
+          <a:ln/>
+        </p:spPr>
+        <p:txBody>
+          <a:bodyPr wrap="square" lIns="0" tIns="0" rIns="0" bIns="0" rtlCol="0" anchor="t"/>
+          <a:lstStyle/>
+          <a:p>
+            <a:pPr indent="0" marL="0">
+              <a:buNone/>
+            </a:pPr>
+            <a:r>
+              <a:rPr lang="en-US" sz="1100" dirty="0">
+                <a:solidFill>
+                  <a:srgbClr val="5C6575"/>
+                </a:solidFill>
+                <a:latin typeface="Calibri" pitchFamily="34" charset="0"/>
+                <a:ea typeface="Calibri" pitchFamily="34" charset="-122"/>
+                <a:cs typeface="Calibri" pitchFamily="34" charset="-120"/>
+              </a:rPr>
+              <a:t>Monthly stories and articles on each theme. One free print subscription per household.</a:t>
+            </a:r>
+            <a:endParaRPr lang="en-US" sz="1100" dirty="0"/>
+          </a:p>
+        </p:txBody>
+      </p:sp>
+      <p:sp>
+        <p:nvSpPr>
+          <p:cNvPr id="14" name="Text 10"/>
+          <p:cNvSpPr txBox="1"/>
+          <p:nvPr/>
+        </p:nvSpPr>
+        <p:spPr>
+          <a:xfrm>
+            <a:off x="3529584" y="4425696"/>
+            <a:ext cx="2432304" cy="274320"/>
+          </a:xfrm>
+          <a:prstGeom prst="rect">
+            <a:avLst/>
+          </a:prstGeom>
+          <a:noFill/>
+          <a:ln/>
+        </p:spPr>
+        <p:txBody>
+          <a:bodyPr wrap="square" lIns="0" tIns="0" rIns="0" bIns="0" rtlCol="0" anchor="ctr"/>
+          <a:lstStyle/>
+          <a:p>
+            <a:pPr indent="0" marL="0">
+              <a:buNone/>
+            </a:pPr>
+            <a:r>
+              <a:rPr lang="en-US" sz="870" b="1" dirty="0">
+                <a:solidFill>
+                  <a:srgbClr val="1B2A52"/>
+                </a:solidFill>
+                <a:latin typeface="Calibri" pitchFamily="34" charset="0"/>
+                <a:ea typeface="Calibri" pitchFamily="34" charset="-122"/>
+                <a:cs typeface="Calibri" pitchFamily="34" charset="-120"/>
+              </a:rPr>
+              <a:t>magazines.ChurchofJesusChrist.org</a:t>
+            </a:r>
+            <a:endParaRPr lang="en-US" sz="870" dirty="0"/>
+          </a:p>
+        </p:txBody>
+      </p:sp>
+      <p:sp>
+        <p:nvSpPr>
+          <p:cNvPr id="15" name="Shape 11"/>
+          <p:cNvSpPr/>
+          <p:nvPr/>
+        </p:nvSpPr>
+        <p:spPr>
+          <a:xfrm>
+            <a:off x="6153912" y="1783080"/>
+            <a:ext cx="2724912" cy="3017520"/>
+          </a:xfrm>
+          <a:prstGeom prst="roundRect">
+            <a:avLst>
+              <a:gd name="adj" fmla="val 4027"/>
+            </a:avLst>
+          </a:prstGeom>
+          <a:solidFill>
+            <a:srgbClr val="EDF1F8"/>
+          </a:solidFill>
+          <a:ln/>
+        </p:spPr>
+      </p:sp>
+      <p:sp>
+        <p:nvSpPr>
+          <p:cNvPr id="16" name="Shape 12"/>
+          <p:cNvSpPr/>
+          <p:nvPr/>
+        </p:nvSpPr>
+        <p:spPr>
+          <a:xfrm>
+            <a:off x="6428232" y="2057400"/>
+            <a:ext cx="566928" cy="566928"/>
+          </a:xfrm>
+          <a:prstGeom prst="ellipse">
+            <a:avLst/>
+          </a:prstGeom>
+          <a:solidFill>
+            <a:srgbClr val="1B2A52"/>
+          </a:solidFill>
+          <a:ln/>
+        </p:spPr>
+      </p:sp>
+      <p:pic>
+        <p:nvPicPr>
+          <p:cNvPr id="17" name="Image 2" descr="preencoded.png">    </p:cNvPr>
+          <p:cNvPicPr>
+            <a:picLocks noChangeAspect="1"/>
+          </p:cNvPicPr>
+          <p:nvPr/>
+        </p:nvPicPr>
+        <p:blipFill>
+          <a:blip r:embed="rId3"/>
+          <a:stretch>
+            <a:fillRect/>
+          </a:stretch>
+        </p:blipFill>
+        <p:spPr>
+          <a:xfrm>
+            <a:off x="6581303" y="2210471"/>
+            <a:ext cx="260787" cy="260787"/>
+          </a:xfrm>
+          <a:prstGeom prst="rect">
+            <a:avLst/>
+          </a:prstGeom>
+        </p:spPr>
+      </p:pic>
+      <p:sp>
+        <p:nvSpPr>
+          <p:cNvPr id="18" name="Text 13"/>
+          <p:cNvSpPr txBox="1"/>
+          <p:nvPr/>
+        </p:nvSpPr>
+        <p:spPr>
+          <a:xfrm>
+            <a:off x="6428232" y="2834640"/>
+            <a:ext cx="2212848" cy="640080"/>
+          </a:xfrm>
+          <a:prstGeom prst="rect">
+            <a:avLst/>
+          </a:prstGeom>
+          <a:noFill/>
+          <a:ln/>
+        </p:spPr>
+        <p:txBody>
+          <a:bodyPr wrap="square" lIns="0" tIns="0" rIns="0" bIns="0" rtlCol="0" anchor="ctr"/>
+          <a:lstStyle/>
+          <a:p>
+            <a:pPr indent="0" marL="0">
+              <a:buNone/>
+            </a:pPr>
+            <a:r>
+              <a:rPr lang="en-US" sz="1500" b="1" dirty="0">
+                <a:solidFill>
+                  <a:srgbClr val="1B2A52"/>
+                </a:solidFill>
+                <a:latin typeface="Calibri" pitchFamily="34" charset="0"/>
+                <a:ea typeface="Calibri" pitchFamily="34" charset="-122"/>
+                <a:cs typeface="Calibri" pitchFamily="34" charset="-120"/>
+              </a:rPr>
+              <a:t>Gospel Library</a:t>
+            </a:r>
+            <a:endParaRPr lang="en-US" sz="1500" dirty="0"/>
+          </a:p>
+        </p:txBody>
+      </p:sp>
+      <p:sp>
+        <p:nvSpPr>
+          <p:cNvPr id="19" name="Text 14"/>
+          <p:cNvSpPr txBox="1"/>
+          <p:nvPr/>
+        </p:nvSpPr>
+        <p:spPr>
+          <a:xfrm>
+            <a:off x="6428232" y="3383280"/>
+            <a:ext cx="2212848" cy="1051560"/>
+          </a:xfrm>
+          <a:prstGeom prst="rect">
+            <a:avLst/>
+          </a:prstGeom>
+          <a:noFill/>
+          <a:ln/>
+        </p:spPr>
+        <p:txBody>
+          <a:bodyPr wrap="square" lIns="0" tIns="0" rIns="0" bIns="0" rtlCol="0" anchor="t"/>
+          <a:lstStyle/>
+          <a:p>
+            <a:pPr indent="0" marL="0">
+              <a:buNone/>
+            </a:pPr>
+            <a:r>
+              <a:rPr lang="en-US" sz="1100" dirty="0">
+                <a:solidFill>
+                  <a:srgbClr val="5C6575"/>
+                </a:solidFill>
+                <a:latin typeface="Calibri" pitchFamily="34" charset="0"/>
+                <a:ea typeface="Calibri" pitchFamily="34" charset="-122"/>
+                <a:cs typeface="Calibri" pitchFamily="34" charset="-120"/>
+              </a:rPr>
+              <a:t>The FSY lessons for every Sunday, plus Come, Follow Me — all in the Gospel Library app.</a:t>
+            </a:r>
+            <a:endParaRPr lang="en-US" sz="1100" dirty="0"/>
+          </a:p>
+        </p:txBody>
+      </p:sp>
+      <p:sp>
+        <p:nvSpPr>
+          <p:cNvPr id="20" name="Shape 15"/>
+          <p:cNvSpPr/>
+          <p:nvPr/>
+        </p:nvSpPr>
+        <p:spPr>
+          <a:xfrm>
+            <a:off x="8979408" y="1783080"/>
+            <a:ext cx="2724912" cy="3017520"/>
+          </a:xfrm>
+          <a:prstGeom prst="roundRect">
+            <a:avLst>
+              <a:gd name="adj" fmla="val 4027"/>
+            </a:avLst>
+          </a:prstGeom>
+          <a:solidFill>
+            <a:srgbClr val="EDF1F8"/>
+          </a:solidFill>
+          <a:ln/>
+        </p:spPr>
+      </p:sp>
+      <p:sp>
+        <p:nvSpPr>
+          <p:cNvPr id="21" name="Shape 16"/>
+          <p:cNvSpPr/>
+          <p:nvPr/>
+        </p:nvSpPr>
+        <p:spPr>
+          <a:xfrm>
+            <a:off x="9253728" y="2057400"/>
+            <a:ext cx="566928" cy="566928"/>
+          </a:xfrm>
+          <a:prstGeom prst="ellipse">
+            <a:avLst/>
+          </a:prstGeom>
+          <a:solidFill>
+            <a:srgbClr val="1B2A52"/>
+          </a:solidFill>
+          <a:ln/>
+        </p:spPr>
+      </p:sp>
+      <p:pic>
+        <p:nvPicPr>
+          <p:cNvPr id="22" name="Image 3" descr="preencoded.png">    </p:cNvPr>
+          <p:cNvPicPr>
+            <a:picLocks noChangeAspect="1"/>
+          </p:cNvPicPr>
+          <p:nvPr/>
+        </p:nvPicPr>
+        <p:blipFill>
+          <a:blip r:embed="rId4"/>
+          <a:stretch>
+            <a:fillRect/>
+          </a:stretch>
+        </p:blipFill>
+        <p:spPr>
+          <a:xfrm>
+            <a:off x="9406799" y="2210471"/>
+            <a:ext cx="260787" cy="260787"/>
+          </a:xfrm>
+          <a:prstGeom prst="rect">
+            <a:avLst/>
+          </a:prstGeom>
+        </p:spPr>
+      </p:pic>
+      <p:sp>
+        <p:nvSpPr>
+          <p:cNvPr id="23" name="Text 17"/>
+          <p:cNvSpPr txBox="1"/>
+          <p:nvPr/>
+        </p:nvSpPr>
+        <p:spPr>
+          <a:xfrm>
+            <a:off x="9253728" y="2834640"/>
+            <a:ext cx="2212848" cy="640080"/>
+          </a:xfrm>
+          <a:prstGeom prst="rect">
+            <a:avLst/>
+          </a:prstGeom>
+          <a:noFill/>
+          <a:ln/>
+        </p:spPr>
+        <p:txBody>
+          <a:bodyPr wrap="square" lIns="0" tIns="0" rIns="0" bIns="0" rtlCol="0" anchor="ctr"/>
+          <a:lstStyle/>
+          <a:p>
+            <a:pPr indent="0" marL="0">
+              <a:buNone/>
+            </a:pPr>
+            <a:r>
+              <a:rPr lang="en-US" sz="1500" b="1" dirty="0">
+                <a:solidFill>
+                  <a:srgbClr val="1B2A52"/>
+                </a:solidFill>
+                <a:latin typeface="Calibri" pitchFamily="34" charset="0"/>
+                <a:ea typeface="Calibri" pitchFamily="34" charset="-122"/>
+                <a:cs typeface="Calibri" pitchFamily="34" charset="-120"/>
+              </a:rPr>
+              <a:t>Sunday Website</a:t>
+            </a:r>
+            <a:endParaRPr lang="en-US" sz="1500" dirty="0"/>
+          </a:p>
+        </p:txBody>
+      </p:sp>
+      <p:sp>
+        <p:nvSpPr>
+          <p:cNvPr id="24" name="Text 18"/>
+          <p:cNvSpPr txBox="1"/>
+          <p:nvPr/>
+        </p:nvSpPr>
+        <p:spPr>
+          <a:xfrm>
+            <a:off x="9253728" y="3383280"/>
+            <a:ext cx="2212848" cy="1051560"/>
+          </a:xfrm>
+          <a:prstGeom prst="rect">
+            <a:avLst/>
+          </a:prstGeom>
+          <a:noFill/>
+          <a:ln/>
+        </p:spPr>
+        <p:txBody>
+          <a:bodyPr wrap="square" lIns="0" tIns="0" rIns="0" bIns="0" rtlCol="0" anchor="t"/>
+          <a:lstStyle/>
+          <a:p>
+            <a:pPr indent="0" marL="0">
+              <a:buNone/>
+            </a:pPr>
+            <a:r>
+              <a:rPr lang="en-US" sz="1100" dirty="0">
+                <a:solidFill>
+                  <a:srgbClr val="5C6575"/>
+                </a:solidFill>
+                <a:latin typeface="Calibri" pitchFamily="34" charset="0"/>
+                <a:ea typeface="Calibri" pitchFamily="34" charset="-122"/>
+                <a:cs typeface="Calibri" pitchFamily="34" charset="-120"/>
+              </a:rPr>
+              <a:t>Instructional videos, the implementation guide, and answers to common questions.</a:t>
+            </a:r>
+            <a:endParaRPr lang="en-US" sz="1100" dirty="0"/>
+          </a:p>
+        </p:txBody>
+      </p:sp>
+      <p:sp>
+        <p:nvSpPr>
+          <p:cNvPr id="25" name="Text 19"/>
+          <p:cNvSpPr txBox="1"/>
+          <p:nvPr/>
+        </p:nvSpPr>
+        <p:spPr>
+          <a:xfrm>
+            <a:off x="9180576" y="4425696"/>
+            <a:ext cx="2432304" cy="274320"/>
+          </a:xfrm>
+          <a:prstGeom prst="rect">
+            <a:avLst/>
+          </a:prstGeom>
+          <a:noFill/>
+          <a:ln/>
+        </p:spPr>
+        <p:txBody>
+          <a:bodyPr wrap="square" lIns="0" tIns="0" rIns="0" bIns="0" rtlCol="0" anchor="ctr"/>
+          <a:lstStyle/>
+          <a:p>
+            <a:pPr indent="0" marL="0">
+              <a:buNone/>
+            </a:pPr>
+            <a:r>
+              <a:rPr lang="en-US" sz="870" b="1" dirty="0">
+                <a:solidFill>
+                  <a:srgbClr val="1B2A52"/>
+                </a:solidFill>
+                <a:latin typeface="Calibri" pitchFamily="34" charset="0"/>
+                <a:ea typeface="Calibri" pitchFamily="34" charset="-122"/>
+                <a:cs typeface="Calibri" pitchFamily="34" charset="-120"/>
+              </a:rPr>
+              <a:t>sunday.ChurchofJesusChrist.org</a:t>
+            </a:r>
+            <a:endParaRPr lang="en-US" sz="870" dirty="0"/>
+          </a:p>
+        </p:txBody>
+      </p:sp>
+      <p:sp>
+        <p:nvSpPr>
+          <p:cNvPr id="26" name="Shape 20"/>
+          <p:cNvSpPr/>
+          <p:nvPr/>
+        </p:nvSpPr>
+        <p:spPr>
+          <a:xfrm>
+            <a:off x="502920" y="5120640"/>
+            <a:ext cx="11201400" cy="1051560"/>
+          </a:xfrm>
+          <a:prstGeom prst="roundRect">
+            <a:avLst>
+              <a:gd name="adj" fmla="val 8696"/>
+            </a:avLst>
+          </a:prstGeom>
+          <a:solidFill>
+            <a:srgbClr val="1B2A52"/>
+          </a:solidFill>
+          <a:ln/>
+        </p:spPr>
+      </p:sp>
+      <p:sp>
+        <p:nvSpPr>
+          <p:cNvPr id="27" name="Shape 21"/>
+          <p:cNvSpPr/>
+          <p:nvPr/>
+        </p:nvSpPr>
+        <p:spPr>
+          <a:xfrm>
+            <a:off x="777240" y="5349240"/>
+            <a:ext cx="566928" cy="566928"/>
+          </a:xfrm>
+          <a:prstGeom prst="ellipse">
+            <a:avLst/>
+          </a:prstGeom>
+          <a:solidFill>
+            <a:srgbClr val="C9A227"/>
+          </a:solidFill>
+          <a:ln/>
+        </p:spPr>
+      </p:sp>
+      <p:pic>
+        <p:nvPicPr>
+          <p:cNvPr id="28" name="Image 4" descr="preencoded.png">    </p:cNvPr>
+          <p:cNvPicPr>
+            <a:picLocks noChangeAspect="1"/>
+          </p:cNvPicPr>
+          <p:nvPr/>
+        </p:nvPicPr>
+        <p:blipFill>
+          <a:blip r:embed="rId5"/>
+          <a:stretch>
+            <a:fillRect/>
+          </a:stretch>
+        </p:blipFill>
+        <p:spPr>
+          <a:xfrm>
+            <a:off x="930311" y="5502311"/>
+            <a:ext cx="260787" cy="260787"/>
+          </a:xfrm>
+          <a:prstGeom prst="rect">
+            <a:avLst/>
+          </a:prstGeom>
+        </p:spPr>
+      </p:pic>
+      <p:sp>
+        <p:nvSpPr>
+          <p:cNvPr id="29" name="Text 22"/>
+          <p:cNvSpPr txBox="1"/>
+          <p:nvPr/>
+        </p:nvSpPr>
+        <p:spPr>
+          <a:xfrm>
+            <a:off x="1554480" y="5321808"/>
+            <a:ext cx="9966960" cy="685800"/>
+          </a:xfrm>
+          <a:prstGeom prst="rect">
+            <a:avLst/>
+          </a:prstGeom>
+          <a:noFill/>
+          <a:ln/>
+        </p:spPr>
+        <p:txBody>
+          <a:bodyPr wrap="square" lIns="0" tIns="0" rIns="0" bIns="0" rtlCol="0" anchor="ctr"/>
+          <a:lstStyle/>
+          <a:p>
+            <a:pPr indent="0" marL="0">
+              <a:buNone/>
+            </a:pPr>
+            <a:r>
+              <a:rPr lang="en-US" sz="1350" b="1" dirty="0">
+                <a:solidFill>
+                  <a:srgbClr val="C9A227"/>
+                </a:solidFill>
+                <a:latin typeface="Calibri" pitchFamily="34" charset="0"/>
+                <a:ea typeface="Calibri" pitchFamily="34" charset="-122"/>
+                <a:cs typeface="Calibri" pitchFamily="34" charset="-120"/>
+              </a:rPr>
+              <a:t>For parents: </a:t>
+            </a:r>
+            <a:pPr indent="0" marL="0">
+              <a:buNone/>
+            </a:pPr>
+            <a:r>
+              <a:rPr lang="en-US" sz="1350" dirty="0">
                 <a:solidFill>
                   <a:srgbClr val="FFFFFF"/>
                 </a:solidFill>
@@ -9553,113 +10769,7 @@
                 <a:ea typeface="Calibri" pitchFamily="34" charset="-122"/>
                 <a:cs typeface="Calibri" pitchFamily="34" charset="-120"/>
               </a:rPr>
-              <a:t>A message from President Timothy L. Farnes and President Emily Belle Freeman introducing the new Sunday youth curriculum.</a:t>
-            </a:r>
-            <a:endParaRPr lang="en-US" sz="1650" dirty="0"/>
-          </a:p>
-        </p:txBody>
-      </p:sp>
-      <p:sp>
-        <p:nvSpPr>
-          <p:cNvPr id="9" name="Text 6"/>
-          <p:cNvSpPr txBox="1"/>
-          <p:nvPr/>
-        </p:nvSpPr>
-        <p:spPr>
-          <a:xfrm>
-            <a:off x="3657600" y="3474720"/>
-            <a:ext cx="7680960" cy="777240"/>
-          </a:xfrm>
-          <a:prstGeom prst="rect">
-            <a:avLst/>
-          </a:prstGeom>
-          <a:noFill/>
-          <a:ln/>
-        </p:spPr>
-        <p:txBody>
-          <a:bodyPr wrap="square" lIns="0" tIns="0" rIns="0" bIns="0" rtlCol="0" anchor="ctr"/>
-          <a:lstStyle/>
-          <a:p>
-            <a:pPr indent="0" marL="0">
-              <a:buNone/>
-            </a:pPr>
-            <a:r>
-              <a:rPr lang="en-US" sz="1350" b="1" dirty="0">
-                <a:solidFill>
-                  <a:srgbClr val="C9A227"/>
-                </a:solidFill>
-                <a:latin typeface="Calibri" pitchFamily="34" charset="0"/>
-                <a:ea typeface="Calibri" pitchFamily="34" charset="-122"/>
-                <a:cs typeface="Calibri" pitchFamily="34" charset="-120"/>
-              </a:rPr>
-              <a:t>Find it in: </a:t>
-            </a:r>
-            <a:pPr indent="0" marL="0">
-              <a:buNone/>
-            </a:pPr>
-            <a:r>
-              <a:rPr lang="en-US" sz="1350" dirty="0">
-                <a:solidFill>
-                  <a:srgbClr val="C9D6EF"/>
-                </a:solidFill>
-                <a:latin typeface="Calibri" pitchFamily="34" charset="0"/>
-                <a:ea typeface="Calibri" pitchFamily="34" charset="-122"/>
-                <a:cs typeface="Calibri" pitchFamily="34" charset="-120"/>
-              </a:rPr>
-              <a:t>Gospel Library → Changes to the Sunday Class Meeting Schedule → Youth Fifth-Sunday Instruction Materials, or at sunday.ChurchofJesusChrist.org.</a:t>
-            </a:r>
-            <a:endParaRPr lang="en-US" sz="1350" dirty="0"/>
-          </a:p>
-        </p:txBody>
-      </p:sp>
-      <p:sp>
-        <p:nvSpPr>
-          <p:cNvPr id="10" name="Text 7"/>
-          <p:cNvSpPr txBox="1"/>
-          <p:nvPr/>
-        </p:nvSpPr>
-        <p:spPr>
-          <a:xfrm>
-            <a:off x="3657600" y="4343400"/>
-            <a:ext cx="7680960" cy="548640"/>
-          </a:xfrm>
-          <a:prstGeom prst="rect">
-            <a:avLst/>
-          </a:prstGeom>
-          <a:noFill/>
-          <a:ln/>
-        </p:spPr>
-        <p:txBody>
-          <a:bodyPr wrap="square" lIns="0" tIns="0" rIns="0" bIns="0" rtlCol="0" anchor="ctr"/>
-          <a:lstStyle/>
-          <a:p>
-            <a:pPr indent="0" marL="0">
-              <a:buNone/>
-            </a:pPr>
-            <a:r>
-              <a:rPr lang="en-US" sz="1350" b="1" dirty="0">
-                <a:solidFill>
-                  <a:srgbClr val="C9A227"/>
-                </a:solidFill>
-                <a:latin typeface="Calibri" pitchFamily="34" charset="0"/>
-                <a:ea typeface="Calibri" pitchFamily="34" charset="-122"/>
-                <a:cs typeface="Calibri" pitchFamily="34" charset="-120"/>
-              </a:rPr>
-              <a:t>Tip: </a:t>
-            </a:r>
-            <a:pPr indent="0" marL="0">
-              <a:buNone/>
-            </a:pPr>
-            <a:r>
-              <a:rPr lang="en-US" sz="1350" dirty="0">
-                <a:solidFill>
-                  <a:srgbClr val="C9D6EF"/>
-                </a:solidFill>
-                <a:latin typeface="Calibri" pitchFamily="34" charset="0"/>
-                <a:ea typeface="Calibri" pitchFamily="34" charset="-122"/>
-                <a:cs typeface="Calibri" pitchFamily="34" charset="-120"/>
-              </a:rPr>
-              <a:t>pause the video where prompted and use the discussion questions on the next slide.</a:t>
+              <a:t>the same guide, magazine, and lessons at home make Sunday classes an easy, natural topic for family conversation all month long.</a:t>
             </a:r>
             <a:endParaRPr lang="en-US" sz="1350" dirty="0"/>
           </a:p>

</xml_diff>

<commit_message>
Add one-click video navigation to every slide
Every slide now carries a small gold 'Video' button (bottom-right) that
jumps to the video slide during the slide show, and the video slide has
a 'Back to slides' button using PowerPoint's built-in last-viewed jump,
so the presenter can bounce between the video and any slide in one
click each way.

Co-Authored-By: Claude Fable 5 <noreply@anthropic.com>
Claude-Session: https://claude.ai/code/session_01NQir395bsK1jUiLLBPYw8i
</commit_message>
<xml_diff>
--- a/new-sunday-youth-curriculum.pptx
+++ b/new-sunday-youth-curriculum.pptx
@@ -2941,6 +2941,48 @@
           </a:p>
         </p:txBody>
       </p:sp>
+      <p:sp>
+        <p:nvSpPr>
+          <p:cNvPr id="951" name="NavButton951">
+            <a:hlinkClick r:id="rId4" action="ppaction://hlinksldjump"/>
+          </p:cNvPr>
+          <p:cNvSpPr/>
+          <p:nvPr/>
+        </p:nvSpPr>
+        <p:spPr>
+          <a:xfrm>
+            <a:off x="11137392" y="6419088"/>
+            <a:ext cx="914400" cy="329184"/>
+          </a:xfrm>
+          <a:prstGeom prst="roundRect">
+            <a:avLst>
+              <a:gd name="adj" fmla="val 50000"/>
+            </a:avLst>
+          </a:prstGeom>
+          <a:solidFill>
+            <a:srgbClr val="C9A227"/>
+          </a:solidFill>
+          <a:ln>
+            <a:noFill/>
+          </a:ln>
+        </p:spPr>
+        <p:txBody>
+          <a:bodyPr anchor="ctr" lIns="0" tIns="0" rIns="0" bIns="0"/>
+          <a:lstStyle/>
+          <a:p>
+            <a:pPr algn="ctr"/>
+            <a:r>
+              <a:rPr lang="en-US" sz="1000" b="1" dirty="0">
+                <a:solidFill>
+                  <a:srgbClr val="1B2A52"/>
+                </a:solidFill>
+                <a:latin typeface="Calibri"/>
+              </a:rPr>
+              <a:t>▶ Video</a:t>
+            </a:r>
+          </a:p>
+        </p:txBody>
+      </p:sp>
     </p:spTree>
   </p:cSld>
   <p:clrMapOvr>
@@ -3962,6 +4004,48 @@
           </a:p>
         </p:txBody>
       </p:sp>
+      <p:sp>
+        <p:nvSpPr>
+          <p:cNvPr id="951" name="NavButton951">
+            <a:hlinkClick r:id="rId8" action="ppaction://hlinksldjump"/>
+          </p:cNvPr>
+          <p:cNvSpPr/>
+          <p:nvPr/>
+        </p:nvSpPr>
+        <p:spPr>
+          <a:xfrm>
+            <a:off x="11137392" y="6419088"/>
+            <a:ext cx="914400" cy="329184"/>
+          </a:xfrm>
+          <a:prstGeom prst="roundRect">
+            <a:avLst>
+              <a:gd name="adj" fmla="val 50000"/>
+            </a:avLst>
+          </a:prstGeom>
+          <a:solidFill>
+            <a:srgbClr val="C9A227"/>
+          </a:solidFill>
+          <a:ln>
+            <a:noFill/>
+          </a:ln>
+        </p:spPr>
+        <p:txBody>
+          <a:bodyPr anchor="ctr" lIns="0" tIns="0" rIns="0" bIns="0"/>
+          <a:lstStyle/>
+          <a:p>
+            <a:pPr algn="ctr"/>
+            <a:r>
+              <a:rPr lang="en-US" sz="1000" b="1" dirty="0">
+                <a:solidFill>
+                  <a:srgbClr val="1B2A52"/>
+                </a:solidFill>
+                <a:latin typeface="Calibri"/>
+              </a:rPr>
+              <a:t>▶ Video</a:t>
+            </a:r>
+          </a:p>
+        </p:txBody>
+      </p:sp>
     </p:spTree>
   </p:cSld>
   <p:clrMapOvr>
@@ -5115,6 +5199,48 @@
           </a:p>
         </p:txBody>
       </p:sp>
+      <p:sp>
+        <p:nvSpPr>
+          <p:cNvPr id="951" name="NavButton951">
+            <a:hlinkClick r:id="rId4" action="ppaction://hlinksldjump"/>
+          </p:cNvPr>
+          <p:cNvSpPr/>
+          <p:nvPr/>
+        </p:nvSpPr>
+        <p:spPr>
+          <a:xfrm>
+            <a:off x="11137392" y="6419088"/>
+            <a:ext cx="914400" cy="329184"/>
+          </a:xfrm>
+          <a:prstGeom prst="roundRect">
+            <a:avLst>
+              <a:gd name="adj" fmla="val 50000"/>
+            </a:avLst>
+          </a:prstGeom>
+          <a:solidFill>
+            <a:srgbClr val="C9A227"/>
+          </a:solidFill>
+          <a:ln>
+            <a:noFill/>
+          </a:ln>
+        </p:spPr>
+        <p:txBody>
+          <a:bodyPr anchor="ctr" lIns="0" tIns="0" rIns="0" bIns="0"/>
+          <a:lstStyle/>
+          <a:p>
+            <a:pPr algn="ctr"/>
+            <a:r>
+              <a:rPr lang="en-US" sz="1000" b="1" dirty="0">
+                <a:solidFill>
+                  <a:srgbClr val="1B2A52"/>
+                </a:solidFill>
+                <a:latin typeface="Calibri"/>
+              </a:rPr>
+              <a:t>▶ Video</a:t>
+            </a:r>
+          </a:p>
+        </p:txBody>
+      </p:sp>
     </p:spTree>
   </p:cSld>
   <p:clrMapOvr>
@@ -5356,6 +5482,48 @@
           </a:p>
         </p:txBody>
       </p:sp>
+      <p:sp>
+        <p:nvSpPr>
+          <p:cNvPr id="951" name="NavButton951">
+            <a:hlinkClick r:id="rId5" action="ppaction://hlinksldjump"/>
+          </p:cNvPr>
+          <p:cNvSpPr/>
+          <p:nvPr/>
+        </p:nvSpPr>
+        <p:spPr>
+          <a:xfrm>
+            <a:off x="11137392" y="6419088"/>
+            <a:ext cx="914400" cy="329184"/>
+          </a:xfrm>
+          <a:prstGeom prst="roundRect">
+            <a:avLst>
+              <a:gd name="adj" fmla="val 50000"/>
+            </a:avLst>
+          </a:prstGeom>
+          <a:solidFill>
+            <a:srgbClr val="C9A227"/>
+          </a:solidFill>
+          <a:ln>
+            <a:noFill/>
+          </a:ln>
+        </p:spPr>
+        <p:txBody>
+          <a:bodyPr anchor="ctr" lIns="0" tIns="0" rIns="0" bIns="0"/>
+          <a:lstStyle/>
+          <a:p>
+            <a:pPr algn="ctr"/>
+            <a:r>
+              <a:rPr lang="en-US" sz="1000" b="1" dirty="0">
+                <a:solidFill>
+                  <a:srgbClr val="1B2A52"/>
+                </a:solidFill>
+                <a:latin typeface="Calibri"/>
+              </a:rPr>
+              <a:t>▶ Video</a:t>
+            </a:r>
+          </a:p>
+        </p:txBody>
+      </p:sp>
     </p:spTree>
   </p:cSld>
   <p:clrMapOvr>
@@ -5597,6 +5765,48 @@
           </a:p>
         </p:txBody>
       </p:sp>
+      <p:sp>
+        <p:nvSpPr>
+          <p:cNvPr id="951" name="NavButton951">
+            <a:hlinkClick r:id="rId5" action="ppaction://hlinksldjump"/>
+          </p:cNvPr>
+          <p:cNvSpPr/>
+          <p:nvPr/>
+        </p:nvSpPr>
+        <p:spPr>
+          <a:xfrm>
+            <a:off x="11137392" y="6419088"/>
+            <a:ext cx="914400" cy="329184"/>
+          </a:xfrm>
+          <a:prstGeom prst="roundRect">
+            <a:avLst>
+              <a:gd name="adj" fmla="val 50000"/>
+            </a:avLst>
+          </a:prstGeom>
+          <a:solidFill>
+            <a:srgbClr val="C9A227"/>
+          </a:solidFill>
+          <a:ln>
+            <a:noFill/>
+          </a:ln>
+        </p:spPr>
+        <p:txBody>
+          <a:bodyPr anchor="ctr" lIns="0" tIns="0" rIns="0" bIns="0"/>
+          <a:lstStyle/>
+          <a:p>
+            <a:pPr algn="ctr"/>
+            <a:r>
+              <a:rPr lang="en-US" sz="1000" b="1" dirty="0">
+                <a:solidFill>
+                  <a:srgbClr val="1B2A52"/>
+                </a:solidFill>
+                <a:latin typeface="Calibri"/>
+              </a:rPr>
+              <a:t>▶ Video</a:t>
+            </a:r>
+          </a:p>
+        </p:txBody>
+      </p:sp>
     </p:spTree>
   </p:cSld>
   <p:clrMapOvr>
@@ -5838,6 +6048,48 @@
           </a:p>
         </p:txBody>
       </p:sp>
+      <p:sp>
+        <p:nvSpPr>
+          <p:cNvPr id="951" name="NavButton951">
+            <a:hlinkClick r:id="rId5" action="ppaction://hlinksldjump"/>
+          </p:cNvPr>
+          <p:cNvSpPr/>
+          <p:nvPr/>
+        </p:nvSpPr>
+        <p:spPr>
+          <a:xfrm>
+            <a:off x="11137392" y="6419088"/>
+            <a:ext cx="914400" cy="329184"/>
+          </a:xfrm>
+          <a:prstGeom prst="roundRect">
+            <a:avLst>
+              <a:gd name="adj" fmla="val 50000"/>
+            </a:avLst>
+          </a:prstGeom>
+          <a:solidFill>
+            <a:srgbClr val="C9A227"/>
+          </a:solidFill>
+          <a:ln>
+            <a:noFill/>
+          </a:ln>
+        </p:spPr>
+        <p:txBody>
+          <a:bodyPr anchor="ctr" lIns="0" tIns="0" rIns="0" bIns="0"/>
+          <a:lstStyle/>
+          <a:p>
+            <a:pPr algn="ctr"/>
+            <a:r>
+              <a:rPr lang="en-US" sz="1000" b="1" dirty="0">
+                <a:solidFill>
+                  <a:srgbClr val="1B2A52"/>
+                </a:solidFill>
+                <a:latin typeface="Calibri"/>
+              </a:rPr>
+              <a:t>▶ Video</a:t>
+            </a:r>
+          </a:p>
+        </p:txBody>
+      </p:sp>
     </p:spTree>
   </p:cSld>
   <p:clrMapOvr>
@@ -6079,6 +6331,48 @@
           </a:p>
         </p:txBody>
       </p:sp>
+      <p:sp>
+        <p:nvSpPr>
+          <p:cNvPr id="951" name="NavButton951">
+            <a:hlinkClick r:id="rId5" action="ppaction://hlinksldjump"/>
+          </p:cNvPr>
+          <p:cNvSpPr/>
+          <p:nvPr/>
+        </p:nvSpPr>
+        <p:spPr>
+          <a:xfrm>
+            <a:off x="11137392" y="6419088"/>
+            <a:ext cx="914400" cy="329184"/>
+          </a:xfrm>
+          <a:prstGeom prst="roundRect">
+            <a:avLst>
+              <a:gd name="adj" fmla="val 50000"/>
+            </a:avLst>
+          </a:prstGeom>
+          <a:solidFill>
+            <a:srgbClr val="C9A227"/>
+          </a:solidFill>
+          <a:ln>
+            <a:noFill/>
+          </a:ln>
+        </p:spPr>
+        <p:txBody>
+          <a:bodyPr anchor="ctr" lIns="0" tIns="0" rIns="0" bIns="0"/>
+          <a:lstStyle/>
+          <a:p>
+            <a:pPr algn="ctr"/>
+            <a:r>
+              <a:rPr lang="en-US" sz="1000" b="1" dirty="0">
+                <a:solidFill>
+                  <a:srgbClr val="1B2A52"/>
+                </a:solidFill>
+                <a:latin typeface="Calibri"/>
+              </a:rPr>
+              <a:t>▶ Video</a:t>
+            </a:r>
+          </a:p>
+        </p:txBody>
+      </p:sp>
     </p:spTree>
   </p:cSld>
   <p:clrMapOvr>
@@ -6962,6 +7256,48 @@
           </a:p>
         </p:txBody>
       </p:sp>
+      <p:sp>
+        <p:nvSpPr>
+          <p:cNvPr id="951" name="NavButton951">
+            <a:hlinkClick r:id="rId8" action="ppaction://hlinksldjump"/>
+          </p:cNvPr>
+          <p:cNvSpPr/>
+          <p:nvPr/>
+        </p:nvSpPr>
+        <p:spPr>
+          <a:xfrm>
+            <a:off x="11137392" y="6419088"/>
+            <a:ext cx="914400" cy="329184"/>
+          </a:xfrm>
+          <a:prstGeom prst="roundRect">
+            <a:avLst>
+              <a:gd name="adj" fmla="val 50000"/>
+            </a:avLst>
+          </a:prstGeom>
+          <a:solidFill>
+            <a:srgbClr val="C9A227"/>
+          </a:solidFill>
+          <a:ln>
+            <a:noFill/>
+          </a:ln>
+        </p:spPr>
+        <p:txBody>
+          <a:bodyPr anchor="ctr" lIns="0" tIns="0" rIns="0" bIns="0"/>
+          <a:lstStyle/>
+          <a:p>
+            <a:pPr algn="ctr"/>
+            <a:r>
+              <a:rPr lang="en-US" sz="1000" b="1" dirty="0">
+                <a:solidFill>
+                  <a:srgbClr val="1B2A52"/>
+                </a:solidFill>
+                <a:latin typeface="Calibri"/>
+              </a:rPr>
+              <a:t>▶ Video</a:t>
+            </a:r>
+          </a:p>
+        </p:txBody>
+      </p:sp>
     </p:spTree>
   </p:cSld>
   <p:clrMapOvr>
@@ -7918,6 +8254,48 @@
           </a:p>
         </p:txBody>
       </p:sp>
+      <p:sp>
+        <p:nvSpPr>
+          <p:cNvPr id="951" name="NavButton951">
+            <a:hlinkClick r:id="rId4" action="ppaction://hlinksldjump"/>
+          </p:cNvPr>
+          <p:cNvSpPr/>
+          <p:nvPr/>
+        </p:nvSpPr>
+        <p:spPr>
+          <a:xfrm>
+            <a:off x="11137392" y="6419088"/>
+            <a:ext cx="914400" cy="329184"/>
+          </a:xfrm>
+          <a:prstGeom prst="roundRect">
+            <a:avLst>
+              <a:gd name="adj" fmla="val 50000"/>
+            </a:avLst>
+          </a:prstGeom>
+          <a:solidFill>
+            <a:srgbClr val="C9A227"/>
+          </a:solidFill>
+          <a:ln>
+            <a:noFill/>
+          </a:ln>
+        </p:spPr>
+        <p:txBody>
+          <a:bodyPr anchor="ctr" lIns="0" tIns="0" rIns="0" bIns="0"/>
+          <a:lstStyle/>
+          <a:p>
+            <a:pPr algn="ctr"/>
+            <a:r>
+              <a:rPr lang="en-US" sz="1000" b="1" dirty="0">
+                <a:solidFill>
+                  <a:srgbClr val="1B2A52"/>
+                </a:solidFill>
+                <a:latin typeface="Calibri"/>
+              </a:rPr>
+              <a:t>▶ Video</a:t>
+            </a:r>
+          </a:p>
+        </p:txBody>
+      </p:sp>
     </p:spTree>
   </p:cSld>
   <p:clrMapOvr>
@@ -8167,6 +8545,48 @@
           </a:p>
         </p:txBody>
       </p:sp>
+      <p:sp>
+        <p:nvSpPr>
+          <p:cNvPr id="950" name="NavButton950">
+            <a:hlinkClick action="ppaction://hlinkshowjump?jump=lastslideviewed"/>
+          </p:cNvPr>
+          <p:cNvSpPr/>
+          <p:nvPr/>
+        </p:nvSpPr>
+        <p:spPr>
+          <a:xfrm>
+            <a:off x="10378440" y="384048"/>
+            <a:ext cx="1371600" cy="365760"/>
+          </a:xfrm>
+          <a:prstGeom prst="roundRect">
+            <a:avLst>
+              <a:gd name="adj" fmla="val 50000"/>
+            </a:avLst>
+          </a:prstGeom>
+          <a:solidFill>
+            <a:srgbClr val="C9A227"/>
+          </a:solidFill>
+          <a:ln>
+            <a:noFill/>
+          </a:ln>
+        </p:spPr>
+        <p:txBody>
+          <a:bodyPr anchor="ctr" lIns="0" tIns="0" rIns="0" bIns="0"/>
+          <a:lstStyle/>
+          <a:p>
+            <a:pPr algn="ctr"/>
+            <a:r>
+              <a:rPr lang="en-US" sz="1000" b="1" dirty="0">
+                <a:solidFill>
+                  <a:srgbClr val="1B2A52"/>
+                </a:solidFill>
+                <a:latin typeface="Calibri"/>
+              </a:rPr>
+              <a:t>⟵ Back to slides</a:t>
+            </a:r>
+          </a:p>
+        </p:txBody>
+      </p:sp>
     </p:spTree>
   </p:cSld>
   <p:clrMapOvr>
@@ -8676,6 +9096,48 @@
           </a:p>
         </p:txBody>
       </p:sp>
+      <p:sp>
+        <p:nvSpPr>
+          <p:cNvPr id="951" name="NavButton951">
+            <a:hlinkClick r:id="rId3" action="ppaction://hlinksldjump"/>
+          </p:cNvPr>
+          <p:cNvSpPr/>
+          <p:nvPr/>
+        </p:nvSpPr>
+        <p:spPr>
+          <a:xfrm>
+            <a:off x="11137392" y="6419088"/>
+            <a:ext cx="914400" cy="329184"/>
+          </a:xfrm>
+          <a:prstGeom prst="roundRect">
+            <a:avLst>
+              <a:gd name="adj" fmla="val 50000"/>
+            </a:avLst>
+          </a:prstGeom>
+          <a:solidFill>
+            <a:srgbClr val="C9A227"/>
+          </a:solidFill>
+          <a:ln>
+            <a:noFill/>
+          </a:ln>
+        </p:spPr>
+        <p:txBody>
+          <a:bodyPr anchor="ctr" lIns="0" tIns="0" rIns="0" bIns="0"/>
+          <a:lstStyle/>
+          <a:p>
+            <a:pPr algn="ctr"/>
+            <a:r>
+              <a:rPr lang="en-US" sz="1000" b="1" dirty="0">
+                <a:solidFill>
+                  <a:srgbClr val="1B2A52"/>
+                </a:solidFill>
+                <a:latin typeface="Calibri"/>
+              </a:rPr>
+              <a:t>▶ Video</a:t>
+            </a:r>
+          </a:p>
+        </p:txBody>
+      </p:sp>
     </p:spTree>
   </p:cSld>
   <p:clrMapOvr>
@@ -9395,6 +9857,48 @@
           </a:p>
         </p:txBody>
       </p:sp>
+      <p:sp>
+        <p:nvSpPr>
+          <p:cNvPr id="951" name="NavButton951">
+            <a:hlinkClick r:id="rId6" action="ppaction://hlinksldjump"/>
+          </p:cNvPr>
+          <p:cNvSpPr/>
+          <p:nvPr/>
+        </p:nvSpPr>
+        <p:spPr>
+          <a:xfrm>
+            <a:off x="11137392" y="6419088"/>
+            <a:ext cx="914400" cy="329184"/>
+          </a:xfrm>
+          <a:prstGeom prst="roundRect">
+            <a:avLst>
+              <a:gd name="adj" fmla="val 50000"/>
+            </a:avLst>
+          </a:prstGeom>
+          <a:solidFill>
+            <a:srgbClr val="C9A227"/>
+          </a:solidFill>
+          <a:ln>
+            <a:noFill/>
+          </a:ln>
+        </p:spPr>
+        <p:txBody>
+          <a:bodyPr anchor="ctr" lIns="0" tIns="0" rIns="0" bIns="0"/>
+          <a:lstStyle/>
+          <a:p>
+            <a:pPr algn="ctr"/>
+            <a:r>
+              <a:rPr lang="en-US" sz="1000" b="1" dirty="0">
+                <a:solidFill>
+                  <a:srgbClr val="1B2A52"/>
+                </a:solidFill>
+                <a:latin typeface="Calibri"/>
+              </a:rPr>
+              <a:t>▶ Video</a:t>
+            </a:r>
+          </a:p>
+        </p:txBody>
+      </p:sp>
     </p:spTree>
   </p:cSld>
   <p:clrMapOvr>
@@ -9993,6 +10497,48 @@
           </a:p>
         </p:txBody>
       </p:sp>
+      <p:sp>
+        <p:nvSpPr>
+          <p:cNvPr id="951" name="NavButton951">
+            <a:hlinkClick r:id="rId6" action="ppaction://hlinksldjump"/>
+          </p:cNvPr>
+          <p:cNvSpPr/>
+          <p:nvPr/>
+        </p:nvSpPr>
+        <p:spPr>
+          <a:xfrm>
+            <a:off x="11137392" y="6419088"/>
+            <a:ext cx="914400" cy="329184"/>
+          </a:xfrm>
+          <a:prstGeom prst="roundRect">
+            <a:avLst>
+              <a:gd name="adj" fmla="val 50000"/>
+            </a:avLst>
+          </a:prstGeom>
+          <a:solidFill>
+            <a:srgbClr val="C9A227"/>
+          </a:solidFill>
+          <a:ln>
+            <a:noFill/>
+          </a:ln>
+        </p:spPr>
+        <p:txBody>
+          <a:bodyPr anchor="ctr" lIns="0" tIns="0" rIns="0" bIns="0"/>
+          <a:lstStyle/>
+          <a:p>
+            <a:pPr algn="ctr"/>
+            <a:r>
+              <a:rPr lang="en-US" sz="1000" b="1" dirty="0">
+                <a:solidFill>
+                  <a:srgbClr val="1B2A52"/>
+                </a:solidFill>
+                <a:latin typeface="Calibri"/>
+              </a:rPr>
+              <a:t>▶ Video</a:t>
+            </a:r>
+          </a:p>
+        </p:txBody>
+      </p:sp>
     </p:spTree>
   </p:cSld>
   <p:clrMapOvr>
@@ -10610,6 +11156,48 @@
           </a:p>
         </p:txBody>
       </p:sp>
+      <p:sp>
+        <p:nvSpPr>
+          <p:cNvPr id="951" name="NavButton951">
+            <a:hlinkClick r:id="rId7" action="ppaction://hlinksldjump"/>
+          </p:cNvPr>
+          <p:cNvSpPr/>
+          <p:nvPr/>
+        </p:nvSpPr>
+        <p:spPr>
+          <a:xfrm>
+            <a:off x="11137392" y="6419088"/>
+            <a:ext cx="914400" cy="329184"/>
+          </a:xfrm>
+          <a:prstGeom prst="roundRect">
+            <a:avLst>
+              <a:gd name="adj" fmla="val 50000"/>
+            </a:avLst>
+          </a:prstGeom>
+          <a:solidFill>
+            <a:srgbClr val="C9A227"/>
+          </a:solidFill>
+          <a:ln>
+            <a:noFill/>
+          </a:ln>
+        </p:spPr>
+        <p:txBody>
+          <a:bodyPr anchor="ctr" lIns="0" tIns="0" rIns="0" bIns="0"/>
+          <a:lstStyle/>
+          <a:p>
+            <a:pPr algn="ctr"/>
+            <a:r>
+              <a:rPr lang="en-US" sz="1000" b="1" dirty="0">
+                <a:solidFill>
+                  <a:srgbClr val="1B2A52"/>
+                </a:solidFill>
+                <a:latin typeface="Calibri"/>
+              </a:rPr>
+              <a:t>▶ Video</a:t>
+            </a:r>
+          </a:p>
+        </p:txBody>
+      </p:sp>
     </p:spTree>
   </p:cSld>
   <p:clrMapOvr>
@@ -11710,6 +12298,48 @@
           </a:p>
         </p:txBody>
       </p:sp>
+      <p:sp>
+        <p:nvSpPr>
+          <p:cNvPr id="951" name="NavButton951">
+            <a:hlinkClick r:id="rId5" action="ppaction://hlinksldjump"/>
+          </p:cNvPr>
+          <p:cNvSpPr/>
+          <p:nvPr/>
+        </p:nvSpPr>
+        <p:spPr>
+          <a:xfrm>
+            <a:off x="11137392" y="6419088"/>
+            <a:ext cx="914400" cy="329184"/>
+          </a:xfrm>
+          <a:prstGeom prst="roundRect">
+            <a:avLst>
+              <a:gd name="adj" fmla="val 50000"/>
+            </a:avLst>
+          </a:prstGeom>
+          <a:solidFill>
+            <a:srgbClr val="C9A227"/>
+          </a:solidFill>
+          <a:ln>
+            <a:noFill/>
+          </a:ln>
+        </p:spPr>
+        <p:txBody>
+          <a:bodyPr anchor="ctr" lIns="0" tIns="0" rIns="0" bIns="0"/>
+          <a:lstStyle/>
+          <a:p>
+            <a:pPr algn="ctr"/>
+            <a:r>
+              <a:rPr lang="en-US" sz="1000" b="1" dirty="0">
+                <a:solidFill>
+                  <a:srgbClr val="1B2A52"/>
+                </a:solidFill>
+                <a:latin typeface="Calibri"/>
+              </a:rPr>
+              <a:t>▶ Video</a:t>
+            </a:r>
+          </a:p>
+        </p:txBody>
+      </p:sp>
     </p:spTree>
   </p:cSld>
   <p:clrMapOvr>
@@ -12371,6 +13001,48 @@
           </a:p>
         </p:txBody>
       </p:sp>
+      <p:sp>
+        <p:nvSpPr>
+          <p:cNvPr id="951" name="NavButton951">
+            <a:hlinkClick r:id="rId7" action="ppaction://hlinksldjump"/>
+          </p:cNvPr>
+          <p:cNvSpPr/>
+          <p:nvPr/>
+        </p:nvSpPr>
+        <p:spPr>
+          <a:xfrm>
+            <a:off x="11137392" y="6419088"/>
+            <a:ext cx="914400" cy="329184"/>
+          </a:xfrm>
+          <a:prstGeom prst="roundRect">
+            <a:avLst>
+              <a:gd name="adj" fmla="val 50000"/>
+            </a:avLst>
+          </a:prstGeom>
+          <a:solidFill>
+            <a:srgbClr val="C9A227"/>
+          </a:solidFill>
+          <a:ln>
+            <a:noFill/>
+          </a:ln>
+        </p:spPr>
+        <p:txBody>
+          <a:bodyPr anchor="ctr" lIns="0" tIns="0" rIns="0" bIns="0"/>
+          <a:lstStyle/>
+          <a:p>
+            <a:pPr algn="ctr"/>
+            <a:r>
+              <a:rPr lang="en-US" sz="1000" b="1" dirty="0">
+                <a:solidFill>
+                  <a:srgbClr val="1B2A52"/>
+                </a:solidFill>
+                <a:latin typeface="Calibri"/>
+              </a:rPr>
+              <a:t>▶ Video</a:t>
+            </a:r>
+          </a:p>
+        </p:txBody>
+      </p:sp>
     </p:spTree>
   </p:cSld>
   <p:clrMapOvr>
@@ -13058,6 +13730,48 @@
           </a:p>
         </p:txBody>
       </p:sp>
+      <p:sp>
+        <p:nvSpPr>
+          <p:cNvPr id="951" name="NavButton951">
+            <a:hlinkClick r:id="rId3" action="ppaction://hlinksldjump"/>
+          </p:cNvPr>
+          <p:cNvSpPr/>
+          <p:nvPr/>
+        </p:nvSpPr>
+        <p:spPr>
+          <a:xfrm>
+            <a:off x="11137392" y="6419088"/>
+            <a:ext cx="914400" cy="329184"/>
+          </a:xfrm>
+          <a:prstGeom prst="roundRect">
+            <a:avLst>
+              <a:gd name="adj" fmla="val 50000"/>
+            </a:avLst>
+          </a:prstGeom>
+          <a:solidFill>
+            <a:srgbClr val="C9A227"/>
+          </a:solidFill>
+          <a:ln>
+            <a:noFill/>
+          </a:ln>
+        </p:spPr>
+        <p:txBody>
+          <a:bodyPr anchor="ctr" lIns="0" tIns="0" rIns="0" bIns="0"/>
+          <a:lstStyle/>
+          <a:p>
+            <a:pPr algn="ctr"/>
+            <a:r>
+              <a:rPr lang="en-US" sz="1000" b="1" dirty="0">
+                <a:solidFill>
+                  <a:srgbClr val="1B2A52"/>
+                </a:solidFill>
+                <a:latin typeface="Calibri"/>
+              </a:rPr>
+              <a:t>▶ Video</a:t>
+            </a:r>
+          </a:p>
+        </p:txBody>
+      </p:sp>
     </p:spTree>
   </p:cSld>
   <p:clrMapOvr>
@@ -13299,6 +14013,48 @@
           </a:p>
         </p:txBody>
       </p:sp>
+      <p:sp>
+        <p:nvSpPr>
+          <p:cNvPr id="951" name="NavButton951">
+            <a:hlinkClick r:id="rId5" action="ppaction://hlinksldjump"/>
+          </p:cNvPr>
+          <p:cNvSpPr/>
+          <p:nvPr/>
+        </p:nvSpPr>
+        <p:spPr>
+          <a:xfrm>
+            <a:off x="11137392" y="6419088"/>
+            <a:ext cx="914400" cy="329184"/>
+          </a:xfrm>
+          <a:prstGeom prst="roundRect">
+            <a:avLst>
+              <a:gd name="adj" fmla="val 50000"/>
+            </a:avLst>
+          </a:prstGeom>
+          <a:solidFill>
+            <a:srgbClr val="C9A227"/>
+          </a:solidFill>
+          <a:ln>
+            <a:noFill/>
+          </a:ln>
+        </p:spPr>
+        <p:txBody>
+          <a:bodyPr anchor="ctr" lIns="0" tIns="0" rIns="0" bIns="0"/>
+          <a:lstStyle/>
+          <a:p>
+            <a:pPr algn="ctr"/>
+            <a:r>
+              <a:rPr lang="en-US" sz="1000" b="1" dirty="0">
+                <a:solidFill>
+                  <a:srgbClr val="1B2A52"/>
+                </a:solidFill>
+                <a:latin typeface="Calibri"/>
+              </a:rPr>
+              <a:t>▶ Video</a:t>
+            </a:r>
+          </a:p>
+        </p:txBody>
+      </p:sp>
     </p:spTree>
   </p:cSld>
   <p:clrMapOvr>
@@ -13540,6 +14296,48 @@
           </a:p>
         </p:txBody>
       </p:sp>
+      <p:sp>
+        <p:nvSpPr>
+          <p:cNvPr id="951" name="NavButton951">
+            <a:hlinkClick r:id="rId5" action="ppaction://hlinksldjump"/>
+          </p:cNvPr>
+          <p:cNvSpPr/>
+          <p:nvPr/>
+        </p:nvSpPr>
+        <p:spPr>
+          <a:xfrm>
+            <a:off x="11137392" y="6419088"/>
+            <a:ext cx="914400" cy="329184"/>
+          </a:xfrm>
+          <a:prstGeom prst="roundRect">
+            <a:avLst>
+              <a:gd name="adj" fmla="val 50000"/>
+            </a:avLst>
+          </a:prstGeom>
+          <a:solidFill>
+            <a:srgbClr val="C9A227"/>
+          </a:solidFill>
+          <a:ln>
+            <a:noFill/>
+          </a:ln>
+        </p:spPr>
+        <p:txBody>
+          <a:bodyPr anchor="ctr" lIns="0" tIns="0" rIns="0" bIns="0"/>
+          <a:lstStyle/>
+          <a:p>
+            <a:pPr algn="ctr"/>
+            <a:r>
+              <a:rPr lang="en-US" sz="1000" b="1" dirty="0">
+                <a:solidFill>
+                  <a:srgbClr val="1B2A52"/>
+                </a:solidFill>
+                <a:latin typeface="Calibri"/>
+              </a:rPr>
+              <a:t>▶ Video</a:t>
+            </a:r>
+          </a:p>
+        </p:txBody>
+      </p:sp>
     </p:spTree>
   </p:cSld>
   <p:clrMapOvr>
@@ -14478,6 +15276,48 @@
               <a:t>youth Sunday School continues to study the scriptures with Come, Follow Me, and the FSY magazine adds monthly stories and articles on the same theme.</a:t>
             </a:r>
             <a:endParaRPr lang="en-US" sz="1300" dirty="0"/>
+          </a:p>
+        </p:txBody>
+      </p:sp>
+      <p:sp>
+        <p:nvSpPr>
+          <p:cNvPr id="951" name="NavButton951">
+            <a:hlinkClick r:id="rId8" action="ppaction://hlinksldjump"/>
+          </p:cNvPr>
+          <p:cNvSpPr/>
+          <p:nvPr/>
+        </p:nvSpPr>
+        <p:spPr>
+          <a:xfrm>
+            <a:off x="11137392" y="6419088"/>
+            <a:ext cx="914400" cy="329184"/>
+          </a:xfrm>
+          <a:prstGeom prst="roundRect">
+            <a:avLst>
+              <a:gd name="adj" fmla="val 50000"/>
+            </a:avLst>
+          </a:prstGeom>
+          <a:solidFill>
+            <a:srgbClr val="C9A227"/>
+          </a:solidFill>
+          <a:ln>
+            <a:noFill/>
+          </a:ln>
+        </p:spPr>
+        <p:txBody>
+          <a:bodyPr anchor="ctr" lIns="0" tIns="0" rIns="0" bIns="0"/>
+          <a:lstStyle/>
+          <a:p>
+            <a:pPr algn="ctr"/>
+            <a:r>
+              <a:rPr lang="en-US" sz="1000" b="1" dirty="0">
+                <a:solidFill>
+                  <a:srgbClr val="1B2A52"/>
+                </a:solidFill>
+                <a:latin typeface="Calibri"/>
+              </a:rPr>
+              <a:t>▶ Video</a:t>
+            </a:r>
           </a:p>
         </p:txBody>
       </p:sp>

</xml_diff>

<commit_message>
Restructure deck around five inline video segments
Replace the single video slide and watch-plan slide with five 'Video
Part' slides woven into the presentation flow at the presenter's pause
points (start-7:23 at slide 3, then 10:00, 12:00, 18:30, and 18:30-end),
each carrying its PowerPoint Trim Video settings and what to do when it
pauses. Content slides are reordered to follow each segment (guide
chapter after part 1, Sunday structure after part 2, last-Sunday lessons
after part 3, September/magazine after part 4, discussion after part 5).
The old jump-to-video nav buttons are removed since the video is now
inline. Deck is 23 slides.

Co-Authored-By: Claude Fable 5 <noreply@anthropic.com>
Claude-Session: https://claude.ai/code/session_01NQir395bsK1jUiLLBPYw8i
</commit_message>
<xml_diff>
--- a/new-sunday-youth-curriculum.pptx
+++ b/new-sunday-youth-curriculum.pptx
@@ -7,23 +7,26 @@
   <p:sldIdLst>
     <p:sldId id="256" r:id="rId2"/>
     <p:sldId id="257" r:id="rId3"/>
+    <p:sldId id="276" r:id="rId27"/>
+    <p:sldId id="261" r:id="rId7"/>
+    <p:sldId id="262" r:id="rId8"/>
+    <p:sldId id="263" r:id="rId9"/>
+    <p:sldId id="277" r:id="rId28"/>
     <p:sldId id="258" r:id="rId4"/>
     <p:sldId id="259" r:id="rId5"/>
     <p:sldId id="260" r:id="rId6"/>
-    <p:sldId id="261" r:id="rId7"/>
-    <p:sldId id="262" r:id="rId8"/>
-    <p:sldId id="263" r:id="rId9"/>
     <p:sldId id="264" r:id="rId10"/>
     <p:sldId id="265" r:id="rId11"/>
+    <p:sldId id="278" r:id="rId29"/>
+    <p:sldId id="269" r:id="rId15"/>
+    <p:sldId id="279" r:id="rId30"/>
     <p:sldId id="266" r:id="rId12"/>
     <p:sldId id="267" r:id="rId13"/>
     <p:sldId id="268" r:id="rId14"/>
-    <p:sldId id="269" r:id="rId15"/>
     <p:sldId id="270" r:id="rId16"/>
+    <p:sldId id="280" r:id="rId31"/>
+    <p:sldId id="274" r:id="rId20"/>
     <p:sldId id="271" r:id="rId17"/>
-    <p:sldId id="272" r:id="rId18"/>
-    <p:sldId id="273" r:id="rId19"/>
-    <p:sldId id="274" r:id="rId20"/>
     <p:sldId id="275" r:id="rId21"/>
   </p:sldIdLst>
   <p:notesMasterIdLst>
@@ -1161,182 +1164,6 @@
             <a:fld id="{F7021451-1387-4CA6-816F-3879F97B5CBC}" type="slidenum">
               <a:rPr lang="en-US"/>
               <a:t>16</a:t>
-            </a:fld>
-            <a:endParaRPr lang="en-US"/>
-          </a:p>
-        </p:txBody>
-      </p:sp>
-    </p:spTree>
-    <p:extLst>
-      <p:ext uri="{BB962C8B-B14F-4D97-AF65-F5344CB8AC3E}">
-        <p14:creationId xmlns:p14="http://schemas.microsoft.com/office/powerpoint/2010/main" val="1024086991"/>
-      </p:ext>
-    </p:extLst>
-  </p:cSld>
-  <p:clrMapOvr>
-    <a:masterClrMapping/>
-  </p:clrMapOvr>
-</p:notes>
-</file>
-
-<file path=ppt/notesSlides/notesSlide17.xml><?xml version="1.0" encoding="utf-8"?>
-<p:notes xmlns:a="http://schemas.openxmlformats.org/drawingml/2006/main" xmlns:r="http://schemas.openxmlformats.org/officeDocument/2006/relationships" xmlns:p="http://schemas.openxmlformats.org/presentationml/2006/main">
-  <p:cSld>
-    <p:spTree>
-      <p:nvGrpSpPr>
-        <p:cNvPr id="1" name=""/>
-        <p:cNvGrpSpPr/>
-        <p:nvPr/>
-      </p:nvGrpSpPr>
-      <p:grpSpPr>
-        <a:xfrm>
-          <a:off x="0" y="0"/>
-          <a:ext cx="0" cy="0"/>
-          <a:chOff x="0" y="0"/>
-          <a:chExt cx="0" cy="0"/>
-        </a:xfrm>
-      </p:grpSpPr>
-      <p:sp>
-        <p:nvSpPr>
-          <p:cNvPr id="2" name="Slide Image Placeholder 1"/>
-          <p:cNvSpPr>
-            <a:spLocks noGrp="1" noRot="1" noChangeAspect="1"/>
-          </p:cNvSpPr>
-          <p:nvPr>
-            <p:ph type="sldImg"/>
-          </p:nvPr>
-        </p:nvSpPr>
-        <p:spPr/>
-      </p:sp>
-      <p:sp>
-        <p:nvSpPr>
-          <p:cNvPr id="3" name="Notes Placeholder 2"/>
-          <p:cNvSpPr>
-            <a:spLocks noGrp="1"/>
-          </p:cNvSpPr>
-          <p:nvPr>
-            <p:ph type="body" idx="1"/>
-          </p:nvPr>
-        </p:nvSpPr>
-        <p:spPr/>
-        <p:txBody>
-          <a:bodyPr/>
-          <a:lstStyle/>
-          <a:p>
-            <a:r>
-              <a:rPr lang="en-US" dirty="0"/>
-              <a:t>Have the video queued in Gospel Library before the meeting. Your watch plan: stop at 7:20 — discuss, then ask why they think the FSY guide is structured this way (truths, invitations, promised blessings). At 10:00, talk through the structure of the Sundays — you can flip back to the monthly-rhythm slide if helpful. At 12:00, cover the last-Sunday split lessons for Young Women and Aaronic Priesthood quorums. Stop again at 18:30 to discuss. At 22:00, ask what statements stood out to them. Then move to the discussion-questions slide.</a:t>
-            </a:r>
-            <a:endParaRPr lang="en-US" dirty="0"/>
-          </a:p>
-        </p:txBody>
-      </p:sp>
-      <p:sp>
-        <p:nvSpPr>
-          <p:cNvPr id="4" name="Slide Number Placeholder 3"/>
-          <p:cNvSpPr>
-            <a:spLocks noGrp="1"/>
-          </p:cNvSpPr>
-          <p:nvPr>
-            <p:ph type="sldNum" sz="quarter" idx="10"/>
-          </p:nvPr>
-        </p:nvSpPr>
-        <p:spPr/>
-        <p:txBody>
-          <a:bodyPr/>
-          <a:lstStyle/>
-          <a:p>
-            <a:fld id="{F7021451-1387-4CA6-816F-3879F97B5CBC}" type="slidenum">
-              <a:rPr lang="en-US"/>
-              <a:t>17</a:t>
-            </a:fld>
-            <a:endParaRPr lang="en-US"/>
-          </a:p>
-        </p:txBody>
-      </p:sp>
-    </p:spTree>
-    <p:extLst>
-      <p:ext uri="{BB962C8B-B14F-4D97-AF65-F5344CB8AC3E}">
-        <p14:creationId xmlns:p14="http://schemas.microsoft.com/office/powerpoint/2010/main" val="1024086991"/>
-      </p:ext>
-    </p:extLst>
-  </p:cSld>
-  <p:clrMapOvr>
-    <a:masterClrMapping/>
-  </p:clrMapOvr>
-</p:notes>
-</file>
-
-<file path=ppt/notesSlides/notesSlide18.xml><?xml version="1.0" encoding="utf-8"?>
-<p:notes xmlns:a="http://schemas.openxmlformats.org/drawingml/2006/main" xmlns:r="http://schemas.openxmlformats.org/officeDocument/2006/relationships" xmlns:p="http://schemas.openxmlformats.org/presentationml/2006/main">
-  <p:cSld>
-    <p:spTree>
-      <p:nvGrpSpPr>
-        <p:cNvPr id="1" name=""/>
-        <p:cNvGrpSpPr/>
-        <p:nvPr/>
-      </p:nvGrpSpPr>
-      <p:grpSpPr>
-        <a:xfrm>
-          <a:off x="0" y="0"/>
-          <a:ext cx="0" cy="0"/>
-          <a:chOff x="0" y="0"/>
-          <a:chExt cx="0" cy="0"/>
-        </a:xfrm>
-      </p:grpSpPr>
-      <p:sp>
-        <p:nvSpPr>
-          <p:cNvPr id="2" name="Slide Image Placeholder 1"/>
-          <p:cNvSpPr>
-            <a:spLocks noGrp="1" noRot="1" noChangeAspect="1"/>
-          </p:cNvSpPr>
-          <p:nvPr>
-            <p:ph type="sldImg"/>
-          </p:nvPr>
-        </p:nvSpPr>
-        <p:spPr/>
-      </p:sp>
-      <p:sp>
-        <p:nvSpPr>
-          <p:cNvPr id="3" name="Notes Placeholder 2"/>
-          <p:cNvSpPr>
-            <a:spLocks noGrp="1"/>
-          </p:cNvSpPr>
-          <p:nvPr>
-            <p:ph type="body" idx="1"/>
-          </p:nvPr>
-        </p:nvSpPr>
-        <p:spPr/>
-        <p:txBody>
-          <a:bodyPr/>
-          <a:lstStyle/>
-          <a:p>
-            <a:r>
-              <a:rPr lang="en-US" dirty="0"/>
-              <a:t>Embed the downloaded video here on your own computer: Insert, Video, This Device, then pick the file — it becomes part of the PowerPoint, no internet needed at church. Click to start; hover over the video for the scrub bar and pause at 7:20, 10:00, 12:00, 18:30, and 22:00 per the watch plan on the previous slide. Note: with the video embedded the file gets very large — present it from this computer rather than re-uploading it anywhere.</a:t>
-            </a:r>
-            <a:endParaRPr lang="en-US" dirty="0"/>
-          </a:p>
-        </p:txBody>
-      </p:sp>
-      <p:sp>
-        <p:nvSpPr>
-          <p:cNvPr id="4" name="Slide Number Placeholder 3"/>
-          <p:cNvSpPr>
-            <a:spLocks noGrp="1"/>
-          </p:cNvSpPr>
-          <p:nvPr>
-            <p:ph type="sldNum" sz="quarter" idx="10"/>
-          </p:nvPr>
-        </p:nvSpPr>
-        <p:spPr/>
-        <p:txBody>
-          <a:bodyPr/>
-          <a:lstStyle/>
-          <a:p>
-            <a:fld id="{F7021451-1387-4CA6-816F-3879F97B5CBC}" type="slidenum">
-              <a:rPr lang="en-US"/>
-              <a:t>18</a:t>
             </a:fld>
             <a:endParaRPr lang="en-US"/>
           </a:p>
@@ -2941,48 +2768,6 @@
           </a:p>
         </p:txBody>
       </p:sp>
-      <p:sp>
-        <p:nvSpPr>
-          <p:cNvPr id="951" name="NavButton951">
-            <a:hlinkClick r:id="rId4" action="ppaction://hlinksldjump"/>
-          </p:cNvPr>
-          <p:cNvSpPr/>
-          <p:nvPr/>
-        </p:nvSpPr>
-        <p:spPr>
-          <a:xfrm>
-            <a:off x="11137392" y="6419088"/>
-            <a:ext cx="914400" cy="329184"/>
-          </a:xfrm>
-          <a:prstGeom prst="roundRect">
-            <a:avLst>
-              <a:gd name="adj" fmla="val 50000"/>
-            </a:avLst>
-          </a:prstGeom>
-          <a:solidFill>
-            <a:srgbClr val="C9A227"/>
-          </a:solidFill>
-          <a:ln>
-            <a:noFill/>
-          </a:ln>
-        </p:spPr>
-        <p:txBody>
-          <a:bodyPr anchor="ctr" lIns="0" tIns="0" rIns="0" bIns="0"/>
-          <a:lstStyle/>
-          <a:p>
-            <a:pPr algn="ctr"/>
-            <a:r>
-              <a:rPr lang="en-US" sz="1000" b="1" dirty="0">
-                <a:solidFill>
-                  <a:srgbClr val="1B2A52"/>
-                </a:solidFill>
-                <a:latin typeface="Calibri"/>
-              </a:rPr>
-              <a:t>▶ Video</a:t>
-            </a:r>
-          </a:p>
-        </p:txBody>
-      </p:sp>
     </p:spTree>
   </p:cSld>
   <p:clrMapOvr>
@@ -4004,48 +3789,6 @@
           </a:p>
         </p:txBody>
       </p:sp>
-      <p:sp>
-        <p:nvSpPr>
-          <p:cNvPr id="951" name="NavButton951">
-            <a:hlinkClick r:id="rId8" action="ppaction://hlinksldjump"/>
-          </p:cNvPr>
-          <p:cNvSpPr/>
-          <p:nvPr/>
-        </p:nvSpPr>
-        <p:spPr>
-          <a:xfrm>
-            <a:off x="11137392" y="6419088"/>
-            <a:ext cx="914400" cy="329184"/>
-          </a:xfrm>
-          <a:prstGeom prst="roundRect">
-            <a:avLst>
-              <a:gd name="adj" fmla="val 50000"/>
-            </a:avLst>
-          </a:prstGeom>
-          <a:solidFill>
-            <a:srgbClr val="C9A227"/>
-          </a:solidFill>
-          <a:ln>
-            <a:noFill/>
-          </a:ln>
-        </p:spPr>
-        <p:txBody>
-          <a:bodyPr anchor="ctr" lIns="0" tIns="0" rIns="0" bIns="0"/>
-          <a:lstStyle/>
-          <a:p>
-            <a:pPr algn="ctr"/>
-            <a:r>
-              <a:rPr lang="en-US" sz="1000" b="1" dirty="0">
-                <a:solidFill>
-                  <a:srgbClr val="1B2A52"/>
-                </a:solidFill>
-                <a:latin typeface="Calibri"/>
-              </a:rPr>
-              <a:t>▶ Video</a:t>
-            </a:r>
-          </a:p>
-        </p:txBody>
-      </p:sp>
     </p:spTree>
   </p:cSld>
   <p:clrMapOvr>
@@ -5199,48 +4942,6 @@
           </a:p>
         </p:txBody>
       </p:sp>
-      <p:sp>
-        <p:nvSpPr>
-          <p:cNvPr id="951" name="NavButton951">
-            <a:hlinkClick r:id="rId4" action="ppaction://hlinksldjump"/>
-          </p:cNvPr>
-          <p:cNvSpPr/>
-          <p:nvPr/>
-        </p:nvSpPr>
-        <p:spPr>
-          <a:xfrm>
-            <a:off x="11137392" y="6419088"/>
-            <a:ext cx="914400" cy="329184"/>
-          </a:xfrm>
-          <a:prstGeom prst="roundRect">
-            <a:avLst>
-              <a:gd name="adj" fmla="val 50000"/>
-            </a:avLst>
-          </a:prstGeom>
-          <a:solidFill>
-            <a:srgbClr val="C9A227"/>
-          </a:solidFill>
-          <a:ln>
-            <a:noFill/>
-          </a:ln>
-        </p:spPr>
-        <p:txBody>
-          <a:bodyPr anchor="ctr" lIns="0" tIns="0" rIns="0" bIns="0"/>
-          <a:lstStyle/>
-          <a:p>
-            <a:pPr algn="ctr"/>
-            <a:r>
-              <a:rPr lang="en-US" sz="1000" b="1" dirty="0">
-                <a:solidFill>
-                  <a:srgbClr val="1B2A52"/>
-                </a:solidFill>
-                <a:latin typeface="Calibri"/>
-              </a:rPr>
-              <a:t>▶ Video</a:t>
-            </a:r>
-          </a:p>
-        </p:txBody>
-      </p:sp>
     </p:spTree>
   </p:cSld>
   <p:clrMapOvr>
@@ -5482,48 +5183,6 @@
           </a:p>
         </p:txBody>
       </p:sp>
-      <p:sp>
-        <p:nvSpPr>
-          <p:cNvPr id="951" name="NavButton951">
-            <a:hlinkClick r:id="rId5" action="ppaction://hlinksldjump"/>
-          </p:cNvPr>
-          <p:cNvSpPr/>
-          <p:nvPr/>
-        </p:nvSpPr>
-        <p:spPr>
-          <a:xfrm>
-            <a:off x="11137392" y="6419088"/>
-            <a:ext cx="914400" cy="329184"/>
-          </a:xfrm>
-          <a:prstGeom prst="roundRect">
-            <a:avLst>
-              <a:gd name="adj" fmla="val 50000"/>
-            </a:avLst>
-          </a:prstGeom>
-          <a:solidFill>
-            <a:srgbClr val="C9A227"/>
-          </a:solidFill>
-          <a:ln>
-            <a:noFill/>
-          </a:ln>
-        </p:spPr>
-        <p:txBody>
-          <a:bodyPr anchor="ctr" lIns="0" tIns="0" rIns="0" bIns="0"/>
-          <a:lstStyle/>
-          <a:p>
-            <a:pPr algn="ctr"/>
-            <a:r>
-              <a:rPr lang="en-US" sz="1000" b="1" dirty="0">
-                <a:solidFill>
-                  <a:srgbClr val="1B2A52"/>
-                </a:solidFill>
-                <a:latin typeface="Calibri"/>
-              </a:rPr>
-              <a:t>▶ Video</a:t>
-            </a:r>
-          </a:p>
-        </p:txBody>
-      </p:sp>
     </p:spTree>
   </p:cSld>
   <p:clrMapOvr>
@@ -5765,48 +5424,6 @@
           </a:p>
         </p:txBody>
       </p:sp>
-      <p:sp>
-        <p:nvSpPr>
-          <p:cNvPr id="951" name="NavButton951">
-            <a:hlinkClick r:id="rId5" action="ppaction://hlinksldjump"/>
-          </p:cNvPr>
-          <p:cNvSpPr/>
-          <p:nvPr/>
-        </p:nvSpPr>
-        <p:spPr>
-          <a:xfrm>
-            <a:off x="11137392" y="6419088"/>
-            <a:ext cx="914400" cy="329184"/>
-          </a:xfrm>
-          <a:prstGeom prst="roundRect">
-            <a:avLst>
-              <a:gd name="adj" fmla="val 50000"/>
-            </a:avLst>
-          </a:prstGeom>
-          <a:solidFill>
-            <a:srgbClr val="C9A227"/>
-          </a:solidFill>
-          <a:ln>
-            <a:noFill/>
-          </a:ln>
-        </p:spPr>
-        <p:txBody>
-          <a:bodyPr anchor="ctr" lIns="0" tIns="0" rIns="0" bIns="0"/>
-          <a:lstStyle/>
-          <a:p>
-            <a:pPr algn="ctr"/>
-            <a:r>
-              <a:rPr lang="en-US" sz="1000" b="1" dirty="0">
-                <a:solidFill>
-                  <a:srgbClr val="1B2A52"/>
-                </a:solidFill>
-                <a:latin typeface="Calibri"/>
-              </a:rPr>
-              <a:t>▶ Video</a:t>
-            </a:r>
-          </a:p>
-        </p:txBody>
-      </p:sp>
     </p:spTree>
   </p:cSld>
   <p:clrMapOvr>
@@ -6048,48 +5665,6 @@
           </a:p>
         </p:txBody>
       </p:sp>
-      <p:sp>
-        <p:nvSpPr>
-          <p:cNvPr id="951" name="NavButton951">
-            <a:hlinkClick r:id="rId5" action="ppaction://hlinksldjump"/>
-          </p:cNvPr>
-          <p:cNvSpPr/>
-          <p:nvPr/>
-        </p:nvSpPr>
-        <p:spPr>
-          <a:xfrm>
-            <a:off x="11137392" y="6419088"/>
-            <a:ext cx="914400" cy="329184"/>
-          </a:xfrm>
-          <a:prstGeom prst="roundRect">
-            <a:avLst>
-              <a:gd name="adj" fmla="val 50000"/>
-            </a:avLst>
-          </a:prstGeom>
-          <a:solidFill>
-            <a:srgbClr val="C9A227"/>
-          </a:solidFill>
-          <a:ln>
-            <a:noFill/>
-          </a:ln>
-        </p:spPr>
-        <p:txBody>
-          <a:bodyPr anchor="ctr" lIns="0" tIns="0" rIns="0" bIns="0"/>
-          <a:lstStyle/>
-          <a:p>
-            <a:pPr algn="ctr"/>
-            <a:r>
-              <a:rPr lang="en-US" sz="1000" b="1" dirty="0">
-                <a:solidFill>
-                  <a:srgbClr val="1B2A52"/>
-                </a:solidFill>
-                <a:latin typeface="Calibri"/>
-              </a:rPr>
-              <a:t>▶ Video</a:t>
-            </a:r>
-          </a:p>
-        </p:txBody>
-      </p:sp>
     </p:spTree>
   </p:cSld>
   <p:clrMapOvr>
@@ -6331,48 +5906,6 @@
           </a:p>
         </p:txBody>
       </p:sp>
-      <p:sp>
-        <p:nvSpPr>
-          <p:cNvPr id="951" name="NavButton951">
-            <a:hlinkClick r:id="rId5" action="ppaction://hlinksldjump"/>
-          </p:cNvPr>
-          <p:cNvSpPr/>
-          <p:nvPr/>
-        </p:nvSpPr>
-        <p:spPr>
-          <a:xfrm>
-            <a:off x="11137392" y="6419088"/>
-            <a:ext cx="914400" cy="329184"/>
-          </a:xfrm>
-          <a:prstGeom prst="roundRect">
-            <a:avLst>
-              <a:gd name="adj" fmla="val 50000"/>
-            </a:avLst>
-          </a:prstGeom>
-          <a:solidFill>
-            <a:srgbClr val="C9A227"/>
-          </a:solidFill>
-          <a:ln>
-            <a:noFill/>
-          </a:ln>
-        </p:spPr>
-        <p:txBody>
-          <a:bodyPr anchor="ctr" lIns="0" tIns="0" rIns="0" bIns="0"/>
-          <a:lstStyle/>
-          <a:p>
-            <a:pPr algn="ctr"/>
-            <a:r>
-              <a:rPr lang="en-US" sz="1000" b="1" dirty="0">
-                <a:solidFill>
-                  <a:srgbClr val="1B2A52"/>
-                </a:solidFill>
-                <a:latin typeface="Calibri"/>
-              </a:rPr>
-              <a:t>▶ Video</a:t>
-            </a:r>
-          </a:p>
-        </p:txBody>
-      </p:sp>
     </p:spTree>
   </p:cSld>
   <p:clrMapOvr>
@@ -7256,1337 +6789,6 @@
           </a:p>
         </p:txBody>
       </p:sp>
-      <p:sp>
-        <p:nvSpPr>
-          <p:cNvPr id="951" name="NavButton951">
-            <a:hlinkClick r:id="rId8" action="ppaction://hlinksldjump"/>
-          </p:cNvPr>
-          <p:cNvSpPr/>
-          <p:nvPr/>
-        </p:nvSpPr>
-        <p:spPr>
-          <a:xfrm>
-            <a:off x="11137392" y="6419088"/>
-            <a:ext cx="914400" cy="329184"/>
-          </a:xfrm>
-          <a:prstGeom prst="roundRect">
-            <a:avLst>
-              <a:gd name="adj" fmla="val 50000"/>
-            </a:avLst>
-          </a:prstGeom>
-          <a:solidFill>
-            <a:srgbClr val="C9A227"/>
-          </a:solidFill>
-          <a:ln>
-            <a:noFill/>
-          </a:ln>
-        </p:spPr>
-        <p:txBody>
-          <a:bodyPr anchor="ctr" lIns="0" tIns="0" rIns="0" bIns="0"/>
-          <a:lstStyle/>
-          <a:p>
-            <a:pPr algn="ctr"/>
-            <a:r>
-              <a:rPr lang="en-US" sz="1000" b="1" dirty="0">
-                <a:solidFill>
-                  <a:srgbClr val="1B2A52"/>
-                </a:solidFill>
-                <a:latin typeface="Calibri"/>
-              </a:rPr>
-              <a:t>▶ Video</a:t>
-            </a:r>
-          </a:p>
-        </p:txBody>
-      </p:sp>
-    </p:spTree>
-  </p:cSld>
-  <p:clrMapOvr>
-    <a:masterClrMapping/>
-  </p:clrMapOvr>
-</p:sld>
-</file>
-
-<file path=ppt/slides/slide17.xml><?xml version="1.0" encoding="utf-8"?>
-<p:sld xmlns:a="http://schemas.openxmlformats.org/drawingml/2006/main" xmlns:r="http://schemas.openxmlformats.org/officeDocument/2006/relationships" xmlns:p="http://schemas.openxmlformats.org/presentationml/2006/main">
-  <p:cSld name="Slide 17">
-    <p:bg>
-      <p:bgPr>
-        <a:solidFill>
-          <a:srgbClr val="1B2A52"/>
-        </a:solidFill>
-      </p:bgPr>
-    </p:bg>
-    <p:spTree>
-      <p:nvGrpSpPr>
-        <p:cNvPr id="1" name=""/>
-        <p:cNvGrpSpPr/>
-        <p:nvPr/>
-      </p:nvGrpSpPr>
-      <p:grpSpPr>
-        <a:xfrm>
-          <a:off x="0" y="0"/>
-          <a:ext cx="0" cy="0"/>
-          <a:chOff x="0" y="0"/>
-          <a:chExt cx="0" cy="0"/>
-        </a:xfrm>
-      </p:grpSpPr>
-      <p:sp>
-        <p:nvSpPr>
-          <p:cNvPr id="2" name="Shape 0"/>
-          <p:cNvSpPr/>
-          <p:nvPr/>
-        </p:nvSpPr>
-        <p:spPr>
-          <a:xfrm>
-            <a:off x="9052560" y="-1920240"/>
-            <a:ext cx="4937760" cy="4937760"/>
-          </a:xfrm>
-          <a:prstGeom prst="ellipse">
-            <a:avLst/>
-          </a:prstGeom>
-          <a:ln w="19050">
-            <a:solidFill>
-              <a:srgbClr val="31437A"/>
-            </a:solidFill>
-            <a:prstDash val="solid"/>
-          </a:ln>
-        </p:spPr>
-      </p:sp>
-      <p:sp>
-        <p:nvSpPr>
-          <p:cNvPr id="3" name="Shape 1"/>
-          <p:cNvSpPr/>
-          <p:nvPr/>
-        </p:nvSpPr>
-        <p:spPr>
-          <a:xfrm>
-            <a:off x="-1463040" y="4572000"/>
-            <a:ext cx="4023360" cy="4023360"/>
-          </a:xfrm>
-          <a:prstGeom prst="ellipse">
-            <a:avLst/>
-          </a:prstGeom>
-          <a:ln w="19050">
-            <a:solidFill>
-              <a:srgbClr val="31437A"/>
-            </a:solidFill>
-            <a:prstDash val="solid"/>
-          </a:ln>
-        </p:spPr>
-      </p:sp>
-      <p:sp>
-        <p:nvSpPr>
-          <p:cNvPr id="4" name="Text 2"/>
-          <p:cNvSpPr txBox="1"/>
-          <p:nvPr/>
-        </p:nvSpPr>
-        <p:spPr>
-          <a:xfrm>
-            <a:off x="548640" y="438912"/>
-            <a:ext cx="11064240" cy="292608"/>
-          </a:xfrm>
-          <a:prstGeom prst="rect">
-            <a:avLst/>
-          </a:prstGeom>
-          <a:noFill/>
-          <a:ln/>
-        </p:spPr>
-        <p:txBody>
-          <a:bodyPr wrap="square" lIns="0" tIns="0" rIns="0" bIns="0" rtlCol="0" anchor="ctr"/>
-          <a:lstStyle/>
-          <a:p>
-            <a:pPr algn="l" indent="0" marL="0">
-              <a:buNone/>
-            </a:pPr>
-            <a:r>
-              <a:rPr lang="en-US" sz="1200" b="1" spc="300" kern="0" dirty="0">
-                <a:solidFill>
-                  <a:srgbClr val="C9A227"/>
-                </a:solidFill>
-                <a:latin typeface="Calibri" pitchFamily="34" charset="0"/>
-                <a:ea typeface="Calibri" pitchFamily="34" charset="-122"/>
-                <a:cs typeface="Calibri" pitchFamily="34" charset="-120"/>
-              </a:rPr>
-              <a:t>WATCH TOGETHER  ·  WE'LL STOP ALONG THE WAY</a:t>
-            </a:r>
-            <a:endParaRPr lang="en-US" sz="1200" dirty="0"/>
-          </a:p>
-        </p:txBody>
-      </p:sp>
-      <p:sp>
-        <p:nvSpPr>
-          <p:cNvPr id="5" name="Text 3"/>
-          <p:cNvSpPr txBox="1"/>
-          <p:nvPr/>
-        </p:nvSpPr>
-        <p:spPr>
-          <a:xfrm>
-            <a:off x="548640" y="749808"/>
-            <a:ext cx="11064240" cy="731520"/>
-          </a:xfrm>
-          <a:prstGeom prst="rect">
-            <a:avLst/>
-          </a:prstGeom>
-          <a:noFill/>
-          <a:ln/>
-        </p:spPr>
-        <p:txBody>
-          <a:bodyPr wrap="square" lIns="0" tIns="0" rIns="0" bIns="0" rtlCol="0" anchor="ctr"/>
-          <a:lstStyle/>
-          <a:p>
-            <a:pPr algn="l" indent="0" marL="0">
-              <a:buNone/>
-            </a:pPr>
-            <a:r>
-              <a:rPr lang="en-US" sz="3400" b="1" dirty="0">
-                <a:solidFill>
-                  <a:srgbClr val="FFFFFF"/>
-                </a:solidFill>
-                <a:latin typeface="Cambria" pitchFamily="34" charset="0"/>
-                <a:ea typeface="Cambria" pitchFamily="34" charset="-122"/>
-                <a:cs typeface="Cambria" pitchFamily="34" charset="-120"/>
-              </a:rPr>
-              <a:t>The Instructional Video</a:t>
-            </a:r>
-            <a:endParaRPr lang="en-US" sz="3400" dirty="0"/>
-          </a:p>
-        </p:txBody>
-      </p:sp>
-      <p:sp>
-        <p:nvSpPr>
-          <p:cNvPr id="6" name="Shape 4"/>
-          <p:cNvSpPr/>
-          <p:nvPr/>
-        </p:nvSpPr>
-        <p:spPr>
-          <a:xfrm>
-            <a:off x="1051560" y="2103120"/>
-            <a:ext cx="1371600" cy="1371600"/>
-          </a:xfrm>
-          <a:prstGeom prst="ellipse">
-            <a:avLst/>
-          </a:prstGeom>
-          <a:solidFill>
-            <a:srgbClr val="C9A227"/>
-          </a:solidFill>
-          <a:ln/>
-        </p:spPr>
-      </p:sp>
-      <p:pic>
-        <p:nvPicPr>
-          <p:cNvPr id="7" name="Image 0" descr="preencoded.png">    </p:cNvPr>
-          <p:cNvPicPr>
-            <a:picLocks noChangeAspect="1"/>
-          </p:cNvPicPr>
-          <p:nvPr/>
-        </p:nvPicPr>
-        <p:blipFill>
-          <a:blip r:embed="rId1"/>
-          <a:stretch>
-            <a:fillRect/>
-          </a:stretch>
-        </p:blipFill>
-        <p:spPr>
-          <a:xfrm>
-            <a:off x="1536192" y="2542032"/>
-            <a:ext cx="493776" cy="493776"/>
-          </a:xfrm>
-          <a:prstGeom prst="rect">
-            <a:avLst/>
-          </a:prstGeom>
-        </p:spPr>
-      </p:pic>
-      <p:sp>
-        <p:nvSpPr>
-          <p:cNvPr id="8" name="Text 5"/>
-          <p:cNvSpPr txBox="1"/>
-          <p:nvPr/>
-        </p:nvSpPr>
-        <p:spPr>
-          <a:xfrm>
-            <a:off x="566928" y="3794760"/>
-            <a:ext cx="3200400" cy="1005840"/>
-          </a:xfrm>
-          <a:prstGeom prst="rect">
-            <a:avLst/>
-          </a:prstGeom>
-          <a:noFill/>
-          <a:ln/>
-        </p:spPr>
-        <p:txBody>
-          <a:bodyPr wrap="square" lIns="0" tIns="0" rIns="0" bIns="0" rtlCol="0" anchor="ctr"/>
-          <a:lstStyle/>
-          <a:p>
-            <a:pPr indent="0" marL="0">
-              <a:buNone/>
-            </a:pPr>
-            <a:r>
-              <a:rPr lang="en-US" sz="1250" dirty="0">
-                <a:solidFill>
-                  <a:srgbClr val="FFFFFF"/>
-                </a:solidFill>
-                <a:latin typeface="Calibri" pitchFamily="34" charset="0"/>
-                <a:ea typeface="Calibri" pitchFamily="34" charset="-122"/>
-                <a:cs typeface="Calibri" pitchFamily="34" charset="-120"/>
-              </a:rPr>
-              <a:t>A message from President Timothy L. Farnes and President Emily Belle Freeman.</a:t>
-            </a:r>
-            <a:endParaRPr lang="en-US" sz="1250" dirty="0"/>
-          </a:p>
-        </p:txBody>
-      </p:sp>
-      <p:sp>
-        <p:nvSpPr>
-          <p:cNvPr id="9" name="Text 6"/>
-          <p:cNvSpPr txBox="1"/>
-          <p:nvPr/>
-        </p:nvSpPr>
-        <p:spPr>
-          <a:xfrm>
-            <a:off x="566928" y="4892040"/>
-            <a:ext cx="3200400" cy="1097280"/>
-          </a:xfrm>
-          <a:prstGeom prst="rect">
-            <a:avLst/>
-          </a:prstGeom>
-          <a:noFill/>
-          <a:ln/>
-        </p:spPr>
-        <p:txBody>
-          <a:bodyPr wrap="square" lIns="0" tIns="0" rIns="0" bIns="0" rtlCol="0" anchor="ctr"/>
-          <a:lstStyle/>
-          <a:p>
-            <a:pPr indent="0" marL="0">
-              <a:buNone/>
-            </a:pPr>
-            <a:r>
-              <a:rPr lang="en-US" sz="1050" dirty="0">
-                <a:solidFill>
-                  <a:srgbClr val="8FA0C8"/>
-                </a:solidFill>
-                <a:latin typeface="Calibri" pitchFamily="34" charset="0"/>
-                <a:ea typeface="Calibri" pitchFamily="34" charset="-122"/>
-                <a:cs typeface="Calibri" pitchFamily="34" charset="-120"/>
-              </a:rPr>
-              <a:t>Gospel Library → Changes to the Sunday Class Meeting Schedule → Youth Fifth-Sunday Instruction Materials</a:t>
-            </a:r>
-            <a:endParaRPr lang="en-US" sz="1050" dirty="0"/>
-          </a:p>
-        </p:txBody>
-      </p:sp>
-      <p:sp>
-        <p:nvSpPr>
-          <p:cNvPr id="10" name="Shape 7"/>
-          <p:cNvSpPr/>
-          <p:nvPr/>
-        </p:nvSpPr>
-        <p:spPr>
-          <a:xfrm>
-            <a:off x="4160520" y="1691640"/>
-            <a:ext cx="7498080" cy="795528"/>
-          </a:xfrm>
-          <a:prstGeom prst="roundRect">
-            <a:avLst>
-              <a:gd name="adj" fmla="val 11494"/>
-            </a:avLst>
-          </a:prstGeom>
-          <a:solidFill>
-            <a:srgbClr val="24356B"/>
-          </a:solidFill>
-          <a:ln/>
-        </p:spPr>
-      </p:sp>
-      <p:sp>
-        <p:nvSpPr>
-          <p:cNvPr id="11" name="Shape 8"/>
-          <p:cNvSpPr/>
-          <p:nvPr/>
-        </p:nvSpPr>
-        <p:spPr>
-          <a:xfrm>
-            <a:off x="4343400" y="1856232"/>
-            <a:ext cx="868680" cy="457200"/>
-          </a:xfrm>
-          <a:prstGeom prst="roundRect">
-            <a:avLst>
-              <a:gd name="adj" fmla="val 16000"/>
-            </a:avLst>
-          </a:prstGeom>
-          <a:solidFill>
-            <a:srgbClr val="C9A227"/>
-          </a:solidFill>
-          <a:ln/>
-        </p:spPr>
-      </p:sp>
-      <p:sp>
-        <p:nvSpPr>
-          <p:cNvPr id="12" name="Text 9"/>
-          <p:cNvSpPr txBox="1"/>
-          <p:nvPr/>
-        </p:nvSpPr>
-        <p:spPr>
-          <a:xfrm>
-            <a:off x="4343400" y="1856232"/>
-            <a:ext cx="868680" cy="457200"/>
-          </a:xfrm>
-          <a:prstGeom prst="rect">
-            <a:avLst/>
-          </a:prstGeom>
-          <a:noFill/>
-          <a:ln/>
-        </p:spPr>
-        <p:txBody>
-          <a:bodyPr wrap="square" lIns="0" tIns="0" rIns="0" bIns="0" rtlCol="0" anchor="ctr"/>
-          <a:lstStyle/>
-          <a:p>
-            <a:pPr algn="ctr" indent="0" marL="0">
-              <a:buNone/>
-            </a:pPr>
-            <a:r>
-              <a:rPr lang="en-US" sz="1250" b="1" dirty="0">
-                <a:solidFill>
-                  <a:srgbClr val="1B2A52"/>
-                </a:solidFill>
-                <a:latin typeface="Calibri" pitchFamily="34" charset="0"/>
-                <a:ea typeface="Calibri" pitchFamily="34" charset="-122"/>
-                <a:cs typeface="Calibri" pitchFamily="34" charset="-120"/>
-              </a:rPr>
-              <a:t>7:20</a:t>
-            </a:r>
-            <a:endParaRPr lang="en-US" sz="1250" dirty="0"/>
-          </a:p>
-        </p:txBody>
-      </p:sp>
-      <p:sp>
-        <p:nvSpPr>
-          <p:cNvPr id="13" name="Text 10"/>
-          <p:cNvSpPr txBox="1"/>
-          <p:nvPr/>
-        </p:nvSpPr>
-        <p:spPr>
-          <a:xfrm>
-            <a:off x="5394960" y="1783080"/>
-            <a:ext cx="6126480" cy="621792"/>
-          </a:xfrm>
-          <a:prstGeom prst="rect">
-            <a:avLst/>
-          </a:prstGeom>
-          <a:noFill/>
-          <a:ln/>
-        </p:spPr>
-        <p:txBody>
-          <a:bodyPr wrap="square" lIns="0" tIns="0" rIns="0" bIns="0" rtlCol="0" anchor="ctr"/>
-          <a:lstStyle/>
-          <a:p>
-            <a:pPr indent="0" marL="0">
-              <a:buNone/>
-            </a:pPr>
-            <a:r>
-              <a:rPr lang="en-US" sz="1200" b="1" dirty="0">
-                <a:solidFill>
-                  <a:srgbClr val="FFFFFF"/>
-                </a:solidFill>
-                <a:latin typeface="Calibri" pitchFamily="34" charset="0"/>
-                <a:ea typeface="Calibri" pitchFamily="34" charset="-122"/>
-                <a:cs typeface="Calibri" pitchFamily="34" charset="-120"/>
-              </a:rPr>
-              <a:t>Pause and discuss — </a:t>
-            </a:r>
-            <a:pPr indent="0" marL="0">
-              <a:buNone/>
-            </a:pPr>
-            <a:r>
-              <a:rPr lang="en-US" sz="1200" dirty="0">
-                <a:solidFill>
-                  <a:srgbClr val="C9D6EF"/>
-                </a:solidFill>
-                <a:latin typeface="Calibri" pitchFamily="34" charset="0"/>
-                <a:ea typeface="Calibri" pitchFamily="34" charset="-122"/>
-                <a:cs typeface="Calibri" pitchFamily="34" charset="-120"/>
-              </a:rPr>
-              <a:t>Then ask: “Why do you think the FSY guide is structured this way?”</a:t>
-            </a:r>
-            <a:endParaRPr lang="en-US" sz="1200" dirty="0"/>
-          </a:p>
-        </p:txBody>
-      </p:sp>
-      <p:sp>
-        <p:nvSpPr>
-          <p:cNvPr id="14" name="Shape 11"/>
-          <p:cNvSpPr/>
-          <p:nvPr/>
-        </p:nvSpPr>
-        <p:spPr>
-          <a:xfrm>
-            <a:off x="4160520" y="2624328"/>
-            <a:ext cx="7498080" cy="795528"/>
-          </a:xfrm>
-          <a:prstGeom prst="roundRect">
-            <a:avLst>
-              <a:gd name="adj" fmla="val 11494"/>
-            </a:avLst>
-          </a:prstGeom>
-          <a:solidFill>
-            <a:srgbClr val="24356B"/>
-          </a:solidFill>
-          <a:ln/>
-        </p:spPr>
-      </p:sp>
-      <p:sp>
-        <p:nvSpPr>
-          <p:cNvPr id="15" name="Shape 12"/>
-          <p:cNvSpPr/>
-          <p:nvPr/>
-        </p:nvSpPr>
-        <p:spPr>
-          <a:xfrm>
-            <a:off x="4343400" y="2788920"/>
-            <a:ext cx="868680" cy="457200"/>
-          </a:xfrm>
-          <a:prstGeom prst="roundRect">
-            <a:avLst>
-              <a:gd name="adj" fmla="val 16000"/>
-            </a:avLst>
-          </a:prstGeom>
-          <a:solidFill>
-            <a:srgbClr val="C9A227"/>
-          </a:solidFill>
-          <a:ln/>
-        </p:spPr>
-      </p:sp>
-      <p:sp>
-        <p:nvSpPr>
-          <p:cNvPr id="16" name="Text 13"/>
-          <p:cNvSpPr txBox="1"/>
-          <p:nvPr/>
-        </p:nvSpPr>
-        <p:spPr>
-          <a:xfrm>
-            <a:off x="4343400" y="2788920"/>
-            <a:ext cx="868680" cy="457200"/>
-          </a:xfrm>
-          <a:prstGeom prst="rect">
-            <a:avLst/>
-          </a:prstGeom>
-          <a:noFill/>
-          <a:ln/>
-        </p:spPr>
-        <p:txBody>
-          <a:bodyPr wrap="square" lIns="0" tIns="0" rIns="0" bIns="0" rtlCol="0" anchor="ctr"/>
-          <a:lstStyle/>
-          <a:p>
-            <a:pPr algn="ctr" indent="0" marL="0">
-              <a:buNone/>
-            </a:pPr>
-            <a:r>
-              <a:rPr lang="en-US" sz="1250" b="1" dirty="0">
-                <a:solidFill>
-                  <a:srgbClr val="1B2A52"/>
-                </a:solidFill>
-                <a:latin typeface="Calibri" pitchFamily="34" charset="0"/>
-                <a:ea typeface="Calibri" pitchFamily="34" charset="-122"/>
-                <a:cs typeface="Calibri" pitchFamily="34" charset="-120"/>
-              </a:rPr>
-              <a:t>10:00</a:t>
-            </a:r>
-            <a:endParaRPr lang="en-US" sz="1250" dirty="0"/>
-          </a:p>
-        </p:txBody>
-      </p:sp>
-      <p:sp>
-        <p:nvSpPr>
-          <p:cNvPr id="17" name="Text 14"/>
-          <p:cNvSpPr txBox="1"/>
-          <p:nvPr/>
-        </p:nvSpPr>
-        <p:spPr>
-          <a:xfrm>
-            <a:off x="5394960" y="2715768"/>
-            <a:ext cx="6126480" cy="621792"/>
-          </a:xfrm>
-          <a:prstGeom prst="rect">
-            <a:avLst/>
-          </a:prstGeom>
-          <a:noFill/>
-          <a:ln/>
-        </p:spPr>
-        <p:txBody>
-          <a:bodyPr wrap="square" lIns="0" tIns="0" rIns="0" bIns="0" rtlCol="0" anchor="ctr"/>
-          <a:lstStyle/>
-          <a:p>
-            <a:pPr indent="0" marL="0">
-              <a:buNone/>
-            </a:pPr>
-            <a:r>
-              <a:rPr lang="en-US" sz="1200" b="1" dirty="0">
-                <a:solidFill>
-                  <a:srgbClr val="FFFFFF"/>
-                </a:solidFill>
-                <a:latin typeface="Calibri" pitchFamily="34" charset="0"/>
-                <a:ea typeface="Calibri" pitchFamily="34" charset="-122"/>
-                <a:cs typeface="Calibri" pitchFamily="34" charset="-120"/>
-              </a:rPr>
-              <a:t>The structure of the Sundays — </a:t>
-            </a:r>
-            <a:pPr indent="0" marL="0">
-              <a:buNone/>
-            </a:pPr>
-            <a:r>
-              <a:rPr lang="en-US" sz="1200" dirty="0">
-                <a:solidFill>
-                  <a:srgbClr val="C9D6EF"/>
-                </a:solidFill>
-                <a:latin typeface="Calibri" pitchFamily="34" charset="0"/>
-                <a:ea typeface="Calibri" pitchFamily="34" charset="-122"/>
-                <a:cs typeface="Calibri" pitchFamily="34" charset="-120"/>
-              </a:rPr>
-              <a:t>How the four weeks of each month fit together.</a:t>
-            </a:r>
-            <a:endParaRPr lang="en-US" sz="1200" dirty="0"/>
-          </a:p>
-        </p:txBody>
-      </p:sp>
-      <p:sp>
-        <p:nvSpPr>
-          <p:cNvPr id="18" name="Shape 15"/>
-          <p:cNvSpPr/>
-          <p:nvPr/>
-        </p:nvSpPr>
-        <p:spPr>
-          <a:xfrm>
-            <a:off x="4160520" y="3557016"/>
-            <a:ext cx="7498080" cy="795528"/>
-          </a:xfrm>
-          <a:prstGeom prst="roundRect">
-            <a:avLst>
-              <a:gd name="adj" fmla="val 11494"/>
-            </a:avLst>
-          </a:prstGeom>
-          <a:solidFill>
-            <a:srgbClr val="24356B"/>
-          </a:solidFill>
-          <a:ln/>
-        </p:spPr>
-      </p:sp>
-      <p:sp>
-        <p:nvSpPr>
-          <p:cNvPr id="19" name="Shape 16"/>
-          <p:cNvSpPr/>
-          <p:nvPr/>
-        </p:nvSpPr>
-        <p:spPr>
-          <a:xfrm>
-            <a:off x="4343400" y="3721608"/>
-            <a:ext cx="868680" cy="457200"/>
-          </a:xfrm>
-          <a:prstGeom prst="roundRect">
-            <a:avLst>
-              <a:gd name="adj" fmla="val 16000"/>
-            </a:avLst>
-          </a:prstGeom>
-          <a:solidFill>
-            <a:srgbClr val="C9A227"/>
-          </a:solidFill>
-          <a:ln/>
-        </p:spPr>
-      </p:sp>
-      <p:sp>
-        <p:nvSpPr>
-          <p:cNvPr id="20" name="Text 17"/>
-          <p:cNvSpPr txBox="1"/>
-          <p:nvPr/>
-        </p:nvSpPr>
-        <p:spPr>
-          <a:xfrm>
-            <a:off x="4343400" y="3721608"/>
-            <a:ext cx="868680" cy="457200"/>
-          </a:xfrm>
-          <a:prstGeom prst="rect">
-            <a:avLst/>
-          </a:prstGeom>
-          <a:noFill/>
-          <a:ln/>
-        </p:spPr>
-        <p:txBody>
-          <a:bodyPr wrap="square" lIns="0" tIns="0" rIns="0" bIns="0" rtlCol="0" anchor="ctr"/>
-          <a:lstStyle/>
-          <a:p>
-            <a:pPr algn="ctr" indent="0" marL="0">
-              <a:buNone/>
-            </a:pPr>
-            <a:r>
-              <a:rPr lang="en-US" sz="1250" b="1" dirty="0">
-                <a:solidFill>
-                  <a:srgbClr val="1B2A52"/>
-                </a:solidFill>
-                <a:latin typeface="Calibri" pitchFamily="34" charset="0"/>
-                <a:ea typeface="Calibri" pitchFamily="34" charset="-122"/>
-                <a:cs typeface="Calibri" pitchFamily="34" charset="-120"/>
-              </a:rPr>
-              <a:t>12:00</a:t>
-            </a:r>
-            <a:endParaRPr lang="en-US" sz="1250" dirty="0"/>
-          </a:p>
-        </p:txBody>
-      </p:sp>
-      <p:sp>
-        <p:nvSpPr>
-          <p:cNvPr id="21" name="Text 18"/>
-          <p:cNvSpPr txBox="1"/>
-          <p:nvPr/>
-        </p:nvSpPr>
-        <p:spPr>
-          <a:xfrm>
-            <a:off x="5394960" y="3648456"/>
-            <a:ext cx="6126480" cy="621792"/>
-          </a:xfrm>
-          <a:prstGeom prst="rect">
-            <a:avLst/>
-          </a:prstGeom>
-          <a:noFill/>
-          <a:ln/>
-        </p:spPr>
-        <p:txBody>
-          <a:bodyPr wrap="square" lIns="0" tIns="0" rIns="0" bIns="0" rtlCol="0" anchor="ctr"/>
-          <a:lstStyle/>
-          <a:p>
-            <a:pPr indent="0" marL="0">
-              <a:buNone/>
-            </a:pPr>
-            <a:r>
-              <a:rPr lang="en-US" sz="1200" b="1" dirty="0">
-                <a:solidFill>
-                  <a:srgbClr val="FFFFFF"/>
-                </a:solidFill>
-                <a:latin typeface="Calibri" pitchFamily="34" charset="0"/>
-                <a:ea typeface="Calibri" pitchFamily="34" charset="-122"/>
-                <a:cs typeface="Calibri" pitchFamily="34" charset="-120"/>
-              </a:rPr>
-              <a:t>The last-Sunday lessons — </a:t>
-            </a:r>
-            <a:pPr indent="0" marL="0">
-              <a:buNone/>
-            </a:pPr>
-            <a:r>
-              <a:rPr lang="en-US" sz="1200" dirty="0">
-                <a:solidFill>
-                  <a:srgbClr val="C9D6EF"/>
-                </a:solidFill>
-                <a:latin typeface="Calibri" pitchFamily="34" charset="0"/>
-                <a:ea typeface="Calibri" pitchFamily="34" charset="-122"/>
-                <a:cs typeface="Calibri" pitchFamily="34" charset="-120"/>
-              </a:rPr>
-              <a:t>Young Women and Aaronic Priesthood quorums each have their own.</a:t>
-            </a:r>
-            <a:endParaRPr lang="en-US" sz="1200" dirty="0"/>
-          </a:p>
-        </p:txBody>
-      </p:sp>
-      <p:sp>
-        <p:nvSpPr>
-          <p:cNvPr id="22" name="Shape 19"/>
-          <p:cNvSpPr/>
-          <p:nvPr/>
-        </p:nvSpPr>
-        <p:spPr>
-          <a:xfrm>
-            <a:off x="4160520" y="4489704"/>
-            <a:ext cx="7498080" cy="795528"/>
-          </a:xfrm>
-          <a:prstGeom prst="roundRect">
-            <a:avLst>
-              <a:gd name="adj" fmla="val 11494"/>
-            </a:avLst>
-          </a:prstGeom>
-          <a:solidFill>
-            <a:srgbClr val="24356B"/>
-          </a:solidFill>
-          <a:ln/>
-        </p:spPr>
-      </p:sp>
-      <p:sp>
-        <p:nvSpPr>
-          <p:cNvPr id="23" name="Shape 20"/>
-          <p:cNvSpPr/>
-          <p:nvPr/>
-        </p:nvSpPr>
-        <p:spPr>
-          <a:xfrm>
-            <a:off x="4343400" y="4654296"/>
-            <a:ext cx="868680" cy="457200"/>
-          </a:xfrm>
-          <a:prstGeom prst="roundRect">
-            <a:avLst>
-              <a:gd name="adj" fmla="val 16000"/>
-            </a:avLst>
-          </a:prstGeom>
-          <a:solidFill>
-            <a:srgbClr val="C9A227"/>
-          </a:solidFill>
-          <a:ln/>
-        </p:spPr>
-      </p:sp>
-      <p:sp>
-        <p:nvSpPr>
-          <p:cNvPr id="24" name="Text 21"/>
-          <p:cNvSpPr txBox="1"/>
-          <p:nvPr/>
-        </p:nvSpPr>
-        <p:spPr>
-          <a:xfrm>
-            <a:off x="4343400" y="4654296"/>
-            <a:ext cx="868680" cy="457200"/>
-          </a:xfrm>
-          <a:prstGeom prst="rect">
-            <a:avLst/>
-          </a:prstGeom>
-          <a:noFill/>
-          <a:ln/>
-        </p:spPr>
-        <p:txBody>
-          <a:bodyPr wrap="square" lIns="0" tIns="0" rIns="0" bIns="0" rtlCol="0" anchor="ctr"/>
-          <a:lstStyle/>
-          <a:p>
-            <a:pPr algn="ctr" indent="0" marL="0">
-              <a:buNone/>
-            </a:pPr>
-            <a:r>
-              <a:rPr lang="en-US" sz="1250" b="1" dirty="0">
-                <a:solidFill>
-                  <a:srgbClr val="1B2A52"/>
-                </a:solidFill>
-                <a:latin typeface="Calibri" pitchFamily="34" charset="0"/>
-                <a:ea typeface="Calibri" pitchFamily="34" charset="-122"/>
-                <a:cs typeface="Calibri" pitchFamily="34" charset="-120"/>
-              </a:rPr>
-              <a:t>18:30</a:t>
-            </a:r>
-            <a:endParaRPr lang="en-US" sz="1250" dirty="0"/>
-          </a:p>
-        </p:txBody>
-      </p:sp>
-      <p:sp>
-        <p:nvSpPr>
-          <p:cNvPr id="25" name="Text 22"/>
-          <p:cNvSpPr txBox="1"/>
-          <p:nvPr/>
-        </p:nvSpPr>
-        <p:spPr>
-          <a:xfrm>
-            <a:off x="5394960" y="4581144"/>
-            <a:ext cx="6126480" cy="621792"/>
-          </a:xfrm>
-          <a:prstGeom prst="rect">
-            <a:avLst/>
-          </a:prstGeom>
-          <a:noFill/>
-          <a:ln/>
-        </p:spPr>
-        <p:txBody>
-          <a:bodyPr wrap="square" lIns="0" tIns="0" rIns="0" bIns="0" rtlCol="0" anchor="ctr"/>
-          <a:lstStyle/>
-          <a:p>
-            <a:pPr indent="0" marL="0">
-              <a:buNone/>
-            </a:pPr>
-            <a:r>
-              <a:rPr lang="en-US" sz="1200" b="1" dirty="0">
-                <a:solidFill>
-                  <a:srgbClr val="FFFFFF"/>
-                </a:solidFill>
-                <a:latin typeface="Calibri" pitchFamily="34" charset="0"/>
-                <a:ea typeface="Calibri" pitchFamily="34" charset="-122"/>
-                <a:cs typeface="Calibri" pitchFamily="34" charset="-120"/>
-              </a:rPr>
-              <a:t>Pause and discuss — </a:t>
-            </a:r>
-            <a:pPr indent="0" marL="0">
-              <a:buNone/>
-            </a:pPr>
-            <a:r>
-              <a:rPr lang="en-US" sz="1200" dirty="0">
-                <a:solidFill>
-                  <a:srgbClr val="C9D6EF"/>
-                </a:solidFill>
-                <a:latin typeface="Calibri" pitchFamily="34" charset="0"/>
-                <a:ea typeface="Calibri" pitchFamily="34" charset="-122"/>
-                <a:cs typeface="Calibri" pitchFamily="34" charset="-120"/>
-              </a:rPr>
-              <a:t>Talk about what we've seen so far.</a:t>
-            </a:r>
-            <a:endParaRPr lang="en-US" sz="1200" dirty="0"/>
-          </a:p>
-        </p:txBody>
-      </p:sp>
-      <p:sp>
-        <p:nvSpPr>
-          <p:cNvPr id="26" name="Shape 23"/>
-          <p:cNvSpPr/>
-          <p:nvPr/>
-        </p:nvSpPr>
-        <p:spPr>
-          <a:xfrm>
-            <a:off x="4160520" y="5422392"/>
-            <a:ext cx="7498080" cy="795528"/>
-          </a:xfrm>
-          <a:prstGeom prst="roundRect">
-            <a:avLst>
-              <a:gd name="adj" fmla="val 11494"/>
-            </a:avLst>
-          </a:prstGeom>
-          <a:solidFill>
-            <a:srgbClr val="24356B"/>
-          </a:solidFill>
-          <a:ln/>
-        </p:spPr>
-      </p:sp>
-      <p:sp>
-        <p:nvSpPr>
-          <p:cNvPr id="27" name="Shape 24"/>
-          <p:cNvSpPr/>
-          <p:nvPr/>
-        </p:nvSpPr>
-        <p:spPr>
-          <a:xfrm>
-            <a:off x="4343400" y="5586984"/>
-            <a:ext cx="868680" cy="457200"/>
-          </a:xfrm>
-          <a:prstGeom prst="roundRect">
-            <a:avLst>
-              <a:gd name="adj" fmla="val 16000"/>
-            </a:avLst>
-          </a:prstGeom>
-          <a:solidFill>
-            <a:srgbClr val="C9A227"/>
-          </a:solidFill>
-          <a:ln/>
-        </p:spPr>
-      </p:sp>
-      <p:sp>
-        <p:nvSpPr>
-          <p:cNvPr id="28" name="Text 25"/>
-          <p:cNvSpPr txBox="1"/>
-          <p:nvPr/>
-        </p:nvSpPr>
-        <p:spPr>
-          <a:xfrm>
-            <a:off x="4343400" y="5586984"/>
-            <a:ext cx="868680" cy="457200"/>
-          </a:xfrm>
-          <a:prstGeom prst="rect">
-            <a:avLst/>
-          </a:prstGeom>
-          <a:noFill/>
-          <a:ln/>
-        </p:spPr>
-        <p:txBody>
-          <a:bodyPr wrap="square" lIns="0" tIns="0" rIns="0" bIns="0" rtlCol="0" anchor="ctr"/>
-          <a:lstStyle/>
-          <a:p>
-            <a:pPr algn="ctr" indent="0" marL="0">
-              <a:buNone/>
-            </a:pPr>
-            <a:r>
-              <a:rPr lang="en-US" sz="1250" b="1" dirty="0">
-                <a:solidFill>
-                  <a:srgbClr val="1B2A52"/>
-                </a:solidFill>
-                <a:latin typeface="Calibri" pitchFamily="34" charset="0"/>
-                <a:ea typeface="Calibri" pitchFamily="34" charset="-122"/>
-                <a:cs typeface="Calibri" pitchFamily="34" charset="-120"/>
-              </a:rPr>
-              <a:t>22:00</a:t>
-            </a:r>
-            <a:endParaRPr lang="en-US" sz="1250" dirty="0"/>
-          </a:p>
-        </p:txBody>
-      </p:sp>
-      <p:sp>
-        <p:nvSpPr>
-          <p:cNvPr id="29" name="Text 26"/>
-          <p:cNvSpPr txBox="1"/>
-          <p:nvPr/>
-        </p:nvSpPr>
-        <p:spPr>
-          <a:xfrm>
-            <a:off x="5394960" y="5513832"/>
-            <a:ext cx="6126480" cy="621792"/>
-          </a:xfrm>
-          <a:prstGeom prst="rect">
-            <a:avLst/>
-          </a:prstGeom>
-          <a:noFill/>
-          <a:ln/>
-        </p:spPr>
-        <p:txBody>
-          <a:bodyPr wrap="square" lIns="0" tIns="0" rIns="0" bIns="0" rtlCol="0" anchor="ctr"/>
-          <a:lstStyle/>
-          <a:p>
-            <a:pPr indent="0" marL="0">
-              <a:buNone/>
-            </a:pPr>
-            <a:r>
-              <a:rPr lang="en-US" sz="1200" b="1" dirty="0">
-                <a:solidFill>
-                  <a:srgbClr val="FFFFFF"/>
-                </a:solidFill>
-                <a:latin typeface="Calibri" pitchFamily="34" charset="0"/>
-                <a:ea typeface="Calibri" pitchFamily="34" charset="-122"/>
-                <a:cs typeface="Calibri" pitchFamily="34" charset="-120"/>
-              </a:rPr>
-              <a:t>Closing question — </a:t>
-            </a:r>
-            <a:pPr indent="0" marL="0">
-              <a:buNone/>
-            </a:pPr>
-            <a:r>
-              <a:rPr lang="en-US" sz="1200" dirty="0">
-                <a:solidFill>
-                  <a:srgbClr val="C9D6EF"/>
-                </a:solidFill>
-                <a:latin typeface="Calibri" pitchFamily="34" charset="0"/>
-                <a:ea typeface="Calibri" pitchFamily="34" charset="-122"/>
-                <a:cs typeface="Calibri" pitchFamily="34" charset="-120"/>
-              </a:rPr>
-              <a:t>Ask: “What statements stood out to you?”</a:t>
-            </a:r>
-            <a:endParaRPr lang="en-US" sz="1200" dirty="0"/>
-          </a:p>
-        </p:txBody>
-      </p:sp>
-      <p:sp>
-        <p:nvSpPr>
-          <p:cNvPr id="951" name="NavButton951">
-            <a:hlinkClick r:id="rId4" action="ppaction://hlinksldjump"/>
-          </p:cNvPr>
-          <p:cNvSpPr/>
-          <p:nvPr/>
-        </p:nvSpPr>
-        <p:spPr>
-          <a:xfrm>
-            <a:off x="11137392" y="6419088"/>
-            <a:ext cx="914400" cy="329184"/>
-          </a:xfrm>
-          <a:prstGeom prst="roundRect">
-            <a:avLst>
-              <a:gd name="adj" fmla="val 50000"/>
-            </a:avLst>
-          </a:prstGeom>
-          <a:solidFill>
-            <a:srgbClr val="C9A227"/>
-          </a:solidFill>
-          <a:ln>
-            <a:noFill/>
-          </a:ln>
-        </p:spPr>
-        <p:txBody>
-          <a:bodyPr anchor="ctr" lIns="0" tIns="0" rIns="0" bIns="0"/>
-          <a:lstStyle/>
-          <a:p>
-            <a:pPr algn="ctr"/>
-            <a:r>
-              <a:rPr lang="en-US" sz="1000" b="1" dirty="0">
-                <a:solidFill>
-                  <a:srgbClr val="1B2A52"/>
-                </a:solidFill>
-                <a:latin typeface="Calibri"/>
-              </a:rPr>
-              <a:t>▶ Video</a:t>
-            </a:r>
-          </a:p>
-        </p:txBody>
-      </p:sp>
-    </p:spTree>
-  </p:cSld>
-  <p:clrMapOvr>
-    <a:masterClrMapping/>
-  </p:clrMapOvr>
-</p:sld>
-</file>
-
-<file path=ppt/slides/slide18.xml><?xml version="1.0" encoding="utf-8"?>
-<p:sld xmlns:a="http://schemas.openxmlformats.org/drawingml/2006/main" xmlns:r="http://schemas.openxmlformats.org/officeDocument/2006/relationships" xmlns:p="http://schemas.openxmlformats.org/presentationml/2006/main">
-  <p:cSld name="Slide 18">
-    <p:bg>
-      <p:bgPr>
-        <a:solidFill>
-          <a:srgbClr val="1B2A52"/>
-        </a:solidFill>
-      </p:bgPr>
-    </p:bg>
-    <p:spTree>
-      <p:nvGrpSpPr>
-        <p:cNvPr id="1" name=""/>
-        <p:cNvGrpSpPr/>
-        <p:nvPr/>
-      </p:nvGrpSpPr>
-      <p:grpSpPr>
-        <a:xfrm>
-          <a:off x="0" y="0"/>
-          <a:ext cx="0" cy="0"/>
-          <a:chOff x="0" y="0"/>
-          <a:chExt cx="0" cy="0"/>
-        </a:xfrm>
-      </p:grpSpPr>
-      <p:sp>
-        <p:nvSpPr>
-          <p:cNvPr id="2" name="Text 0"/>
-          <p:cNvSpPr txBox="1"/>
-          <p:nvPr/>
-        </p:nvSpPr>
-        <p:spPr>
-          <a:xfrm>
-            <a:off x="548640" y="438912"/>
-            <a:ext cx="11064240" cy="292608"/>
-          </a:xfrm>
-          <a:prstGeom prst="rect">
-            <a:avLst/>
-          </a:prstGeom>
-          <a:noFill/>
-          <a:ln/>
-        </p:spPr>
-        <p:txBody>
-          <a:bodyPr wrap="square" lIns="0" tIns="0" rIns="0" bIns="0" rtlCol="0" anchor="ctr"/>
-          <a:lstStyle/>
-          <a:p>
-            <a:pPr algn="l" indent="0" marL="0">
-              <a:buNone/>
-            </a:pPr>
-            <a:r>
-              <a:rPr lang="en-US" sz="1200" b="1" spc="300" kern="0" dirty="0">
-                <a:solidFill>
-                  <a:srgbClr val="C9A227"/>
-                </a:solidFill>
-                <a:latin typeface="Calibri" pitchFamily="34" charset="0"/>
-                <a:ea typeface="Calibri" pitchFamily="34" charset="-122"/>
-                <a:cs typeface="Calibri" pitchFamily="34" charset="-120"/>
-              </a:rPr>
-              <a:t>PLAY THE VIDEO HERE</a:t>
-            </a:r>
-            <a:endParaRPr lang="en-US" sz="1200" dirty="0"/>
-          </a:p>
-        </p:txBody>
-      </p:sp>
-      <p:sp>
-        <p:nvSpPr>
-          <p:cNvPr id="3" name="Shape 1"/>
-          <p:cNvSpPr/>
-          <p:nvPr/>
-        </p:nvSpPr>
-        <p:spPr>
-          <a:xfrm>
-            <a:off x="822960" y="1234440"/>
-            <a:ext cx="10515600" cy="4846320"/>
-          </a:xfrm>
-          <a:prstGeom prst="roundRect">
-            <a:avLst>
-              <a:gd name="adj" fmla="val 2830"/>
-            </a:avLst>
-          </a:prstGeom>
-          <a:solidFill>
-            <a:srgbClr val="24356B"/>
-          </a:solidFill>
-          <a:ln w="19050">
-            <a:solidFill>
-              <a:srgbClr val="31437A"/>
-            </a:solidFill>
-            <a:prstDash val="dash"/>
-          </a:ln>
-        </p:spPr>
-      </p:sp>
-      <p:sp>
-        <p:nvSpPr>
-          <p:cNvPr id="4" name="Text 2"/>
-          <p:cNvSpPr txBox="1"/>
-          <p:nvPr/>
-        </p:nvSpPr>
-        <p:spPr>
-          <a:xfrm>
-            <a:off x="1280160" y="2514600"/>
-            <a:ext cx="9601200" cy="457200"/>
-          </a:xfrm>
-          <a:prstGeom prst="rect">
-            <a:avLst/>
-          </a:prstGeom>
-          <a:noFill/>
-          <a:ln/>
-        </p:spPr>
-        <p:txBody>
-          <a:bodyPr wrap="square" lIns="0" tIns="0" rIns="0" bIns="0" rtlCol="0" anchor="ctr"/>
-          <a:lstStyle/>
-          <a:p>
-            <a:pPr algn="ctr" indent="0" marL="0">
-              <a:buNone/>
-            </a:pPr>
-            <a:r>
-              <a:rPr lang="en-US" sz="2200" b="1" dirty="0">
-                <a:solidFill>
-                  <a:srgbClr val="FFFFFF"/>
-                </a:solidFill>
-                <a:latin typeface="Calibri" pitchFamily="34" charset="0"/>
-                <a:ea typeface="Calibri" pitchFamily="34" charset="-122"/>
-                <a:cs typeface="Calibri" pitchFamily="34" charset="-120"/>
-              </a:rPr>
-              <a:t>Insert your downloaded video on this slide</a:t>
-            </a:r>
-            <a:endParaRPr lang="en-US" sz="2200" dirty="0"/>
-          </a:p>
-        </p:txBody>
-      </p:sp>
-      <p:sp>
-        <p:nvSpPr>
-          <p:cNvPr id="5" name="Text 3"/>
-          <p:cNvSpPr txBox="1"/>
-          <p:nvPr/>
-        </p:nvSpPr>
-        <p:spPr>
-          <a:xfrm>
-            <a:off x="1280160" y="3200400"/>
-            <a:ext cx="9601200" cy="1280160"/>
-          </a:xfrm>
-          <a:prstGeom prst="rect">
-            <a:avLst/>
-          </a:prstGeom>
-          <a:noFill/>
-          <a:ln/>
-        </p:spPr>
-        <p:txBody>
-          <a:bodyPr wrap="square" lIns="0" tIns="0" rIns="0" bIns="0" rtlCol="0" anchor="ctr"/>
-          <a:lstStyle/>
-          <a:p>
-            <a:pPr algn="ctr" indent="0" marL="0">
-              <a:buNone/>
-            </a:pPr>
-            <a:r>
-              <a:rPr lang="en-US" sz="1500" dirty="0">
-                <a:solidFill>
-                  <a:srgbClr val="C9D6EF"/>
-                </a:solidFill>
-                <a:latin typeface="Calibri" pitchFamily="34" charset="0"/>
-                <a:ea typeface="Calibri" pitchFamily="34" charset="-122"/>
-                <a:cs typeface="Calibri" pitchFamily="34" charset="-120"/>
-              </a:rPr>
-              <a:t>PowerPoint: Insert → Video → This Device → choose the file.</a:t>
-            </a:r>
-            <a:endParaRPr lang="en-US" sz="1500" dirty="0"/>
-          </a:p>
-          <a:p>
-            <a:pPr algn="ctr" indent="0" marL="0">
-              <a:buNone/>
-            </a:pPr>
-            <a:r>
-              <a:rPr lang="en-US" sz="1500" dirty="0">
-                <a:solidFill>
-                  <a:srgbClr val="C9D6EF"/>
-                </a:solidFill>
-                <a:latin typeface="Calibri" pitchFamily="34" charset="0"/>
-                <a:ea typeface="Calibri" pitchFamily="34" charset="-122"/>
-                <a:cs typeface="Calibri" pitchFamily="34" charset="-120"/>
-              </a:rPr>
-              <a:t>Size it to fill this box and set Start: On Click.</a:t>
-            </a:r>
-            <a:endParaRPr lang="en-US" sz="1500" dirty="0"/>
-          </a:p>
-          <a:p>
-            <a:pPr algn="ctr" indent="0" marL="0">
-              <a:buNone/>
-            </a:pPr>
-            <a:r>
-              <a:rPr lang="en-US" sz="1500" dirty="0">
-                <a:solidFill>
-                  <a:srgbClr val="C9D6EF"/>
-                </a:solidFill>
-                <a:latin typeface="Calibri" pitchFamily="34" charset="0"/>
-                <a:ea typeface="Calibri" pitchFamily="34" charset="-122"/>
-                <a:cs typeface="Calibri" pitchFamily="34" charset="-120"/>
-              </a:rPr>
-              <a:t>Then delete this text box.</a:t>
-            </a:r>
-            <a:endParaRPr lang="en-US" sz="1500" dirty="0"/>
-          </a:p>
-        </p:txBody>
-      </p:sp>
-      <p:sp>
-        <p:nvSpPr>
-          <p:cNvPr id="6" name="Text 4"/>
-          <p:cNvSpPr txBox="1"/>
-          <p:nvPr/>
-        </p:nvSpPr>
-        <p:spPr>
-          <a:xfrm>
-            <a:off x="822960" y="6263640"/>
-            <a:ext cx="10515600" cy="320040"/>
-          </a:xfrm>
-          <a:prstGeom prst="rect">
-            <a:avLst/>
-          </a:prstGeom>
-          <a:noFill/>
-          <a:ln/>
-        </p:spPr>
-        <p:txBody>
-          <a:bodyPr wrap="square" lIns="0" tIns="0" rIns="0" bIns="0" rtlCol="0" anchor="ctr"/>
-          <a:lstStyle/>
-          <a:p>
-            <a:pPr algn="ctr" indent="0" marL="0">
-              <a:buNone/>
-            </a:pPr>
-            <a:r>
-              <a:rPr lang="en-US" sz="1200" dirty="0">
-                <a:solidFill>
-                  <a:srgbClr val="8FA0C8"/>
-                </a:solidFill>
-                <a:latin typeface="Calibri" pitchFamily="34" charset="0"/>
-                <a:ea typeface="Calibri" pitchFamily="34" charset="-122"/>
-                <a:cs typeface="Calibri" pitchFamily="34" charset="-120"/>
-              </a:rPr>
-              <a:t>Hover over the playing video for the scrub bar — your stops: 7:20 · 10:00 · 12:00 · 18:30 · 22:00</a:t>
-            </a:r>
-            <a:endParaRPr lang="en-US" sz="1200" dirty="0"/>
-          </a:p>
-        </p:txBody>
-      </p:sp>
-      <p:sp>
-        <p:nvSpPr>
-          <p:cNvPr id="950" name="NavButton950">
-            <a:hlinkClick action="ppaction://hlinkshowjump?jump=lastslideviewed"/>
-          </p:cNvPr>
-          <p:cNvSpPr/>
-          <p:nvPr/>
-        </p:nvSpPr>
-        <p:spPr>
-          <a:xfrm>
-            <a:off x="10378440" y="384048"/>
-            <a:ext cx="1371600" cy="365760"/>
-          </a:xfrm>
-          <a:prstGeom prst="roundRect">
-            <a:avLst>
-              <a:gd name="adj" fmla="val 50000"/>
-            </a:avLst>
-          </a:prstGeom>
-          <a:solidFill>
-            <a:srgbClr val="C9A227"/>
-          </a:solidFill>
-          <a:ln>
-            <a:noFill/>
-          </a:ln>
-        </p:spPr>
-        <p:txBody>
-          <a:bodyPr anchor="ctr" lIns="0" tIns="0" rIns="0" bIns="0"/>
-          <a:lstStyle/>
-          <a:p>
-            <a:pPr algn="ctr"/>
-            <a:r>
-              <a:rPr lang="en-US" sz="1000" b="1" dirty="0">
-                <a:solidFill>
-                  <a:srgbClr val="1B2A52"/>
-                </a:solidFill>
-                <a:latin typeface="Calibri"/>
-              </a:rPr>
-              <a:t>⟵ Back to slides</a:t>
-            </a:r>
-          </a:p>
-        </p:txBody>
-      </p:sp>
     </p:spTree>
   </p:cSld>
   <p:clrMapOvr>
@@ -9096,48 +7298,6 @@
           </a:p>
         </p:txBody>
       </p:sp>
-      <p:sp>
-        <p:nvSpPr>
-          <p:cNvPr id="951" name="NavButton951">
-            <a:hlinkClick r:id="rId3" action="ppaction://hlinksldjump"/>
-          </p:cNvPr>
-          <p:cNvSpPr/>
-          <p:nvPr/>
-        </p:nvSpPr>
-        <p:spPr>
-          <a:xfrm>
-            <a:off x="11137392" y="6419088"/>
-            <a:ext cx="914400" cy="329184"/>
-          </a:xfrm>
-          <a:prstGeom prst="roundRect">
-            <a:avLst>
-              <a:gd name="adj" fmla="val 50000"/>
-            </a:avLst>
-          </a:prstGeom>
-          <a:solidFill>
-            <a:srgbClr val="C9A227"/>
-          </a:solidFill>
-          <a:ln>
-            <a:noFill/>
-          </a:ln>
-        </p:spPr>
-        <p:txBody>
-          <a:bodyPr anchor="ctr" lIns="0" tIns="0" rIns="0" bIns="0"/>
-          <a:lstStyle/>
-          <a:p>
-            <a:pPr algn="ctr"/>
-            <a:r>
-              <a:rPr lang="en-US" sz="1000" b="1" dirty="0">
-                <a:solidFill>
-                  <a:srgbClr val="1B2A52"/>
-                </a:solidFill>
-                <a:latin typeface="Calibri"/>
-              </a:rPr>
-              <a:t>▶ Video</a:t>
-            </a:r>
-          </a:p>
-        </p:txBody>
-      </p:sp>
     </p:spTree>
   </p:cSld>
   <p:clrMapOvr>
@@ -9857,48 +8017,6 @@
           </a:p>
         </p:txBody>
       </p:sp>
-      <p:sp>
-        <p:nvSpPr>
-          <p:cNvPr id="951" name="NavButton951">
-            <a:hlinkClick r:id="rId6" action="ppaction://hlinksldjump"/>
-          </p:cNvPr>
-          <p:cNvSpPr/>
-          <p:nvPr/>
-        </p:nvSpPr>
-        <p:spPr>
-          <a:xfrm>
-            <a:off x="11137392" y="6419088"/>
-            <a:ext cx="914400" cy="329184"/>
-          </a:xfrm>
-          <a:prstGeom prst="roundRect">
-            <a:avLst>
-              <a:gd name="adj" fmla="val 50000"/>
-            </a:avLst>
-          </a:prstGeom>
-          <a:solidFill>
-            <a:srgbClr val="C9A227"/>
-          </a:solidFill>
-          <a:ln>
-            <a:noFill/>
-          </a:ln>
-        </p:spPr>
-        <p:txBody>
-          <a:bodyPr anchor="ctr" lIns="0" tIns="0" rIns="0" bIns="0"/>
-          <a:lstStyle/>
-          <a:p>
-            <a:pPr algn="ctr"/>
-            <a:r>
-              <a:rPr lang="en-US" sz="1000" b="1" dirty="0">
-                <a:solidFill>
-                  <a:srgbClr val="1B2A52"/>
-                </a:solidFill>
-                <a:latin typeface="Calibri"/>
-              </a:rPr>
-              <a:t>▶ Video</a:t>
-            </a:r>
-          </a:p>
-        </p:txBody>
-      </p:sp>
     </p:spTree>
   </p:cSld>
   <p:clrMapOvr>
@@ -10497,23 +8615,51 @@
           </a:p>
         </p:txBody>
       </p:sp>
-      <p:sp>
-        <p:nvSpPr>
-          <p:cNvPr id="951" name="NavButton951">
-            <a:hlinkClick r:id="rId6" action="ppaction://hlinksldjump"/>
-          </p:cNvPr>
+    </p:spTree>
+  </p:cSld>
+  <p:clrMapOvr>
+    <a:masterClrMapping/>
+  </p:clrMapOvr>
+</p:sld>
+</file>
+
+<file path=ppt/slides/slide21.xml><?xml version="1.0" encoding="utf-8"?>
+<p:sld xmlns:a="http://schemas.openxmlformats.org/drawingml/2006/main" xmlns:r="http://schemas.openxmlformats.org/officeDocument/2006/relationships" xmlns:p="http://schemas.openxmlformats.org/presentationml/2006/main">
+  <p:cSld name="Slide 18">
+    <p:bg>
+      <p:bgPr>
+        <a:solidFill>
+          <a:srgbClr val="1B2A52"/>
+        </a:solidFill>
+      </p:bgPr>
+    </p:bg>
+    <p:spTree>
+      <p:nvGrpSpPr>
+        <p:cNvPr id="1" name=""/>
+        <p:cNvGrpSpPr/>
+        <p:nvPr/>
+      </p:nvGrpSpPr>
+      <p:grpSpPr>
+        <a:xfrm>
+          <a:off x="0" y="0"/>
+          <a:ext cx="0" cy="0"/>
+          <a:chOff x="0" y="0"/>
+          <a:chExt cx="0" cy="0"/>
+        </a:xfrm>
+      </p:grpSpPr>
+      <p:sp>
+        <p:nvSpPr>
+          <p:cNvPr id="611" name="SegBox611"/>
           <p:cNvSpPr/>
           <p:nvPr/>
         </p:nvSpPr>
         <p:spPr>
           <a:xfrm>
-            <a:off x="11137392" y="6419088"/>
-            <a:ext cx="914400" cy="329184"/>
+            <a:off x="548640" y="411480"/>
+            <a:ext cx="1828800" cy="457200"/>
           </a:xfrm>
           <a:prstGeom prst="roundRect">
-            <a:avLst>
-              <a:gd name="adj" fmla="val 50000"/>
-            </a:avLst>
+            <a:avLst/>
           </a:prstGeom>
           <a:solidFill>
             <a:srgbClr val="C9A227"/>
@@ -10523,18 +8669,1293 @@
           </a:ln>
         </p:spPr>
         <p:txBody>
+          <a:bodyPr/>
+          <a:lstStyle/>
+          <a:p/>
+        </p:txBody>
+      </p:sp>
+      <p:sp>
+        <p:nvSpPr>
+          <p:cNvPr id="510" name="Seg510"/>
+          <p:cNvSpPr txBox="1"/>
+          <p:nvPr/>
+        </p:nvSpPr>
+        <p:spPr>
+          <a:xfrm>
+            <a:off x="548640" y="502920"/>
+            <a:ext cx="1828800" cy="310896"/>
+          </a:xfrm>
+          <a:prstGeom prst="rect">
+            <a:avLst/>
+          </a:prstGeom>
+          <a:noFill/>
+        </p:spPr>
+        <p:txBody>
           <a:bodyPr anchor="ctr" lIns="0" tIns="0" rIns="0" bIns="0"/>
           <a:lstStyle/>
           <a:p>
             <a:pPr algn="ctr"/>
             <a:r>
-              <a:rPr lang="en-US" sz="1000" b="1" dirty="0">
+              <a:rPr lang="en-US" sz="1300" b="1" dirty="0">
                 <a:solidFill>
                   <a:srgbClr val="1B2A52"/>
                 </a:solidFill>
                 <a:latin typeface="Calibri"/>
               </a:rPr>
-              <a:t>▶ Video</a:t>
+              <a:t>VIDEO · PART 1</a:t>
+            </a:r>
+          </a:p>
+        </p:txBody>
+      </p:sp>
+      <p:sp>
+        <p:nvSpPr>
+          <p:cNvPr id="510" name="Seg510"/>
+          <p:cNvSpPr txBox="1"/>
+          <p:nvPr/>
+        </p:nvSpPr>
+        <p:spPr>
+          <a:xfrm>
+            <a:off x="2651760" y="384048"/>
+            <a:ext cx="8961120" cy="548640"/>
+          </a:xfrm>
+          <a:prstGeom prst="rect">
+            <a:avLst/>
+          </a:prstGeom>
+          <a:noFill/>
+        </p:spPr>
+        <p:txBody>
+          <a:bodyPr anchor="ctr" lIns="0" tIns="0" rIns="0" bIns="0"/>
+          <a:lstStyle/>
+          <a:p>
+            <a:pPr algn="l"/>
+            <a:r>
+              <a:rPr lang="en-US" sz="2400" b="1" dirty="0">
+                <a:solidFill>
+                  <a:srgbClr val="FFFFFF"/>
+                </a:solidFill>
+                <a:latin typeface="Calibri"/>
+              </a:rPr>
+              <a:t>Start → 7:23</a:t>
+            </a:r>
+          </a:p>
+        </p:txBody>
+      </p:sp>
+      <p:sp>
+        <p:nvSpPr>
+          <p:cNvPr id="612" name="SegBox612"/>
+          <p:cNvSpPr/>
+          <p:nvPr/>
+        </p:nvSpPr>
+        <p:spPr>
+          <a:xfrm>
+            <a:off x="822960" y="1234440"/>
+            <a:ext cx="10543032" cy="4663440"/>
+          </a:xfrm>
+          <a:prstGeom prst="roundRect">
+            <a:avLst/>
+          </a:prstGeom>
+          <a:solidFill>
+            <a:srgbClr val="24356B"/>
+          </a:solidFill>
+          <a:ln w="19050">
+            <a:solidFill>
+              <a:srgbClr val="31437A"/>
+            </a:solidFill>
+            <a:prstDash val="dash"/>
+          </a:ln>
+        </p:spPr>
+        <p:txBody>
+          <a:bodyPr/>
+          <a:lstStyle/>
+          <a:p/>
+        </p:txBody>
+      </p:sp>
+      <p:sp>
+        <p:nvSpPr>
+          <p:cNvPr id="510" name="Seg510"/>
+          <p:cNvSpPr txBox="1"/>
+          <p:nvPr/>
+        </p:nvSpPr>
+        <p:spPr>
+          <a:xfrm>
+            <a:off x="1463040" y="2377440"/>
+            <a:ext cx="9235440" cy="2377440"/>
+          </a:xfrm>
+          <a:prstGeom prst="rect">
+            <a:avLst/>
+          </a:prstGeom>
+          <a:noFill/>
+        </p:spPr>
+        <p:txBody>
+          <a:bodyPr anchor="t" lIns="0" tIns="0" rIns="0" bIns="0"/>
+          <a:lstStyle/>
+          <a:p>
+            <a:pPr algn="ctr"/>
+            <a:r>
+              <a:rPr lang="en-US" sz="1500" b="1" dirty="0">
+                <a:solidFill>
+                  <a:srgbClr val="FFFFFF"/>
+                </a:solidFill>
+                <a:latin typeface="Calibri"/>
+              </a:rPr>
+              <a:t>Insert the video here — Insert → Video → This Device</a:t>
+            </a:r>
+          </a:p>
+          <a:p>
+            <a:pPr algn="ctr"/>
+            <a:r>
+              <a:rPr lang="en-US" sz="800" dirty="0">
+                <a:solidFill>
+                  <a:srgbClr val="FFFFFF"/>
+                </a:solidFill>
+                <a:latin typeface="Calibri"/>
+              </a:rPr>
+              <a:t> </a:t>
+            </a:r>
+          </a:p>
+          <a:p>
+            <a:pPr algn="ctr"/>
+            <a:r>
+              <a:rPr lang="en-US" sz="1300" dirty="0">
+                <a:solidFill>
+                  <a:srgbClr val="C9D6EF"/>
+                </a:solidFill>
+                <a:latin typeface="Calibri"/>
+              </a:rPr>
+              <a:t>Then trim this copy: Playback → Trim Video → End Time 7:23</a:t>
+            </a:r>
+          </a:p>
+          <a:p>
+            <a:pPr algn="ctr"/>
+            <a:r>
+              <a:rPr lang="en-US" sz="1300" dirty="0">
+                <a:solidFill>
+                  <a:srgbClr val="C9D6EF"/>
+                </a:solidFill>
+                <a:latin typeface="Calibri"/>
+              </a:rPr>
+              <a:t>Insert once, then copy–paste the same video onto the other PART slides</a:t>
+            </a:r>
+          </a:p>
+          <a:p>
+            <a:pPr algn="ctr"/>
+            <a:r>
+              <a:rPr lang="en-US" sz="1300" dirty="0">
+                <a:solidFill>
+                  <a:srgbClr val="C9D6EF"/>
+                </a:solidFill>
+                <a:latin typeface="Calibri"/>
+              </a:rPr>
+              <a:t>(it stays one embedded copy). Set Start: Automatically. Delete this text box.</a:t>
+            </a:r>
+          </a:p>
+        </p:txBody>
+      </p:sp>
+      <p:sp>
+        <p:nvSpPr>
+          <p:cNvPr id="510" name="Seg510"/>
+          <p:cNvSpPr txBox="1"/>
+          <p:nvPr/>
+        </p:nvSpPr>
+        <p:spPr>
+          <a:xfrm>
+            <a:off x="822960" y="6126480"/>
+            <a:ext cx="10543032" cy="457200"/>
+          </a:xfrm>
+          <a:prstGeom prst="rect">
+            <a:avLst/>
+          </a:prstGeom>
+          <a:noFill/>
+        </p:spPr>
+        <p:txBody>
+          <a:bodyPr anchor="ctr" lIns="0" tIns="0" rIns="0" bIns="0"/>
+          <a:lstStyle/>
+          <a:p>
+            <a:pPr algn="ctr"/>
+            <a:r>
+              <a:rPr lang="en-US" sz="1250" i="1" dirty="0">
+                <a:solidFill>
+                  <a:srgbClr val="C9D6EF"/>
+                </a:solidFill>
+                <a:latin typeface="Calibri"/>
+              </a:rPr>
+              <a:t>When it pauses: discuss, then ask — “Why do you think the FSY guide is structured this way?”</a:t>
+            </a:r>
+          </a:p>
+        </p:txBody>
+      </p:sp>
+    </p:spTree>
+  </p:cSld>
+  <p:clrMapOvr>
+    <a:masterClrMapping/>
+  </p:clrMapOvr>
+</p:sld>
+</file>
+
+<file path=ppt/slides/slide22.xml><?xml version="1.0" encoding="utf-8"?>
+<p:sld xmlns:a="http://schemas.openxmlformats.org/drawingml/2006/main" xmlns:r="http://schemas.openxmlformats.org/officeDocument/2006/relationships" xmlns:p="http://schemas.openxmlformats.org/presentationml/2006/main">
+  <p:cSld name="Slide 18">
+    <p:bg>
+      <p:bgPr>
+        <a:solidFill>
+          <a:srgbClr val="1B2A52"/>
+        </a:solidFill>
+      </p:bgPr>
+    </p:bg>
+    <p:spTree>
+      <p:nvGrpSpPr>
+        <p:cNvPr id="1" name=""/>
+        <p:cNvGrpSpPr/>
+        <p:nvPr/>
+      </p:nvGrpSpPr>
+      <p:grpSpPr>
+        <a:xfrm>
+          <a:off x="0" y="0"/>
+          <a:ext cx="0" cy="0"/>
+          <a:chOff x="0" y="0"/>
+          <a:chExt cx="0" cy="0"/>
+        </a:xfrm>
+      </p:grpSpPr>
+      <p:sp>
+        <p:nvSpPr>
+          <p:cNvPr id="623" name="SegBox623"/>
+          <p:cNvSpPr/>
+          <p:nvPr/>
+        </p:nvSpPr>
+        <p:spPr>
+          <a:xfrm>
+            <a:off x="548640" y="411480"/>
+            <a:ext cx="1828800" cy="457200"/>
+          </a:xfrm>
+          <a:prstGeom prst="roundRect">
+            <a:avLst/>
+          </a:prstGeom>
+          <a:solidFill>
+            <a:srgbClr val="C9A227"/>
+          </a:solidFill>
+          <a:ln>
+            <a:noFill/>
+          </a:ln>
+        </p:spPr>
+        <p:txBody>
+          <a:bodyPr/>
+          <a:lstStyle/>
+          <a:p/>
+        </p:txBody>
+      </p:sp>
+      <p:sp>
+        <p:nvSpPr>
+          <p:cNvPr id="520" name="Seg520"/>
+          <p:cNvSpPr txBox="1"/>
+          <p:nvPr/>
+        </p:nvSpPr>
+        <p:spPr>
+          <a:xfrm>
+            <a:off x="548640" y="502920"/>
+            <a:ext cx="1828800" cy="310896"/>
+          </a:xfrm>
+          <a:prstGeom prst="rect">
+            <a:avLst/>
+          </a:prstGeom>
+          <a:noFill/>
+        </p:spPr>
+        <p:txBody>
+          <a:bodyPr anchor="ctr" lIns="0" tIns="0" rIns="0" bIns="0"/>
+          <a:lstStyle/>
+          <a:p>
+            <a:pPr algn="ctr"/>
+            <a:r>
+              <a:rPr lang="en-US" sz="1300" b="1" dirty="0">
+                <a:solidFill>
+                  <a:srgbClr val="1B2A52"/>
+                </a:solidFill>
+                <a:latin typeface="Calibri"/>
+              </a:rPr>
+              <a:t>VIDEO · PART 2</a:t>
+            </a:r>
+          </a:p>
+        </p:txBody>
+      </p:sp>
+      <p:sp>
+        <p:nvSpPr>
+          <p:cNvPr id="520" name="Seg520"/>
+          <p:cNvSpPr txBox="1"/>
+          <p:nvPr/>
+        </p:nvSpPr>
+        <p:spPr>
+          <a:xfrm>
+            <a:off x="2651760" y="384048"/>
+            <a:ext cx="8961120" cy="548640"/>
+          </a:xfrm>
+          <a:prstGeom prst="rect">
+            <a:avLst/>
+          </a:prstGeom>
+          <a:noFill/>
+        </p:spPr>
+        <p:txBody>
+          <a:bodyPr anchor="ctr" lIns="0" tIns="0" rIns="0" bIns="0"/>
+          <a:lstStyle/>
+          <a:p>
+            <a:pPr algn="l"/>
+            <a:r>
+              <a:rPr lang="en-US" sz="2400" b="1" dirty="0">
+                <a:solidFill>
+                  <a:srgbClr val="FFFFFF"/>
+                </a:solidFill>
+                <a:latin typeface="Calibri"/>
+              </a:rPr>
+              <a:t>7:23 → 10:00</a:t>
+            </a:r>
+          </a:p>
+        </p:txBody>
+      </p:sp>
+      <p:sp>
+        <p:nvSpPr>
+          <p:cNvPr id="624" name="SegBox624"/>
+          <p:cNvSpPr/>
+          <p:nvPr/>
+        </p:nvSpPr>
+        <p:spPr>
+          <a:xfrm>
+            <a:off x="822960" y="1234440"/>
+            <a:ext cx="10543032" cy="4663440"/>
+          </a:xfrm>
+          <a:prstGeom prst="roundRect">
+            <a:avLst/>
+          </a:prstGeom>
+          <a:solidFill>
+            <a:srgbClr val="24356B"/>
+          </a:solidFill>
+          <a:ln w="19050">
+            <a:solidFill>
+              <a:srgbClr val="31437A"/>
+            </a:solidFill>
+            <a:prstDash val="dash"/>
+          </a:ln>
+        </p:spPr>
+        <p:txBody>
+          <a:bodyPr/>
+          <a:lstStyle/>
+          <a:p/>
+        </p:txBody>
+      </p:sp>
+      <p:sp>
+        <p:nvSpPr>
+          <p:cNvPr id="520" name="Seg520"/>
+          <p:cNvSpPr txBox="1"/>
+          <p:nvPr/>
+        </p:nvSpPr>
+        <p:spPr>
+          <a:xfrm>
+            <a:off x="1463040" y="2377440"/>
+            <a:ext cx="9235440" cy="2377440"/>
+          </a:xfrm>
+          <a:prstGeom prst="rect">
+            <a:avLst/>
+          </a:prstGeom>
+          <a:noFill/>
+        </p:spPr>
+        <p:txBody>
+          <a:bodyPr anchor="t" lIns="0" tIns="0" rIns="0" bIns="0"/>
+          <a:lstStyle/>
+          <a:p>
+            <a:pPr algn="ctr"/>
+            <a:r>
+              <a:rPr lang="en-US" sz="1500" b="1" dirty="0">
+                <a:solidFill>
+                  <a:srgbClr val="FFFFFF"/>
+                </a:solidFill>
+                <a:latin typeface="Calibri"/>
+              </a:rPr>
+              <a:t>Insert the video here — Insert → Video → This Device</a:t>
+            </a:r>
+          </a:p>
+          <a:p>
+            <a:pPr algn="ctr"/>
+            <a:r>
+              <a:rPr lang="en-US" sz="800" dirty="0">
+                <a:solidFill>
+                  <a:srgbClr val="FFFFFF"/>
+                </a:solidFill>
+                <a:latin typeface="Calibri"/>
+              </a:rPr>
+              <a:t> </a:t>
+            </a:r>
+          </a:p>
+          <a:p>
+            <a:pPr algn="ctr"/>
+            <a:r>
+              <a:rPr lang="en-US" sz="1300" dirty="0">
+                <a:solidFill>
+                  <a:srgbClr val="C9D6EF"/>
+                </a:solidFill>
+                <a:latin typeface="Calibri"/>
+              </a:rPr>
+              <a:t>Then trim this copy: Playback → Trim Video → Start Time 7:23, End Time 10:00</a:t>
+            </a:r>
+          </a:p>
+          <a:p>
+            <a:pPr algn="ctr"/>
+            <a:r>
+              <a:rPr lang="en-US" sz="1300" dirty="0">
+                <a:solidFill>
+                  <a:srgbClr val="C9D6EF"/>
+                </a:solidFill>
+                <a:latin typeface="Calibri"/>
+              </a:rPr>
+              <a:t>Insert once, then copy–paste the same video onto the other PART slides</a:t>
+            </a:r>
+          </a:p>
+          <a:p>
+            <a:pPr algn="ctr"/>
+            <a:r>
+              <a:rPr lang="en-US" sz="1300" dirty="0">
+                <a:solidFill>
+                  <a:srgbClr val="C9D6EF"/>
+                </a:solidFill>
+                <a:latin typeface="Calibri"/>
+              </a:rPr>
+              <a:t>(it stays one embedded copy). Set Start: Automatically. Delete this text box.</a:t>
+            </a:r>
+          </a:p>
+        </p:txBody>
+      </p:sp>
+      <p:sp>
+        <p:nvSpPr>
+          <p:cNvPr id="520" name="Seg520"/>
+          <p:cNvSpPr txBox="1"/>
+          <p:nvPr/>
+        </p:nvSpPr>
+        <p:spPr>
+          <a:xfrm>
+            <a:off x="822960" y="6126480"/>
+            <a:ext cx="10543032" cy="457200"/>
+          </a:xfrm>
+          <a:prstGeom prst="rect">
+            <a:avLst/>
+          </a:prstGeom>
+          <a:noFill/>
+        </p:spPr>
+        <p:txBody>
+          <a:bodyPr anchor="ctr" lIns="0" tIns="0" rIns="0" bIns="0"/>
+          <a:lstStyle/>
+          <a:p>
+            <a:pPr algn="ctr"/>
+            <a:r>
+              <a:rPr lang="en-US" sz="1250" i="1" dirty="0">
+                <a:solidFill>
+                  <a:srgbClr val="C9D6EF"/>
+                </a:solidFill>
+                <a:latin typeface="Calibri"/>
+              </a:rPr>
+              <a:t>When it pauses: talk through how the Sundays are structured (next slides).</a:t>
+            </a:r>
+          </a:p>
+        </p:txBody>
+      </p:sp>
+    </p:spTree>
+  </p:cSld>
+  <p:clrMapOvr>
+    <a:masterClrMapping/>
+  </p:clrMapOvr>
+</p:sld>
+</file>
+
+<file path=ppt/slides/slide23.xml><?xml version="1.0" encoding="utf-8"?>
+<p:sld xmlns:a="http://schemas.openxmlformats.org/drawingml/2006/main" xmlns:r="http://schemas.openxmlformats.org/officeDocument/2006/relationships" xmlns:p="http://schemas.openxmlformats.org/presentationml/2006/main">
+  <p:cSld name="Slide 18">
+    <p:bg>
+      <p:bgPr>
+        <a:solidFill>
+          <a:srgbClr val="1B2A52"/>
+        </a:solidFill>
+      </p:bgPr>
+    </p:bg>
+    <p:spTree>
+      <p:nvGrpSpPr>
+        <p:cNvPr id="1" name=""/>
+        <p:cNvGrpSpPr/>
+        <p:nvPr/>
+      </p:nvGrpSpPr>
+      <p:grpSpPr>
+        <a:xfrm>
+          <a:off x="0" y="0"/>
+          <a:ext cx="0" cy="0"/>
+          <a:chOff x="0" y="0"/>
+          <a:chExt cx="0" cy="0"/>
+        </a:xfrm>
+      </p:grpSpPr>
+      <p:sp>
+        <p:nvSpPr>
+          <p:cNvPr id="635" name="SegBox635"/>
+          <p:cNvSpPr/>
+          <p:nvPr/>
+        </p:nvSpPr>
+        <p:spPr>
+          <a:xfrm>
+            <a:off x="548640" y="411480"/>
+            <a:ext cx="1828800" cy="457200"/>
+          </a:xfrm>
+          <a:prstGeom prst="roundRect">
+            <a:avLst/>
+          </a:prstGeom>
+          <a:solidFill>
+            <a:srgbClr val="C9A227"/>
+          </a:solidFill>
+          <a:ln>
+            <a:noFill/>
+          </a:ln>
+        </p:spPr>
+        <p:txBody>
+          <a:bodyPr/>
+          <a:lstStyle/>
+          <a:p/>
+        </p:txBody>
+      </p:sp>
+      <p:sp>
+        <p:nvSpPr>
+          <p:cNvPr id="530" name="Seg530"/>
+          <p:cNvSpPr txBox="1"/>
+          <p:nvPr/>
+        </p:nvSpPr>
+        <p:spPr>
+          <a:xfrm>
+            <a:off x="548640" y="502920"/>
+            <a:ext cx="1828800" cy="310896"/>
+          </a:xfrm>
+          <a:prstGeom prst="rect">
+            <a:avLst/>
+          </a:prstGeom>
+          <a:noFill/>
+        </p:spPr>
+        <p:txBody>
+          <a:bodyPr anchor="ctr" lIns="0" tIns="0" rIns="0" bIns="0"/>
+          <a:lstStyle/>
+          <a:p>
+            <a:pPr algn="ctr"/>
+            <a:r>
+              <a:rPr lang="en-US" sz="1300" b="1" dirty="0">
+                <a:solidFill>
+                  <a:srgbClr val="1B2A52"/>
+                </a:solidFill>
+                <a:latin typeface="Calibri"/>
+              </a:rPr>
+              <a:t>VIDEO · PART 3</a:t>
+            </a:r>
+          </a:p>
+        </p:txBody>
+      </p:sp>
+      <p:sp>
+        <p:nvSpPr>
+          <p:cNvPr id="530" name="Seg530"/>
+          <p:cNvSpPr txBox="1"/>
+          <p:nvPr/>
+        </p:nvSpPr>
+        <p:spPr>
+          <a:xfrm>
+            <a:off x="2651760" y="384048"/>
+            <a:ext cx="8961120" cy="548640"/>
+          </a:xfrm>
+          <a:prstGeom prst="rect">
+            <a:avLst/>
+          </a:prstGeom>
+          <a:noFill/>
+        </p:spPr>
+        <p:txBody>
+          <a:bodyPr anchor="ctr" lIns="0" tIns="0" rIns="0" bIns="0"/>
+          <a:lstStyle/>
+          <a:p>
+            <a:pPr algn="l"/>
+            <a:r>
+              <a:rPr lang="en-US" sz="2400" b="1" dirty="0">
+                <a:solidFill>
+                  <a:srgbClr val="FFFFFF"/>
+                </a:solidFill>
+                <a:latin typeface="Calibri"/>
+              </a:rPr>
+              <a:t>10:00 → 12:00</a:t>
+            </a:r>
+          </a:p>
+        </p:txBody>
+      </p:sp>
+      <p:sp>
+        <p:nvSpPr>
+          <p:cNvPr id="636" name="SegBox636"/>
+          <p:cNvSpPr/>
+          <p:nvPr/>
+        </p:nvSpPr>
+        <p:spPr>
+          <a:xfrm>
+            <a:off x="822960" y="1234440"/>
+            <a:ext cx="10543032" cy="4663440"/>
+          </a:xfrm>
+          <a:prstGeom prst="roundRect">
+            <a:avLst/>
+          </a:prstGeom>
+          <a:solidFill>
+            <a:srgbClr val="24356B"/>
+          </a:solidFill>
+          <a:ln w="19050">
+            <a:solidFill>
+              <a:srgbClr val="31437A"/>
+            </a:solidFill>
+            <a:prstDash val="dash"/>
+          </a:ln>
+        </p:spPr>
+        <p:txBody>
+          <a:bodyPr/>
+          <a:lstStyle/>
+          <a:p/>
+        </p:txBody>
+      </p:sp>
+      <p:sp>
+        <p:nvSpPr>
+          <p:cNvPr id="530" name="Seg530"/>
+          <p:cNvSpPr txBox="1"/>
+          <p:nvPr/>
+        </p:nvSpPr>
+        <p:spPr>
+          <a:xfrm>
+            <a:off x="1463040" y="2377440"/>
+            <a:ext cx="9235440" cy="2377440"/>
+          </a:xfrm>
+          <a:prstGeom prst="rect">
+            <a:avLst/>
+          </a:prstGeom>
+          <a:noFill/>
+        </p:spPr>
+        <p:txBody>
+          <a:bodyPr anchor="t" lIns="0" tIns="0" rIns="0" bIns="0"/>
+          <a:lstStyle/>
+          <a:p>
+            <a:pPr algn="ctr"/>
+            <a:r>
+              <a:rPr lang="en-US" sz="1500" b="1" dirty="0">
+                <a:solidFill>
+                  <a:srgbClr val="FFFFFF"/>
+                </a:solidFill>
+                <a:latin typeface="Calibri"/>
+              </a:rPr>
+              <a:t>Insert the video here — Insert → Video → This Device</a:t>
+            </a:r>
+          </a:p>
+          <a:p>
+            <a:pPr algn="ctr"/>
+            <a:r>
+              <a:rPr lang="en-US" sz="800" dirty="0">
+                <a:solidFill>
+                  <a:srgbClr val="FFFFFF"/>
+                </a:solidFill>
+                <a:latin typeface="Calibri"/>
+              </a:rPr>
+              <a:t> </a:t>
+            </a:r>
+          </a:p>
+          <a:p>
+            <a:pPr algn="ctr"/>
+            <a:r>
+              <a:rPr lang="en-US" sz="1300" dirty="0">
+                <a:solidFill>
+                  <a:srgbClr val="C9D6EF"/>
+                </a:solidFill>
+                <a:latin typeface="Calibri"/>
+              </a:rPr>
+              <a:t>Then trim this copy: Playback → Trim Video → Start Time 10:00, End Time 12:00</a:t>
+            </a:r>
+          </a:p>
+          <a:p>
+            <a:pPr algn="ctr"/>
+            <a:r>
+              <a:rPr lang="en-US" sz="1300" dirty="0">
+                <a:solidFill>
+                  <a:srgbClr val="C9D6EF"/>
+                </a:solidFill>
+                <a:latin typeface="Calibri"/>
+              </a:rPr>
+              <a:t>Insert once, then copy–paste the same video onto the other PART slides</a:t>
+            </a:r>
+          </a:p>
+          <a:p>
+            <a:pPr algn="ctr"/>
+            <a:r>
+              <a:rPr lang="en-US" sz="1300" dirty="0">
+                <a:solidFill>
+                  <a:srgbClr val="C9D6EF"/>
+                </a:solidFill>
+                <a:latin typeface="Calibri"/>
+              </a:rPr>
+              <a:t>(it stays one embedded copy). Set Start: Automatically. Delete this text box.</a:t>
+            </a:r>
+          </a:p>
+        </p:txBody>
+      </p:sp>
+      <p:sp>
+        <p:nvSpPr>
+          <p:cNvPr id="530" name="Seg530"/>
+          <p:cNvSpPr txBox="1"/>
+          <p:nvPr/>
+        </p:nvSpPr>
+        <p:spPr>
+          <a:xfrm>
+            <a:off x="822960" y="6126480"/>
+            <a:ext cx="10543032" cy="457200"/>
+          </a:xfrm>
+          <a:prstGeom prst="rect">
+            <a:avLst/>
+          </a:prstGeom>
+          <a:noFill/>
+        </p:spPr>
+        <p:txBody>
+          <a:bodyPr anchor="ctr" lIns="0" tIns="0" rIns="0" bIns="0"/>
+          <a:lstStyle/>
+          <a:p>
+            <a:pPr algn="ctr"/>
+            <a:r>
+              <a:rPr lang="en-US" sz="1250" i="1" dirty="0">
+                <a:solidFill>
+                  <a:srgbClr val="C9D6EF"/>
+                </a:solidFill>
+                <a:latin typeface="Calibri"/>
+              </a:rPr>
+              <a:t>When it pauses: look at the last-Sunday lessons (next slide).</a:t>
+            </a:r>
+          </a:p>
+        </p:txBody>
+      </p:sp>
+    </p:spTree>
+  </p:cSld>
+  <p:clrMapOvr>
+    <a:masterClrMapping/>
+  </p:clrMapOvr>
+</p:sld>
+</file>
+
+<file path=ppt/slides/slide24.xml><?xml version="1.0" encoding="utf-8"?>
+<p:sld xmlns:a="http://schemas.openxmlformats.org/drawingml/2006/main" xmlns:r="http://schemas.openxmlformats.org/officeDocument/2006/relationships" xmlns:p="http://schemas.openxmlformats.org/presentationml/2006/main">
+  <p:cSld name="Slide 18">
+    <p:bg>
+      <p:bgPr>
+        <a:solidFill>
+          <a:srgbClr val="1B2A52"/>
+        </a:solidFill>
+      </p:bgPr>
+    </p:bg>
+    <p:spTree>
+      <p:nvGrpSpPr>
+        <p:cNvPr id="1" name=""/>
+        <p:cNvGrpSpPr/>
+        <p:nvPr/>
+      </p:nvGrpSpPr>
+      <p:grpSpPr>
+        <a:xfrm>
+          <a:off x="0" y="0"/>
+          <a:ext cx="0" cy="0"/>
+          <a:chOff x="0" y="0"/>
+          <a:chExt cx="0" cy="0"/>
+        </a:xfrm>
+      </p:grpSpPr>
+      <p:sp>
+        <p:nvSpPr>
+          <p:cNvPr id="647" name="SegBox647"/>
+          <p:cNvSpPr/>
+          <p:nvPr/>
+        </p:nvSpPr>
+        <p:spPr>
+          <a:xfrm>
+            <a:off x="548640" y="411480"/>
+            <a:ext cx="1828800" cy="457200"/>
+          </a:xfrm>
+          <a:prstGeom prst="roundRect">
+            <a:avLst/>
+          </a:prstGeom>
+          <a:solidFill>
+            <a:srgbClr val="C9A227"/>
+          </a:solidFill>
+          <a:ln>
+            <a:noFill/>
+          </a:ln>
+        </p:spPr>
+        <p:txBody>
+          <a:bodyPr/>
+          <a:lstStyle/>
+          <a:p/>
+        </p:txBody>
+      </p:sp>
+      <p:sp>
+        <p:nvSpPr>
+          <p:cNvPr id="540" name="Seg540"/>
+          <p:cNvSpPr txBox="1"/>
+          <p:nvPr/>
+        </p:nvSpPr>
+        <p:spPr>
+          <a:xfrm>
+            <a:off x="548640" y="502920"/>
+            <a:ext cx="1828800" cy="310896"/>
+          </a:xfrm>
+          <a:prstGeom prst="rect">
+            <a:avLst/>
+          </a:prstGeom>
+          <a:noFill/>
+        </p:spPr>
+        <p:txBody>
+          <a:bodyPr anchor="ctr" lIns="0" tIns="0" rIns="0" bIns="0"/>
+          <a:lstStyle/>
+          <a:p>
+            <a:pPr algn="ctr"/>
+            <a:r>
+              <a:rPr lang="en-US" sz="1300" b="1" dirty="0">
+                <a:solidFill>
+                  <a:srgbClr val="1B2A52"/>
+                </a:solidFill>
+                <a:latin typeface="Calibri"/>
+              </a:rPr>
+              <a:t>VIDEO · PART 4</a:t>
+            </a:r>
+          </a:p>
+        </p:txBody>
+      </p:sp>
+      <p:sp>
+        <p:nvSpPr>
+          <p:cNvPr id="540" name="Seg540"/>
+          <p:cNvSpPr txBox="1"/>
+          <p:nvPr/>
+        </p:nvSpPr>
+        <p:spPr>
+          <a:xfrm>
+            <a:off x="2651760" y="384048"/>
+            <a:ext cx="8961120" cy="548640"/>
+          </a:xfrm>
+          <a:prstGeom prst="rect">
+            <a:avLst/>
+          </a:prstGeom>
+          <a:noFill/>
+        </p:spPr>
+        <p:txBody>
+          <a:bodyPr anchor="ctr" lIns="0" tIns="0" rIns="0" bIns="0"/>
+          <a:lstStyle/>
+          <a:p>
+            <a:pPr algn="l"/>
+            <a:r>
+              <a:rPr lang="en-US" sz="2400" b="1" dirty="0">
+                <a:solidFill>
+                  <a:srgbClr val="FFFFFF"/>
+                </a:solidFill>
+                <a:latin typeface="Calibri"/>
+              </a:rPr>
+              <a:t>12:00 → 18:30</a:t>
+            </a:r>
+          </a:p>
+        </p:txBody>
+      </p:sp>
+      <p:sp>
+        <p:nvSpPr>
+          <p:cNvPr id="648" name="SegBox648"/>
+          <p:cNvSpPr/>
+          <p:nvPr/>
+        </p:nvSpPr>
+        <p:spPr>
+          <a:xfrm>
+            <a:off x="822960" y="1234440"/>
+            <a:ext cx="10543032" cy="4663440"/>
+          </a:xfrm>
+          <a:prstGeom prst="roundRect">
+            <a:avLst/>
+          </a:prstGeom>
+          <a:solidFill>
+            <a:srgbClr val="24356B"/>
+          </a:solidFill>
+          <a:ln w="19050">
+            <a:solidFill>
+              <a:srgbClr val="31437A"/>
+            </a:solidFill>
+            <a:prstDash val="dash"/>
+          </a:ln>
+        </p:spPr>
+        <p:txBody>
+          <a:bodyPr/>
+          <a:lstStyle/>
+          <a:p/>
+        </p:txBody>
+      </p:sp>
+      <p:sp>
+        <p:nvSpPr>
+          <p:cNvPr id="540" name="Seg540"/>
+          <p:cNvSpPr txBox="1"/>
+          <p:nvPr/>
+        </p:nvSpPr>
+        <p:spPr>
+          <a:xfrm>
+            <a:off x="1463040" y="2377440"/>
+            <a:ext cx="9235440" cy="2377440"/>
+          </a:xfrm>
+          <a:prstGeom prst="rect">
+            <a:avLst/>
+          </a:prstGeom>
+          <a:noFill/>
+        </p:spPr>
+        <p:txBody>
+          <a:bodyPr anchor="t" lIns="0" tIns="0" rIns="0" bIns="0"/>
+          <a:lstStyle/>
+          <a:p>
+            <a:pPr algn="ctr"/>
+            <a:r>
+              <a:rPr lang="en-US" sz="1500" b="1" dirty="0">
+                <a:solidFill>
+                  <a:srgbClr val="FFFFFF"/>
+                </a:solidFill>
+                <a:latin typeface="Calibri"/>
+              </a:rPr>
+              <a:t>Insert the video here — Insert → Video → This Device</a:t>
+            </a:r>
+          </a:p>
+          <a:p>
+            <a:pPr algn="ctr"/>
+            <a:r>
+              <a:rPr lang="en-US" sz="800" dirty="0">
+                <a:solidFill>
+                  <a:srgbClr val="FFFFFF"/>
+                </a:solidFill>
+                <a:latin typeface="Calibri"/>
+              </a:rPr>
+              <a:t> </a:t>
+            </a:r>
+          </a:p>
+          <a:p>
+            <a:pPr algn="ctr"/>
+            <a:r>
+              <a:rPr lang="en-US" sz="1300" dirty="0">
+                <a:solidFill>
+                  <a:srgbClr val="C9D6EF"/>
+                </a:solidFill>
+                <a:latin typeface="Calibri"/>
+              </a:rPr>
+              <a:t>Then trim this copy: Playback → Trim Video → Start Time 12:00, End Time 18:30</a:t>
+            </a:r>
+          </a:p>
+          <a:p>
+            <a:pPr algn="ctr"/>
+            <a:r>
+              <a:rPr lang="en-US" sz="1300" dirty="0">
+                <a:solidFill>
+                  <a:srgbClr val="C9D6EF"/>
+                </a:solidFill>
+                <a:latin typeface="Calibri"/>
+              </a:rPr>
+              <a:t>Insert once, then copy–paste the same video onto the other PART slides</a:t>
+            </a:r>
+          </a:p>
+          <a:p>
+            <a:pPr algn="ctr"/>
+            <a:r>
+              <a:rPr lang="en-US" sz="1300" dirty="0">
+                <a:solidFill>
+                  <a:srgbClr val="C9D6EF"/>
+                </a:solidFill>
+                <a:latin typeface="Calibri"/>
+              </a:rPr>
+              <a:t>(it stays one embedded copy). Set Start: Automatically. Delete this text box.</a:t>
+            </a:r>
+          </a:p>
+        </p:txBody>
+      </p:sp>
+      <p:sp>
+        <p:nvSpPr>
+          <p:cNvPr id="540" name="Seg540"/>
+          <p:cNvSpPr txBox="1"/>
+          <p:nvPr/>
+        </p:nvSpPr>
+        <p:spPr>
+          <a:xfrm>
+            <a:off x="822960" y="6126480"/>
+            <a:ext cx="10543032" cy="457200"/>
+          </a:xfrm>
+          <a:prstGeom prst="rect">
+            <a:avLst/>
+          </a:prstGeom>
+          <a:noFill/>
+        </p:spPr>
+        <p:txBody>
+          <a:bodyPr anchor="ctr" lIns="0" tIns="0" rIns="0" bIns="0"/>
+          <a:lstStyle/>
+          <a:p>
+            <a:pPr algn="ctr"/>
+            <a:r>
+              <a:rPr lang="en-US" sz="1250" i="1" dirty="0">
+                <a:solidFill>
+                  <a:srgbClr val="C9D6EF"/>
+                </a:solidFill>
+                <a:latin typeface="Calibri"/>
+              </a:rPr>
+              <a:t>When it pauses: discuss, then walk through September and the magazine (next slides).</a:t>
+            </a:r>
+          </a:p>
+        </p:txBody>
+      </p:sp>
+    </p:spTree>
+  </p:cSld>
+  <p:clrMapOvr>
+    <a:masterClrMapping/>
+  </p:clrMapOvr>
+</p:sld>
+</file>
+
+<file path=ppt/slides/slide25.xml><?xml version="1.0" encoding="utf-8"?>
+<p:sld xmlns:a="http://schemas.openxmlformats.org/drawingml/2006/main" xmlns:r="http://schemas.openxmlformats.org/officeDocument/2006/relationships" xmlns:p="http://schemas.openxmlformats.org/presentationml/2006/main">
+  <p:cSld name="Slide 18">
+    <p:bg>
+      <p:bgPr>
+        <a:solidFill>
+          <a:srgbClr val="1B2A52"/>
+        </a:solidFill>
+      </p:bgPr>
+    </p:bg>
+    <p:spTree>
+      <p:nvGrpSpPr>
+        <p:cNvPr id="1" name=""/>
+        <p:cNvGrpSpPr/>
+        <p:nvPr/>
+      </p:nvGrpSpPr>
+      <p:grpSpPr>
+        <a:xfrm>
+          <a:off x="0" y="0"/>
+          <a:ext cx="0" cy="0"/>
+          <a:chOff x="0" y="0"/>
+          <a:chExt cx="0" cy="0"/>
+        </a:xfrm>
+      </p:grpSpPr>
+      <p:sp>
+        <p:nvSpPr>
+          <p:cNvPr id="659" name="SegBox659"/>
+          <p:cNvSpPr/>
+          <p:nvPr/>
+        </p:nvSpPr>
+        <p:spPr>
+          <a:xfrm>
+            <a:off x="548640" y="411480"/>
+            <a:ext cx="1828800" cy="457200"/>
+          </a:xfrm>
+          <a:prstGeom prst="roundRect">
+            <a:avLst/>
+          </a:prstGeom>
+          <a:solidFill>
+            <a:srgbClr val="C9A227"/>
+          </a:solidFill>
+          <a:ln>
+            <a:noFill/>
+          </a:ln>
+        </p:spPr>
+        <p:txBody>
+          <a:bodyPr/>
+          <a:lstStyle/>
+          <a:p/>
+        </p:txBody>
+      </p:sp>
+      <p:sp>
+        <p:nvSpPr>
+          <p:cNvPr id="550" name="Seg550"/>
+          <p:cNvSpPr txBox="1"/>
+          <p:nvPr/>
+        </p:nvSpPr>
+        <p:spPr>
+          <a:xfrm>
+            <a:off x="548640" y="502920"/>
+            <a:ext cx="1828800" cy="310896"/>
+          </a:xfrm>
+          <a:prstGeom prst="rect">
+            <a:avLst/>
+          </a:prstGeom>
+          <a:noFill/>
+        </p:spPr>
+        <p:txBody>
+          <a:bodyPr anchor="ctr" lIns="0" tIns="0" rIns="0" bIns="0"/>
+          <a:lstStyle/>
+          <a:p>
+            <a:pPr algn="ctr"/>
+            <a:r>
+              <a:rPr lang="en-US" sz="1300" b="1" dirty="0">
+                <a:solidFill>
+                  <a:srgbClr val="1B2A52"/>
+                </a:solidFill>
+                <a:latin typeface="Calibri"/>
+              </a:rPr>
+              <a:t>VIDEO · PART 5</a:t>
+            </a:r>
+          </a:p>
+        </p:txBody>
+      </p:sp>
+      <p:sp>
+        <p:nvSpPr>
+          <p:cNvPr id="550" name="Seg550"/>
+          <p:cNvSpPr txBox="1"/>
+          <p:nvPr/>
+        </p:nvSpPr>
+        <p:spPr>
+          <a:xfrm>
+            <a:off x="2651760" y="384048"/>
+            <a:ext cx="8961120" cy="548640"/>
+          </a:xfrm>
+          <a:prstGeom prst="rect">
+            <a:avLst/>
+          </a:prstGeom>
+          <a:noFill/>
+        </p:spPr>
+        <p:txBody>
+          <a:bodyPr anchor="ctr" lIns="0" tIns="0" rIns="0" bIns="0"/>
+          <a:lstStyle/>
+          <a:p>
+            <a:pPr algn="l"/>
+            <a:r>
+              <a:rPr lang="en-US" sz="2400" b="1" dirty="0">
+                <a:solidFill>
+                  <a:srgbClr val="FFFFFF"/>
+                </a:solidFill>
+                <a:latin typeface="Calibri"/>
+              </a:rPr>
+              <a:t>18:30 → End (≈22:00)</a:t>
+            </a:r>
+          </a:p>
+        </p:txBody>
+      </p:sp>
+      <p:sp>
+        <p:nvSpPr>
+          <p:cNvPr id="660" name="SegBox660"/>
+          <p:cNvSpPr/>
+          <p:nvPr/>
+        </p:nvSpPr>
+        <p:spPr>
+          <a:xfrm>
+            <a:off x="822960" y="1234440"/>
+            <a:ext cx="10543032" cy="4663440"/>
+          </a:xfrm>
+          <a:prstGeom prst="roundRect">
+            <a:avLst/>
+          </a:prstGeom>
+          <a:solidFill>
+            <a:srgbClr val="24356B"/>
+          </a:solidFill>
+          <a:ln w="19050">
+            <a:solidFill>
+              <a:srgbClr val="31437A"/>
+            </a:solidFill>
+            <a:prstDash val="dash"/>
+          </a:ln>
+        </p:spPr>
+        <p:txBody>
+          <a:bodyPr/>
+          <a:lstStyle/>
+          <a:p/>
+        </p:txBody>
+      </p:sp>
+      <p:sp>
+        <p:nvSpPr>
+          <p:cNvPr id="550" name="Seg550"/>
+          <p:cNvSpPr txBox="1"/>
+          <p:nvPr/>
+        </p:nvSpPr>
+        <p:spPr>
+          <a:xfrm>
+            <a:off x="1463040" y="2377440"/>
+            <a:ext cx="9235440" cy="2377440"/>
+          </a:xfrm>
+          <a:prstGeom prst="rect">
+            <a:avLst/>
+          </a:prstGeom>
+          <a:noFill/>
+        </p:spPr>
+        <p:txBody>
+          <a:bodyPr anchor="t" lIns="0" tIns="0" rIns="0" bIns="0"/>
+          <a:lstStyle/>
+          <a:p>
+            <a:pPr algn="ctr"/>
+            <a:r>
+              <a:rPr lang="en-US" sz="1500" b="1" dirty="0">
+                <a:solidFill>
+                  <a:srgbClr val="FFFFFF"/>
+                </a:solidFill>
+                <a:latin typeface="Calibri"/>
+              </a:rPr>
+              <a:t>Insert the video here — Insert → Video → This Device</a:t>
+            </a:r>
+          </a:p>
+          <a:p>
+            <a:pPr algn="ctr"/>
+            <a:r>
+              <a:rPr lang="en-US" sz="800" dirty="0">
+                <a:solidFill>
+                  <a:srgbClr val="FFFFFF"/>
+                </a:solidFill>
+                <a:latin typeface="Calibri"/>
+              </a:rPr>
+              <a:t> </a:t>
+            </a:r>
+          </a:p>
+          <a:p>
+            <a:pPr algn="ctr"/>
+            <a:r>
+              <a:rPr lang="en-US" sz="1300" dirty="0">
+                <a:solidFill>
+                  <a:srgbClr val="C9D6EF"/>
+                </a:solidFill>
+                <a:latin typeface="Calibri"/>
+              </a:rPr>
+              <a:t>Then trim this copy: Playback → Trim Video → Start Time 18:30 (play to the end)</a:t>
+            </a:r>
+          </a:p>
+          <a:p>
+            <a:pPr algn="ctr"/>
+            <a:r>
+              <a:rPr lang="en-US" sz="1300" dirty="0">
+                <a:solidFill>
+                  <a:srgbClr val="C9D6EF"/>
+                </a:solidFill>
+                <a:latin typeface="Calibri"/>
+              </a:rPr>
+              <a:t>Insert once, then copy–paste the same video onto the other PART slides</a:t>
+            </a:r>
+          </a:p>
+          <a:p>
+            <a:pPr algn="ctr"/>
+            <a:r>
+              <a:rPr lang="en-US" sz="1300" dirty="0">
+                <a:solidFill>
+                  <a:srgbClr val="C9D6EF"/>
+                </a:solidFill>
+                <a:latin typeface="Calibri"/>
+              </a:rPr>
+              <a:t>(it stays one embedded copy). Set Start: Automatically. Delete this text box.</a:t>
+            </a:r>
+          </a:p>
+        </p:txBody>
+      </p:sp>
+      <p:sp>
+        <p:nvSpPr>
+          <p:cNvPr id="550" name="Seg550"/>
+          <p:cNvSpPr txBox="1"/>
+          <p:nvPr/>
+        </p:nvSpPr>
+        <p:spPr>
+          <a:xfrm>
+            <a:off x="822960" y="6126480"/>
+            <a:ext cx="10543032" cy="457200"/>
+          </a:xfrm>
+          <a:prstGeom prst="rect">
+            <a:avLst/>
+          </a:prstGeom>
+          <a:noFill/>
+        </p:spPr>
+        <p:txBody>
+          <a:bodyPr anchor="ctr" lIns="0" tIns="0" rIns="0" bIns="0"/>
+          <a:lstStyle/>
+          <a:p>
+            <a:pPr algn="ctr"/>
+            <a:r>
+              <a:rPr lang="en-US" sz="1250" i="1" dirty="0">
+                <a:solidFill>
+                  <a:srgbClr val="C9D6EF"/>
+                </a:solidFill>
+                <a:latin typeface="Calibri"/>
+              </a:rPr>
+              <a:t>When it ends: ask — “What statements stood out to you?” Then the discussion questions.</a:t>
             </a:r>
           </a:p>
         </p:txBody>
@@ -11156,48 +10577,6 @@
           </a:p>
         </p:txBody>
       </p:sp>
-      <p:sp>
-        <p:nvSpPr>
-          <p:cNvPr id="951" name="NavButton951">
-            <a:hlinkClick r:id="rId7" action="ppaction://hlinksldjump"/>
-          </p:cNvPr>
-          <p:cNvSpPr/>
-          <p:nvPr/>
-        </p:nvSpPr>
-        <p:spPr>
-          <a:xfrm>
-            <a:off x="11137392" y="6419088"/>
-            <a:ext cx="914400" cy="329184"/>
-          </a:xfrm>
-          <a:prstGeom prst="roundRect">
-            <a:avLst>
-              <a:gd name="adj" fmla="val 50000"/>
-            </a:avLst>
-          </a:prstGeom>
-          <a:solidFill>
-            <a:srgbClr val="C9A227"/>
-          </a:solidFill>
-          <a:ln>
-            <a:noFill/>
-          </a:ln>
-        </p:spPr>
-        <p:txBody>
-          <a:bodyPr anchor="ctr" lIns="0" tIns="0" rIns="0" bIns="0"/>
-          <a:lstStyle/>
-          <a:p>
-            <a:pPr algn="ctr"/>
-            <a:r>
-              <a:rPr lang="en-US" sz="1000" b="1" dirty="0">
-                <a:solidFill>
-                  <a:srgbClr val="1B2A52"/>
-                </a:solidFill>
-                <a:latin typeface="Calibri"/>
-              </a:rPr>
-              <a:t>▶ Video</a:t>
-            </a:r>
-          </a:p>
-        </p:txBody>
-      </p:sp>
     </p:spTree>
   </p:cSld>
   <p:clrMapOvr>
@@ -12298,48 +11677,6 @@
           </a:p>
         </p:txBody>
       </p:sp>
-      <p:sp>
-        <p:nvSpPr>
-          <p:cNvPr id="951" name="NavButton951">
-            <a:hlinkClick r:id="rId5" action="ppaction://hlinksldjump"/>
-          </p:cNvPr>
-          <p:cNvSpPr/>
-          <p:nvPr/>
-        </p:nvSpPr>
-        <p:spPr>
-          <a:xfrm>
-            <a:off x="11137392" y="6419088"/>
-            <a:ext cx="914400" cy="329184"/>
-          </a:xfrm>
-          <a:prstGeom prst="roundRect">
-            <a:avLst>
-              <a:gd name="adj" fmla="val 50000"/>
-            </a:avLst>
-          </a:prstGeom>
-          <a:solidFill>
-            <a:srgbClr val="C9A227"/>
-          </a:solidFill>
-          <a:ln>
-            <a:noFill/>
-          </a:ln>
-        </p:spPr>
-        <p:txBody>
-          <a:bodyPr anchor="ctr" lIns="0" tIns="0" rIns="0" bIns="0"/>
-          <a:lstStyle/>
-          <a:p>
-            <a:pPr algn="ctr"/>
-            <a:r>
-              <a:rPr lang="en-US" sz="1000" b="1" dirty="0">
-                <a:solidFill>
-                  <a:srgbClr val="1B2A52"/>
-                </a:solidFill>
-                <a:latin typeface="Calibri"/>
-              </a:rPr>
-              <a:t>▶ Video</a:t>
-            </a:r>
-          </a:p>
-        </p:txBody>
-      </p:sp>
     </p:spTree>
   </p:cSld>
   <p:clrMapOvr>
@@ -13001,48 +12338,6 @@
           </a:p>
         </p:txBody>
       </p:sp>
-      <p:sp>
-        <p:nvSpPr>
-          <p:cNvPr id="951" name="NavButton951">
-            <a:hlinkClick r:id="rId7" action="ppaction://hlinksldjump"/>
-          </p:cNvPr>
-          <p:cNvSpPr/>
-          <p:nvPr/>
-        </p:nvSpPr>
-        <p:spPr>
-          <a:xfrm>
-            <a:off x="11137392" y="6419088"/>
-            <a:ext cx="914400" cy="329184"/>
-          </a:xfrm>
-          <a:prstGeom prst="roundRect">
-            <a:avLst>
-              <a:gd name="adj" fmla="val 50000"/>
-            </a:avLst>
-          </a:prstGeom>
-          <a:solidFill>
-            <a:srgbClr val="C9A227"/>
-          </a:solidFill>
-          <a:ln>
-            <a:noFill/>
-          </a:ln>
-        </p:spPr>
-        <p:txBody>
-          <a:bodyPr anchor="ctr" lIns="0" tIns="0" rIns="0" bIns="0"/>
-          <a:lstStyle/>
-          <a:p>
-            <a:pPr algn="ctr"/>
-            <a:r>
-              <a:rPr lang="en-US" sz="1000" b="1" dirty="0">
-                <a:solidFill>
-                  <a:srgbClr val="1B2A52"/>
-                </a:solidFill>
-                <a:latin typeface="Calibri"/>
-              </a:rPr>
-              <a:t>▶ Video</a:t>
-            </a:r>
-          </a:p>
-        </p:txBody>
-      </p:sp>
     </p:spTree>
   </p:cSld>
   <p:clrMapOvr>
@@ -13730,48 +13025,6 @@
           </a:p>
         </p:txBody>
       </p:sp>
-      <p:sp>
-        <p:nvSpPr>
-          <p:cNvPr id="951" name="NavButton951">
-            <a:hlinkClick r:id="rId3" action="ppaction://hlinksldjump"/>
-          </p:cNvPr>
-          <p:cNvSpPr/>
-          <p:nvPr/>
-        </p:nvSpPr>
-        <p:spPr>
-          <a:xfrm>
-            <a:off x="11137392" y="6419088"/>
-            <a:ext cx="914400" cy="329184"/>
-          </a:xfrm>
-          <a:prstGeom prst="roundRect">
-            <a:avLst>
-              <a:gd name="adj" fmla="val 50000"/>
-            </a:avLst>
-          </a:prstGeom>
-          <a:solidFill>
-            <a:srgbClr val="C9A227"/>
-          </a:solidFill>
-          <a:ln>
-            <a:noFill/>
-          </a:ln>
-        </p:spPr>
-        <p:txBody>
-          <a:bodyPr anchor="ctr" lIns="0" tIns="0" rIns="0" bIns="0"/>
-          <a:lstStyle/>
-          <a:p>
-            <a:pPr algn="ctr"/>
-            <a:r>
-              <a:rPr lang="en-US" sz="1000" b="1" dirty="0">
-                <a:solidFill>
-                  <a:srgbClr val="1B2A52"/>
-                </a:solidFill>
-                <a:latin typeface="Calibri"/>
-              </a:rPr>
-              <a:t>▶ Video</a:t>
-            </a:r>
-          </a:p>
-        </p:txBody>
-      </p:sp>
     </p:spTree>
   </p:cSld>
   <p:clrMapOvr>
@@ -14013,48 +13266,6 @@
           </a:p>
         </p:txBody>
       </p:sp>
-      <p:sp>
-        <p:nvSpPr>
-          <p:cNvPr id="951" name="NavButton951">
-            <a:hlinkClick r:id="rId5" action="ppaction://hlinksldjump"/>
-          </p:cNvPr>
-          <p:cNvSpPr/>
-          <p:nvPr/>
-        </p:nvSpPr>
-        <p:spPr>
-          <a:xfrm>
-            <a:off x="11137392" y="6419088"/>
-            <a:ext cx="914400" cy="329184"/>
-          </a:xfrm>
-          <a:prstGeom prst="roundRect">
-            <a:avLst>
-              <a:gd name="adj" fmla="val 50000"/>
-            </a:avLst>
-          </a:prstGeom>
-          <a:solidFill>
-            <a:srgbClr val="C9A227"/>
-          </a:solidFill>
-          <a:ln>
-            <a:noFill/>
-          </a:ln>
-        </p:spPr>
-        <p:txBody>
-          <a:bodyPr anchor="ctr" lIns="0" tIns="0" rIns="0" bIns="0"/>
-          <a:lstStyle/>
-          <a:p>
-            <a:pPr algn="ctr"/>
-            <a:r>
-              <a:rPr lang="en-US" sz="1000" b="1" dirty="0">
-                <a:solidFill>
-                  <a:srgbClr val="1B2A52"/>
-                </a:solidFill>
-                <a:latin typeface="Calibri"/>
-              </a:rPr>
-              <a:t>▶ Video</a:t>
-            </a:r>
-          </a:p>
-        </p:txBody>
-      </p:sp>
     </p:spTree>
   </p:cSld>
   <p:clrMapOvr>
@@ -14296,48 +13507,6 @@
           </a:p>
         </p:txBody>
       </p:sp>
-      <p:sp>
-        <p:nvSpPr>
-          <p:cNvPr id="951" name="NavButton951">
-            <a:hlinkClick r:id="rId5" action="ppaction://hlinksldjump"/>
-          </p:cNvPr>
-          <p:cNvSpPr/>
-          <p:nvPr/>
-        </p:nvSpPr>
-        <p:spPr>
-          <a:xfrm>
-            <a:off x="11137392" y="6419088"/>
-            <a:ext cx="914400" cy="329184"/>
-          </a:xfrm>
-          <a:prstGeom prst="roundRect">
-            <a:avLst>
-              <a:gd name="adj" fmla="val 50000"/>
-            </a:avLst>
-          </a:prstGeom>
-          <a:solidFill>
-            <a:srgbClr val="C9A227"/>
-          </a:solidFill>
-          <a:ln>
-            <a:noFill/>
-          </a:ln>
-        </p:spPr>
-        <p:txBody>
-          <a:bodyPr anchor="ctr" lIns="0" tIns="0" rIns="0" bIns="0"/>
-          <a:lstStyle/>
-          <a:p>
-            <a:pPr algn="ctr"/>
-            <a:r>
-              <a:rPr lang="en-US" sz="1000" b="1" dirty="0">
-                <a:solidFill>
-                  <a:srgbClr val="1B2A52"/>
-                </a:solidFill>
-                <a:latin typeface="Calibri"/>
-              </a:rPr>
-              <a:t>▶ Video</a:t>
-            </a:r>
-          </a:p>
-        </p:txBody>
-      </p:sp>
     </p:spTree>
   </p:cSld>
   <p:clrMapOvr>
@@ -15276,48 +14445,6 @@
               <a:t>youth Sunday School continues to study the scriptures with Come, Follow Me, and the FSY magazine adds monthly stories and articles on the same theme.</a:t>
             </a:r>
             <a:endParaRPr lang="en-US" sz="1300" dirty="0"/>
-          </a:p>
-        </p:txBody>
-      </p:sp>
-      <p:sp>
-        <p:nvSpPr>
-          <p:cNvPr id="951" name="NavButton951">
-            <a:hlinkClick r:id="rId8" action="ppaction://hlinksldjump"/>
-          </p:cNvPr>
-          <p:cNvSpPr/>
-          <p:nvPr/>
-        </p:nvSpPr>
-        <p:spPr>
-          <a:xfrm>
-            <a:off x="11137392" y="6419088"/>
-            <a:ext cx="914400" cy="329184"/>
-          </a:xfrm>
-          <a:prstGeom prst="roundRect">
-            <a:avLst>
-              <a:gd name="adj" fmla="val 50000"/>
-            </a:avLst>
-          </a:prstGeom>
-          <a:solidFill>
-            <a:srgbClr val="C9A227"/>
-          </a:solidFill>
-          <a:ln>
-            <a:noFill/>
-          </a:ln>
-        </p:spPr>
-        <p:txBody>
-          <a:bodyPr anchor="ctr" lIns="0" tIns="0" rIns="0" bIns="0"/>
-          <a:lstStyle/>
-          <a:p>
-            <a:pPr algn="ctr"/>
-            <a:r>
-              <a:rPr lang="en-US" sz="1000" b="1" dirty="0">
-                <a:solidFill>
-                  <a:srgbClr val="1B2A52"/>
-                </a:solidFill>
-                <a:latin typeface="Calibri"/>
-              </a:rPr>
-              <a:t>▶ Video</a:t>
-            </a:r>
           </a:p>
         </p:txBody>
       </p:sp>

</xml_diff>